<commit_message>
work on unit 2 visualization
</commit_message>
<xml_diff>
--- a/Unit 2 Visualization/Isabella_Westlauer_FLS_Unit2.pptx
+++ b/Unit 2 Visualization/Isabella_Westlauer_FLS_Unit2.pptx
@@ -7,26 +7,27 @@
   <p:sldIdLst>
     <p:sldId id="256" r:id="rId2"/>
     <p:sldId id="266" r:id="rId3"/>
-    <p:sldId id="267" r:id="rId4"/>
-    <p:sldId id="257" r:id="rId5"/>
-    <p:sldId id="268" r:id="rId6"/>
-    <p:sldId id="258" r:id="rId7"/>
-    <p:sldId id="269" r:id="rId8"/>
-    <p:sldId id="259" r:id="rId9"/>
-    <p:sldId id="270" r:id="rId10"/>
-    <p:sldId id="260" r:id="rId11"/>
-    <p:sldId id="271" r:id="rId12"/>
-    <p:sldId id="261" r:id="rId13"/>
-    <p:sldId id="272" r:id="rId14"/>
-    <p:sldId id="262" r:id="rId15"/>
-    <p:sldId id="273" r:id="rId16"/>
-    <p:sldId id="263" r:id="rId17"/>
-    <p:sldId id="274" r:id="rId18"/>
-    <p:sldId id="264" r:id="rId19"/>
-    <p:sldId id="275" r:id="rId20"/>
-    <p:sldId id="265" r:id="rId21"/>
-    <p:sldId id="276" r:id="rId22"/>
-    <p:sldId id="277" r:id="rId23"/>
+    <p:sldId id="257" r:id="rId4"/>
+    <p:sldId id="268" r:id="rId5"/>
+    <p:sldId id="258" r:id="rId6"/>
+    <p:sldId id="269" r:id="rId7"/>
+    <p:sldId id="259" r:id="rId8"/>
+    <p:sldId id="270" r:id="rId9"/>
+    <p:sldId id="278" r:id="rId10"/>
+    <p:sldId id="271" r:id="rId11"/>
+    <p:sldId id="260" r:id="rId12"/>
+    <p:sldId id="279" r:id="rId13"/>
+    <p:sldId id="261" r:id="rId14"/>
+    <p:sldId id="272" r:id="rId15"/>
+    <p:sldId id="262" r:id="rId16"/>
+    <p:sldId id="273" r:id="rId17"/>
+    <p:sldId id="263" r:id="rId18"/>
+    <p:sldId id="274" r:id="rId19"/>
+    <p:sldId id="264" r:id="rId20"/>
+    <p:sldId id="275" r:id="rId21"/>
+    <p:sldId id="265" r:id="rId22"/>
+    <p:sldId id="276" r:id="rId23"/>
+    <p:sldId id="277" r:id="rId24"/>
   </p:sldIdLst>
   <p:sldSz cx="12192000" cy="6858000"/>
   <p:notesSz cx="6858000" cy="9144000"/>
@@ -132,15 +133,16 @@
           <p14:sldIdLst>
             <p14:sldId id="256"/>
             <p14:sldId id="266"/>
-            <p14:sldId id="267"/>
             <p14:sldId id="257"/>
             <p14:sldId id="268"/>
             <p14:sldId id="258"/>
             <p14:sldId id="269"/>
             <p14:sldId id="259"/>
             <p14:sldId id="270"/>
+            <p14:sldId id="278"/>
+            <p14:sldId id="271"/>
             <p14:sldId id="260"/>
-            <p14:sldId id="271"/>
+            <p14:sldId id="279"/>
             <p14:sldId id="261"/>
             <p14:sldId id="272"/>
             <p14:sldId id="262"/>
@@ -310,7 +312,7 @@
           <a:p>
             <a:fld id="{A095E84C-799E-434B-B555-A2CE91254D07}" type="datetimeFigureOut">
               <a:rPr lang="en-US" smtClean="0"/>
-              <a:t>1/22/2026</a:t>
+              <a:t>1/25/2026</a:t>
             </a:fld>
             <a:endParaRPr lang="en-US"/>
           </a:p>
@@ -508,7 +510,7 @@
           <a:p>
             <a:fld id="{A095E84C-799E-434B-B555-A2CE91254D07}" type="datetimeFigureOut">
               <a:rPr lang="en-US" smtClean="0"/>
-              <a:t>1/22/2026</a:t>
+              <a:t>1/25/2026</a:t>
             </a:fld>
             <a:endParaRPr lang="en-US"/>
           </a:p>
@@ -716,7 +718,7 @@
           <a:p>
             <a:fld id="{A095E84C-799E-434B-B555-A2CE91254D07}" type="datetimeFigureOut">
               <a:rPr lang="en-US" smtClean="0"/>
-              <a:t>1/22/2026</a:t>
+              <a:t>1/25/2026</a:t>
             </a:fld>
             <a:endParaRPr lang="en-US"/>
           </a:p>
@@ -914,7 +916,7 @@
           <a:p>
             <a:fld id="{A095E84C-799E-434B-B555-A2CE91254D07}" type="datetimeFigureOut">
               <a:rPr lang="en-US" smtClean="0"/>
-              <a:t>1/22/2026</a:t>
+              <a:t>1/25/2026</a:t>
             </a:fld>
             <a:endParaRPr lang="en-US"/>
           </a:p>
@@ -1189,7 +1191,7 @@
           <a:p>
             <a:fld id="{A095E84C-799E-434B-B555-A2CE91254D07}" type="datetimeFigureOut">
               <a:rPr lang="en-US" smtClean="0"/>
-              <a:t>1/22/2026</a:t>
+              <a:t>1/25/2026</a:t>
             </a:fld>
             <a:endParaRPr lang="en-US"/>
           </a:p>
@@ -1454,7 +1456,7 @@
           <a:p>
             <a:fld id="{A095E84C-799E-434B-B555-A2CE91254D07}" type="datetimeFigureOut">
               <a:rPr lang="en-US" smtClean="0"/>
-              <a:t>1/22/2026</a:t>
+              <a:t>1/25/2026</a:t>
             </a:fld>
             <a:endParaRPr lang="en-US"/>
           </a:p>
@@ -1866,7 +1868,7 @@
           <a:p>
             <a:fld id="{A095E84C-799E-434B-B555-A2CE91254D07}" type="datetimeFigureOut">
               <a:rPr lang="en-US" smtClean="0"/>
-              <a:t>1/22/2026</a:t>
+              <a:t>1/25/2026</a:t>
             </a:fld>
             <a:endParaRPr lang="en-US"/>
           </a:p>
@@ -2007,7 +2009,7 @@
           <a:p>
             <a:fld id="{A095E84C-799E-434B-B555-A2CE91254D07}" type="datetimeFigureOut">
               <a:rPr lang="en-US" smtClean="0"/>
-              <a:t>1/22/2026</a:t>
+              <a:t>1/25/2026</a:t>
             </a:fld>
             <a:endParaRPr lang="en-US"/>
           </a:p>
@@ -2120,7 +2122,7 @@
           <a:p>
             <a:fld id="{A095E84C-799E-434B-B555-A2CE91254D07}" type="datetimeFigureOut">
               <a:rPr lang="en-US" smtClean="0"/>
-              <a:t>1/22/2026</a:t>
+              <a:t>1/25/2026</a:t>
             </a:fld>
             <a:endParaRPr lang="en-US"/>
           </a:p>
@@ -2431,7 +2433,7 @@
           <a:p>
             <a:fld id="{A095E84C-799E-434B-B555-A2CE91254D07}" type="datetimeFigureOut">
               <a:rPr lang="en-US" smtClean="0"/>
-              <a:t>1/22/2026</a:t>
+              <a:t>1/25/2026</a:t>
             </a:fld>
             <a:endParaRPr lang="en-US"/>
           </a:p>
@@ -2719,7 +2721,7 @@
           <a:p>
             <a:fld id="{A095E84C-799E-434B-B555-A2CE91254D07}" type="datetimeFigureOut">
               <a:rPr lang="en-US" smtClean="0"/>
-              <a:t>1/22/2026</a:t>
+              <a:t>1/25/2026</a:t>
             </a:fld>
             <a:endParaRPr lang="en-US"/>
           </a:p>
@@ -2960,7 +2962,7 @@
           <a:p>
             <a:fld id="{A095E84C-799E-434B-B555-A2CE91254D07}" type="datetimeFigureOut">
               <a:rPr lang="en-US" smtClean="0"/>
-              <a:t>1/22/2026</a:t>
+              <a:t>1/25/2026</a:t>
             </a:fld>
             <a:endParaRPr lang="en-US"/>
           </a:p>
@@ -3454,99 +3456,6 @@
   <p:cSld>
     <p:spTree>
       <p:nvGrpSpPr>
-        <p:cNvPr id="1" name=""/>
-        <p:cNvGrpSpPr/>
-        <p:nvPr/>
-      </p:nvGrpSpPr>
-      <p:grpSpPr>
-        <a:xfrm>
-          <a:off x="0" y="0"/>
-          <a:ext cx="0" cy="0"/>
-          <a:chOff x="0" y="0"/>
-          <a:chExt cx="0" cy="0"/>
-        </a:xfrm>
-      </p:grpSpPr>
-      <p:sp>
-        <p:nvSpPr>
-          <p:cNvPr id="2" name="Title 1">
-            <a:extLst>
-              <a:ext uri="{FF2B5EF4-FFF2-40B4-BE49-F238E27FC236}">
-                <a16:creationId xmlns:a16="http://schemas.microsoft.com/office/drawing/2014/main" id="{57A23C56-3CF7-E665-CC81-B5794343CF51}"/>
-              </a:ext>
-            </a:extLst>
-          </p:cNvPr>
-          <p:cNvSpPr>
-            <a:spLocks noGrp="1"/>
-          </p:cNvSpPr>
-          <p:nvPr>
-            <p:ph type="title"/>
-          </p:nvPr>
-        </p:nvSpPr>
-        <p:spPr/>
-        <p:txBody>
-          <a:bodyPr>
-            <a:normAutofit fontScale="90000"/>
-          </a:bodyPr>
-          <a:lstStyle/>
-          <a:p>
-            <a:r>
-              <a:rPr lang="en-US" dirty="0"/>
-              <a:t>Use the dataset to visually investigate if the distribution of height is different between </a:t>
-            </a:r>
-            <a:r>
-              <a:rPr lang="en-US" i="1" dirty="0"/>
-              <a:t>any </a:t>
-            </a:r>
-            <a:r>
-              <a:rPr lang="en-US" dirty="0"/>
-              <a:t>of the positions.</a:t>
-            </a:r>
-          </a:p>
-        </p:txBody>
-      </p:sp>
-      <p:sp>
-        <p:nvSpPr>
-          <p:cNvPr id="3" name="Text Placeholder 2">
-            <a:extLst>
-              <a:ext uri="{FF2B5EF4-FFF2-40B4-BE49-F238E27FC236}">
-                <a16:creationId xmlns:a16="http://schemas.microsoft.com/office/drawing/2014/main" id="{5BBC405A-8591-BA6F-4666-2EE0CFACEE40}"/>
-              </a:ext>
-            </a:extLst>
-          </p:cNvPr>
-          <p:cNvSpPr>
-            <a:spLocks noGrp="1"/>
-          </p:cNvSpPr>
-          <p:nvPr>
-            <p:ph type="body" idx="1"/>
-          </p:nvPr>
-        </p:nvSpPr>
-        <p:spPr/>
-        <p:txBody>
-          <a:bodyPr/>
-          <a:lstStyle/>
-          <a:p>
-            <a:endParaRPr lang="en-US"/>
-          </a:p>
-        </p:txBody>
-      </p:sp>
-    </p:spTree>
-    <p:extLst>
-      <p:ext uri="{BB962C8B-B14F-4D97-AF65-F5344CB8AC3E}">
-        <p14:creationId xmlns:p14="http://schemas.microsoft.com/office/powerpoint/2010/main" val="1459221153"/>
-      </p:ext>
-    </p:extLst>
-  </p:cSld>
-  <p:clrMapOvr>
-    <a:masterClrMapping/>
-  </p:clrMapOvr>
-</p:sld>
-</file>
-
-<file path=ppt/slides/slide11.xml><?xml version="1.0" encoding="utf-8"?>
-<p:sld xmlns:a="http://schemas.openxmlformats.org/drawingml/2006/main" xmlns:r="http://schemas.openxmlformats.org/officeDocument/2006/relationships" xmlns:p="http://schemas.openxmlformats.org/presentationml/2006/main">
-  <p:cSld>
-    <p:spTree>
-      <p:nvGrpSpPr>
         <p:cNvPr id="1" name="">
           <a:extLst>
             <a:ext uri="{FF2B5EF4-FFF2-40B4-BE49-F238E27FC236}">
@@ -3565,35 +3474,138 @@
           <a:chExt cx="0" cy="0"/>
         </a:xfrm>
       </p:grpSpPr>
-      <p:sp>
-        <p:nvSpPr>
-          <p:cNvPr id="4" name="Title 3">
-            <a:extLst>
-              <a:ext uri="{FF2B5EF4-FFF2-40B4-BE49-F238E27FC236}">
-                <a16:creationId xmlns:a16="http://schemas.microsoft.com/office/drawing/2014/main" id="{3C0DAA5B-9C41-B29C-0CA0-D76246A3592F}"/>
-              </a:ext>
-            </a:extLst>
-          </p:cNvPr>
-          <p:cNvSpPr>
-            <a:spLocks noGrp="1"/>
-          </p:cNvSpPr>
-          <p:nvPr>
-            <p:ph type="title"/>
-          </p:nvPr>
-        </p:nvSpPr>
-        <p:spPr/>
-        <p:txBody>
-          <a:bodyPr/>
-          <a:lstStyle/>
-          <a:p>
-            <a:endParaRPr lang="en-US"/>
-          </a:p>
-        </p:txBody>
-      </p:sp>
+      <p:pic>
+        <p:nvPicPr>
+          <p:cNvPr id="5" name="Picture 4">
+            <a:extLst>
+              <a:ext uri="{FF2B5EF4-FFF2-40B4-BE49-F238E27FC236}">
+                <a16:creationId xmlns:a16="http://schemas.microsoft.com/office/drawing/2014/main" id="{EC8D9154-0048-B4F9-16A6-3E5CA8BD09E4}"/>
+              </a:ext>
+            </a:extLst>
+          </p:cNvPr>
+          <p:cNvPicPr>
+            <a:picLocks noChangeAspect="1"/>
+          </p:cNvPicPr>
+          <p:nvPr/>
+        </p:nvPicPr>
+        <p:blipFill>
+          <a:blip r:embed="rId2"/>
+          <a:stretch>
+            <a:fillRect/>
+          </a:stretch>
+        </p:blipFill>
+        <p:spPr>
+          <a:xfrm>
+            <a:off x="88703" y="1428471"/>
+            <a:ext cx="4582164" cy="4001058"/>
+          </a:xfrm>
+          <a:prstGeom prst="rect">
+            <a:avLst/>
+          </a:prstGeom>
+        </p:spPr>
+      </p:pic>
+      <p:pic>
+        <p:nvPicPr>
+          <p:cNvPr id="7" name="Picture 6">
+            <a:extLst>
+              <a:ext uri="{FF2B5EF4-FFF2-40B4-BE49-F238E27FC236}">
+                <a16:creationId xmlns:a16="http://schemas.microsoft.com/office/drawing/2014/main" id="{1C488AEE-1B15-C584-A5C9-FFAE2B5C4F44}"/>
+              </a:ext>
+            </a:extLst>
+          </p:cNvPr>
+          <p:cNvPicPr>
+            <a:picLocks noChangeAspect="1"/>
+          </p:cNvPicPr>
+          <p:nvPr/>
+        </p:nvPicPr>
+        <p:blipFill>
+          <a:blip r:embed="rId3"/>
+          <a:stretch>
+            <a:fillRect/>
+          </a:stretch>
+        </p:blipFill>
+        <p:spPr>
+          <a:xfrm>
+            <a:off x="5458483" y="1147444"/>
+            <a:ext cx="6315956" cy="4563112"/>
+          </a:xfrm>
+          <a:prstGeom prst="rect">
+            <a:avLst/>
+          </a:prstGeom>
+        </p:spPr>
+      </p:pic>
     </p:spTree>
     <p:extLst>
       <p:ext uri="{BB962C8B-B14F-4D97-AF65-F5344CB8AC3E}">
         <p14:creationId xmlns:p14="http://schemas.microsoft.com/office/powerpoint/2010/main" val="2016946357"/>
+      </p:ext>
+    </p:extLst>
+  </p:cSld>
+  <p:clrMapOvr>
+    <a:masterClrMapping/>
+  </p:clrMapOvr>
+</p:sld>
+</file>
+
+<file path=ppt/slides/slide11.xml><?xml version="1.0" encoding="utf-8"?>
+<p:sld xmlns:a="http://schemas.openxmlformats.org/drawingml/2006/main" xmlns:r="http://schemas.openxmlformats.org/officeDocument/2006/relationships" xmlns:p="http://schemas.openxmlformats.org/presentationml/2006/main">
+  <p:cSld>
+    <p:spTree>
+      <p:nvGrpSpPr>
+        <p:cNvPr id="1" name=""/>
+        <p:cNvGrpSpPr/>
+        <p:nvPr/>
+      </p:nvGrpSpPr>
+      <p:grpSpPr>
+        <a:xfrm>
+          <a:off x="0" y="0"/>
+          <a:ext cx="0" cy="0"/>
+          <a:chOff x="0" y="0"/>
+          <a:chExt cx="0" cy="0"/>
+        </a:xfrm>
+      </p:grpSpPr>
+      <p:sp>
+        <p:nvSpPr>
+          <p:cNvPr id="2" name="Title 1">
+            <a:extLst>
+              <a:ext uri="{FF2B5EF4-FFF2-40B4-BE49-F238E27FC236}">
+                <a16:creationId xmlns:a16="http://schemas.microsoft.com/office/drawing/2014/main" id="{57A23C56-3CF7-E665-CC81-B5794343CF51}"/>
+              </a:ext>
+            </a:extLst>
+          </p:cNvPr>
+          <p:cNvSpPr>
+            <a:spLocks noGrp="1"/>
+          </p:cNvSpPr>
+          <p:nvPr>
+            <p:ph type="title"/>
+          </p:nvPr>
+        </p:nvSpPr>
+        <p:spPr/>
+        <p:txBody>
+          <a:bodyPr>
+            <a:normAutofit fontScale="90000"/>
+          </a:bodyPr>
+          <a:lstStyle/>
+          <a:p>
+            <a:r>
+              <a:rPr lang="en-US" dirty="0"/>
+              <a:t>Use the dataset to visually investigate if the distribution of height is different between </a:t>
+            </a:r>
+            <a:r>
+              <a:rPr lang="en-US" i="1" dirty="0"/>
+              <a:t>any </a:t>
+            </a:r>
+            <a:r>
+              <a:rPr lang="en-US" dirty="0"/>
+              <a:t>of the positions.</a:t>
+            </a:r>
+          </a:p>
+        </p:txBody>
+      </p:sp>
+    </p:spTree>
+    <p:extLst>
+      <p:ext uri="{BB962C8B-B14F-4D97-AF65-F5344CB8AC3E}">
+        <p14:creationId xmlns:p14="http://schemas.microsoft.com/office/powerpoint/2010/main" val="1459221153"/>
       </p:ext>
     </p:extLst>
   </p:cSld>
@@ -3620,65 +3632,40 @@
           <a:chExt cx="0" cy="0"/>
         </a:xfrm>
       </p:grpSpPr>
-      <p:sp>
-        <p:nvSpPr>
-          <p:cNvPr id="2" name="Title 1">
-            <a:extLst>
-              <a:ext uri="{FF2B5EF4-FFF2-40B4-BE49-F238E27FC236}">
-                <a16:creationId xmlns:a16="http://schemas.microsoft.com/office/drawing/2014/main" id="{C4569DDD-0071-EC55-D735-1835EE6237E2}"/>
-              </a:ext>
-            </a:extLst>
-          </p:cNvPr>
-          <p:cNvSpPr>
-            <a:spLocks noGrp="1"/>
-          </p:cNvSpPr>
-          <p:nvPr>
-            <p:ph type="title"/>
-          </p:nvPr>
-        </p:nvSpPr>
-        <p:spPr/>
-        <p:txBody>
-          <a:bodyPr>
-            <a:normAutofit fontScale="90000"/>
-          </a:bodyPr>
-          <a:lstStyle/>
-          <a:p>
-            <a:r>
-              <a:rPr lang="en-US" dirty="0"/>
-              <a:t>Use the dataset to investigate how the player’s height is related to the player’s weight. How does height change as the weight changes?</a:t>
-            </a:r>
-          </a:p>
-        </p:txBody>
-      </p:sp>
-      <p:sp>
-        <p:nvSpPr>
-          <p:cNvPr id="3" name="Text Placeholder 2">
-            <a:extLst>
-              <a:ext uri="{FF2B5EF4-FFF2-40B4-BE49-F238E27FC236}">
-                <a16:creationId xmlns:a16="http://schemas.microsoft.com/office/drawing/2014/main" id="{B03818DC-0495-CA51-F42A-D4E1EA6A1C1E}"/>
-              </a:ext>
-            </a:extLst>
-          </p:cNvPr>
-          <p:cNvSpPr>
-            <a:spLocks noGrp="1"/>
-          </p:cNvSpPr>
-          <p:nvPr>
-            <p:ph type="body" idx="1"/>
-          </p:nvPr>
-        </p:nvSpPr>
-        <p:spPr/>
-        <p:txBody>
-          <a:bodyPr/>
-          <a:lstStyle/>
-          <a:p>
-            <a:endParaRPr lang="en-US"/>
-          </a:p>
-        </p:txBody>
-      </p:sp>
+      <p:pic>
+        <p:nvPicPr>
+          <p:cNvPr id="5" name="Picture 4">
+            <a:extLst>
+              <a:ext uri="{FF2B5EF4-FFF2-40B4-BE49-F238E27FC236}">
+                <a16:creationId xmlns:a16="http://schemas.microsoft.com/office/drawing/2014/main" id="{883C941B-F477-BF77-9BAF-9A6F0B361966}"/>
+              </a:ext>
+            </a:extLst>
+          </p:cNvPr>
+          <p:cNvPicPr>
+            <a:picLocks noChangeAspect="1"/>
+          </p:cNvPicPr>
+          <p:nvPr/>
+        </p:nvPicPr>
+        <p:blipFill>
+          <a:blip r:embed="rId2"/>
+          <a:stretch>
+            <a:fillRect/>
+          </a:stretch>
+        </p:blipFill>
+        <p:spPr>
+          <a:xfrm>
+            <a:off x="2790363" y="185285"/>
+            <a:ext cx="6611273" cy="6487430"/>
+          </a:xfrm>
+          <a:prstGeom prst="rect">
+            <a:avLst/>
+          </a:prstGeom>
+        </p:spPr>
+      </p:pic>
     </p:spTree>
     <p:extLst>
       <p:ext uri="{BB962C8B-B14F-4D97-AF65-F5344CB8AC3E}">
-        <p14:creationId xmlns:p14="http://schemas.microsoft.com/office/powerpoint/2010/main" val="2280422974"/>
+        <p14:creationId xmlns:p14="http://schemas.microsoft.com/office/powerpoint/2010/main" val="3553000149"/>
       </p:ext>
     </p:extLst>
   </p:cSld>
@@ -3710,7 +3697,7 @@
           <p:cNvPr id="2" name="Title 1">
             <a:extLst>
               <a:ext uri="{FF2B5EF4-FFF2-40B4-BE49-F238E27FC236}">
-                <a16:creationId xmlns:a16="http://schemas.microsoft.com/office/drawing/2014/main" id="{42646971-32A9-5296-F995-462837C06267}"/>
+                <a16:creationId xmlns:a16="http://schemas.microsoft.com/office/drawing/2014/main" id="{C4569DDD-0071-EC55-D735-1835EE6237E2}"/>
               </a:ext>
             </a:extLst>
           </p:cNvPr>
@@ -3723,17 +3710,22 @@
         </p:nvSpPr>
         <p:spPr/>
         <p:txBody>
-          <a:bodyPr/>
-          <a:lstStyle/>
-          <a:p>
-            <a:endParaRPr lang="en-US"/>
+          <a:bodyPr>
+            <a:normAutofit fontScale="90000"/>
+          </a:bodyPr>
+          <a:lstStyle/>
+          <a:p>
+            <a:r>
+              <a:rPr lang="en-US" dirty="0"/>
+              <a:t>Use the dataset to investigate how the player’s height is related to the player’s weight. How does height change as the weight changes?</a:t>
+            </a:r>
           </a:p>
         </p:txBody>
       </p:sp>
     </p:spTree>
     <p:extLst>
       <p:ext uri="{BB962C8B-B14F-4D97-AF65-F5344CB8AC3E}">
-        <p14:creationId xmlns:p14="http://schemas.microsoft.com/office/powerpoint/2010/main" val="89551103"/>
+        <p14:creationId xmlns:p14="http://schemas.microsoft.com/office/powerpoint/2010/main" val="2280422974"/>
       </p:ext>
     </p:extLst>
   </p:cSld>
@@ -3760,65 +3752,40 @@
           <a:chExt cx="0" cy="0"/>
         </a:xfrm>
       </p:grpSpPr>
-      <p:sp>
-        <p:nvSpPr>
-          <p:cNvPr id="2" name="Title 1">
-            <a:extLst>
-              <a:ext uri="{FF2B5EF4-FFF2-40B4-BE49-F238E27FC236}">
-                <a16:creationId xmlns:a16="http://schemas.microsoft.com/office/drawing/2014/main" id="{223B0F22-36F3-C0C6-0960-FE53686440DD}"/>
-              </a:ext>
-            </a:extLst>
-          </p:cNvPr>
-          <p:cNvSpPr>
-            <a:spLocks noGrp="1"/>
-          </p:cNvSpPr>
-          <p:nvPr>
-            <p:ph type="title"/>
-          </p:nvPr>
-        </p:nvSpPr>
-        <p:spPr/>
-        <p:txBody>
-          <a:bodyPr>
-            <a:normAutofit fontScale="90000"/>
-          </a:bodyPr>
-          <a:lstStyle/>
-          <a:p>
-            <a:r>
-              <a:rPr lang="en-US" dirty="0"/>
-              <a:t>Is their any difference in the relationship between height and weight between positions?  Are height and weight related differently for different positions.</a:t>
-            </a:r>
-          </a:p>
-        </p:txBody>
-      </p:sp>
-      <p:sp>
-        <p:nvSpPr>
-          <p:cNvPr id="3" name="Text Placeholder 2">
-            <a:extLst>
-              <a:ext uri="{FF2B5EF4-FFF2-40B4-BE49-F238E27FC236}">
-                <a16:creationId xmlns:a16="http://schemas.microsoft.com/office/drawing/2014/main" id="{28AF8037-5A81-F986-1B8A-7BB0003ECDCA}"/>
-              </a:ext>
-            </a:extLst>
-          </p:cNvPr>
-          <p:cNvSpPr>
-            <a:spLocks noGrp="1"/>
-          </p:cNvSpPr>
-          <p:nvPr>
-            <p:ph type="body" idx="1"/>
-          </p:nvPr>
-        </p:nvSpPr>
-        <p:spPr/>
-        <p:txBody>
-          <a:bodyPr/>
-          <a:lstStyle/>
-          <a:p>
-            <a:endParaRPr lang="en-US"/>
-          </a:p>
-        </p:txBody>
-      </p:sp>
+      <p:pic>
+        <p:nvPicPr>
+          <p:cNvPr id="4" name="Picture 3">
+            <a:extLst>
+              <a:ext uri="{FF2B5EF4-FFF2-40B4-BE49-F238E27FC236}">
+                <a16:creationId xmlns:a16="http://schemas.microsoft.com/office/drawing/2014/main" id="{5B7F0E65-FA81-13AC-1881-59C65DF2CACF}"/>
+              </a:ext>
+            </a:extLst>
+          </p:cNvPr>
+          <p:cNvPicPr>
+            <a:picLocks noChangeAspect="1"/>
+          </p:cNvPicPr>
+          <p:nvPr/>
+        </p:nvPicPr>
+        <p:blipFill>
+          <a:blip r:embed="rId2"/>
+          <a:stretch>
+            <a:fillRect/>
+          </a:stretch>
+        </p:blipFill>
+        <p:spPr>
+          <a:xfrm>
+            <a:off x="2230244" y="0"/>
+            <a:ext cx="7731512" cy="6858000"/>
+          </a:xfrm>
+          <a:prstGeom prst="rect">
+            <a:avLst/>
+          </a:prstGeom>
+        </p:spPr>
+      </p:pic>
     </p:spTree>
     <p:extLst>
       <p:ext uri="{BB962C8B-B14F-4D97-AF65-F5344CB8AC3E}">
-        <p14:creationId xmlns:p14="http://schemas.microsoft.com/office/powerpoint/2010/main" val="2004947187"/>
+        <p14:creationId xmlns:p14="http://schemas.microsoft.com/office/powerpoint/2010/main" val="89551103"/>
       </p:ext>
     </p:extLst>
   </p:cSld>
@@ -3850,7 +3817,7 @@
           <p:cNvPr id="2" name="Title 1">
             <a:extLst>
               <a:ext uri="{FF2B5EF4-FFF2-40B4-BE49-F238E27FC236}">
-                <a16:creationId xmlns:a16="http://schemas.microsoft.com/office/drawing/2014/main" id="{B06CD728-7598-5DAD-26DB-B368BB2539BB}"/>
+                <a16:creationId xmlns:a16="http://schemas.microsoft.com/office/drawing/2014/main" id="{223B0F22-36F3-C0C6-0960-FE53686440DD}"/>
               </a:ext>
             </a:extLst>
           </p:cNvPr>
@@ -3863,17 +3830,22 @@
         </p:nvSpPr>
         <p:spPr/>
         <p:txBody>
-          <a:bodyPr/>
-          <a:lstStyle/>
-          <a:p>
-            <a:endParaRPr lang="en-US"/>
+          <a:bodyPr>
+            <a:normAutofit fontScale="90000"/>
+          </a:bodyPr>
+          <a:lstStyle/>
+          <a:p>
+            <a:r>
+              <a:rPr lang="en-US" dirty="0"/>
+              <a:t>Is their any difference in the relationship between height and weight between positions?  Are height and weight related differently for different positions.</a:t>
+            </a:r>
           </a:p>
         </p:txBody>
       </p:sp>
     </p:spTree>
     <p:extLst>
       <p:ext uri="{BB962C8B-B14F-4D97-AF65-F5344CB8AC3E}">
-        <p14:creationId xmlns:p14="http://schemas.microsoft.com/office/powerpoint/2010/main" val="2162116713"/>
+        <p14:creationId xmlns:p14="http://schemas.microsoft.com/office/powerpoint/2010/main" val="2004947187"/>
       </p:ext>
     </p:extLst>
   </p:cSld>
@@ -3900,65 +3872,70 @@
           <a:chExt cx="0" cy="0"/>
         </a:xfrm>
       </p:grpSpPr>
-      <p:sp>
-        <p:nvSpPr>
-          <p:cNvPr id="2" name="Title 1">
-            <a:extLst>
-              <a:ext uri="{FF2B5EF4-FFF2-40B4-BE49-F238E27FC236}">
-                <a16:creationId xmlns:a16="http://schemas.microsoft.com/office/drawing/2014/main" id="{A2946D8E-31E3-BCF6-1B70-0C34F68C8399}"/>
-              </a:ext>
-            </a:extLst>
-          </p:cNvPr>
-          <p:cNvSpPr>
-            <a:spLocks noGrp="1"/>
-          </p:cNvSpPr>
-          <p:nvPr>
-            <p:ph type="title"/>
-          </p:nvPr>
-        </p:nvSpPr>
-        <p:spPr/>
-        <p:txBody>
-          <a:bodyPr>
-            <a:normAutofit fontScale="90000"/>
-          </a:bodyPr>
-          <a:lstStyle/>
-          <a:p>
-            <a:r>
-              <a:rPr lang="en-US" dirty="0"/>
-              <a:t>A historian would like to investigate the claim that the heights of players have increased over the years.  Analyze this claim graphically / visually.</a:t>
-            </a:r>
-          </a:p>
-        </p:txBody>
-      </p:sp>
-      <p:sp>
-        <p:nvSpPr>
-          <p:cNvPr id="3" name="Text Placeholder 2">
-            <a:extLst>
-              <a:ext uri="{FF2B5EF4-FFF2-40B4-BE49-F238E27FC236}">
-                <a16:creationId xmlns:a16="http://schemas.microsoft.com/office/drawing/2014/main" id="{2743FCB1-1894-A2C4-C7CC-6C620E5C2A02}"/>
-              </a:ext>
-            </a:extLst>
-          </p:cNvPr>
-          <p:cNvSpPr>
-            <a:spLocks noGrp="1"/>
-          </p:cNvSpPr>
-          <p:nvPr>
-            <p:ph type="body" idx="1"/>
-          </p:nvPr>
-        </p:nvSpPr>
-        <p:spPr/>
-        <p:txBody>
-          <a:bodyPr/>
-          <a:lstStyle/>
-          <a:p>
-            <a:endParaRPr lang="en-US"/>
-          </a:p>
-        </p:txBody>
-      </p:sp>
+      <p:pic>
+        <p:nvPicPr>
+          <p:cNvPr id="4" name="Picture 3">
+            <a:extLst>
+              <a:ext uri="{FF2B5EF4-FFF2-40B4-BE49-F238E27FC236}">
+                <a16:creationId xmlns:a16="http://schemas.microsoft.com/office/drawing/2014/main" id="{5392273D-FD59-CD29-858C-E8EF9E0F796C}"/>
+              </a:ext>
+            </a:extLst>
+          </p:cNvPr>
+          <p:cNvPicPr>
+            <a:picLocks noChangeAspect="1"/>
+          </p:cNvPicPr>
+          <p:nvPr/>
+        </p:nvPicPr>
+        <p:blipFill>
+          <a:blip r:embed="rId2"/>
+          <a:stretch>
+            <a:fillRect/>
+          </a:stretch>
+        </p:blipFill>
+        <p:spPr>
+          <a:xfrm>
+            <a:off x="3280969" y="113829"/>
+            <a:ext cx="5630061" cy="1495634"/>
+          </a:xfrm>
+          <a:prstGeom prst="rect">
+            <a:avLst/>
+          </a:prstGeom>
+        </p:spPr>
+      </p:pic>
+      <p:pic>
+        <p:nvPicPr>
+          <p:cNvPr id="6" name="Picture 5">
+            <a:extLst>
+              <a:ext uri="{FF2B5EF4-FFF2-40B4-BE49-F238E27FC236}">
+                <a16:creationId xmlns:a16="http://schemas.microsoft.com/office/drawing/2014/main" id="{CE8F9093-49AF-39F8-8277-C829D4761C4B}"/>
+              </a:ext>
+            </a:extLst>
+          </p:cNvPr>
+          <p:cNvPicPr>
+            <a:picLocks noChangeAspect="1"/>
+          </p:cNvPicPr>
+          <p:nvPr/>
+        </p:nvPicPr>
+        <p:blipFill>
+          <a:blip r:embed="rId3"/>
+          <a:stretch>
+            <a:fillRect/>
+          </a:stretch>
+        </p:blipFill>
+        <p:spPr>
+          <a:xfrm>
+            <a:off x="2814178" y="1609463"/>
+            <a:ext cx="6563641" cy="4582164"/>
+          </a:xfrm>
+          <a:prstGeom prst="rect">
+            <a:avLst/>
+          </a:prstGeom>
+        </p:spPr>
+      </p:pic>
     </p:spTree>
     <p:extLst>
       <p:ext uri="{BB962C8B-B14F-4D97-AF65-F5344CB8AC3E}">
-        <p14:creationId xmlns:p14="http://schemas.microsoft.com/office/powerpoint/2010/main" val="3384548216"/>
+        <p14:creationId xmlns:p14="http://schemas.microsoft.com/office/powerpoint/2010/main" val="2162116713"/>
       </p:ext>
     </p:extLst>
   </p:cSld>
@@ -3990,7 +3967,7 @@
           <p:cNvPr id="2" name="Title 1">
             <a:extLst>
               <a:ext uri="{FF2B5EF4-FFF2-40B4-BE49-F238E27FC236}">
-                <a16:creationId xmlns:a16="http://schemas.microsoft.com/office/drawing/2014/main" id="{E7B0C72B-C56A-DE96-3B15-90BD228D9733}"/>
+                <a16:creationId xmlns:a16="http://schemas.microsoft.com/office/drawing/2014/main" id="{A2946D8E-31E3-BCF6-1B70-0C34F68C8399}"/>
               </a:ext>
             </a:extLst>
           </p:cNvPr>
@@ -4003,17 +3980,22 @@
         </p:nvSpPr>
         <p:spPr/>
         <p:txBody>
-          <a:bodyPr/>
-          <a:lstStyle/>
-          <a:p>
-            <a:endParaRPr lang="en-US"/>
+          <a:bodyPr>
+            <a:normAutofit fontScale="90000"/>
+          </a:bodyPr>
+          <a:lstStyle/>
+          <a:p>
+            <a:r>
+              <a:rPr lang="en-US" dirty="0"/>
+              <a:t>A historian would like to investigate the claim that the heights of players have increased over the years.  Analyze this claim graphically / visually.</a:t>
+            </a:r>
           </a:p>
         </p:txBody>
       </p:sp>
     </p:spTree>
     <p:extLst>
       <p:ext uri="{BB962C8B-B14F-4D97-AF65-F5344CB8AC3E}">
-        <p14:creationId xmlns:p14="http://schemas.microsoft.com/office/powerpoint/2010/main" val="434424728"/>
+        <p14:creationId xmlns:p14="http://schemas.microsoft.com/office/powerpoint/2010/main" val="3384548216"/>
       </p:ext>
     </p:extLst>
   </p:cSld>
@@ -4040,65 +4022,105 @@
           <a:chExt cx="0" cy="0"/>
         </a:xfrm>
       </p:grpSpPr>
-      <p:sp>
-        <p:nvSpPr>
-          <p:cNvPr id="2" name="Title 1">
-            <a:extLst>
-              <a:ext uri="{FF2B5EF4-FFF2-40B4-BE49-F238E27FC236}">
-                <a16:creationId xmlns:a16="http://schemas.microsoft.com/office/drawing/2014/main" id="{67E89843-7680-DC6B-7247-610B38EC2999}"/>
-              </a:ext>
-            </a:extLst>
-          </p:cNvPr>
-          <p:cNvSpPr>
-            <a:spLocks noGrp="1"/>
-          </p:cNvSpPr>
-          <p:nvPr>
-            <p:ph type="title"/>
-          </p:nvPr>
-        </p:nvSpPr>
-        <p:spPr/>
-        <p:txBody>
-          <a:bodyPr>
-            <a:normAutofit/>
+      <p:pic>
+        <p:nvPicPr>
+          <p:cNvPr id="4" name="Picture 3">
+            <a:extLst>
+              <a:ext uri="{FF2B5EF4-FFF2-40B4-BE49-F238E27FC236}">
+                <a16:creationId xmlns:a16="http://schemas.microsoft.com/office/drawing/2014/main" id="{585752C8-EEF0-5F45-E86A-65914070EB2B}"/>
+              </a:ext>
+            </a:extLst>
+          </p:cNvPr>
+          <p:cNvPicPr>
+            <a:picLocks noChangeAspect="1"/>
+          </p:cNvPicPr>
+          <p:nvPr/>
+        </p:nvPicPr>
+        <p:blipFill>
+          <a:blip r:embed="rId2"/>
+          <a:stretch>
+            <a:fillRect/>
+          </a:stretch>
+        </p:blipFill>
+        <p:spPr>
+          <a:xfrm>
+            <a:off x="65833" y="671127"/>
+            <a:ext cx="6030167" cy="5515745"/>
+          </a:xfrm>
+          <a:prstGeom prst="rect">
+            <a:avLst/>
+          </a:prstGeom>
+        </p:spPr>
+      </p:pic>
+      <p:pic>
+        <p:nvPicPr>
+          <p:cNvPr id="6" name="Picture 5">
+            <a:extLst>
+              <a:ext uri="{FF2B5EF4-FFF2-40B4-BE49-F238E27FC236}">
+                <a16:creationId xmlns:a16="http://schemas.microsoft.com/office/drawing/2014/main" id="{F872338E-F87E-58E0-D189-66E020E29AF1}"/>
+              </a:ext>
+            </a:extLst>
+          </p:cNvPr>
+          <p:cNvPicPr>
+            <a:picLocks noChangeAspect="1"/>
+          </p:cNvPicPr>
+          <p:nvPr/>
+        </p:nvPicPr>
+        <p:blipFill>
+          <a:blip r:embed="rId3"/>
+          <a:stretch>
+            <a:fillRect/>
+          </a:stretch>
+        </p:blipFill>
+        <p:spPr>
+          <a:xfrm>
+            <a:off x="6096000" y="1443161"/>
+            <a:ext cx="6030167" cy="3971676"/>
+          </a:xfrm>
+          <a:prstGeom prst="rect">
+            <a:avLst/>
+          </a:prstGeom>
+        </p:spPr>
+      </p:pic>
+      <p:sp>
+        <p:nvSpPr>
+          <p:cNvPr id="7" name="TextBox 6">
+            <a:extLst>
+              <a:ext uri="{FF2B5EF4-FFF2-40B4-BE49-F238E27FC236}">
+                <a16:creationId xmlns:a16="http://schemas.microsoft.com/office/drawing/2014/main" id="{6C4B2D1C-7778-53B8-10C4-4111AD14DC9E}"/>
+              </a:ext>
+            </a:extLst>
+          </p:cNvPr>
+          <p:cNvSpPr txBox="1"/>
+          <p:nvPr/>
+        </p:nvSpPr>
+        <p:spPr>
+          <a:xfrm>
+            <a:off x="6271846" y="5477689"/>
+            <a:ext cx="5627077" cy="646331"/>
+          </a:xfrm>
+          <a:prstGeom prst="rect">
+            <a:avLst/>
+          </a:prstGeom>
+          <a:noFill/>
+        </p:spPr>
+        <p:txBody>
+          <a:bodyPr wrap="square" rtlCol="0">
+            <a:spAutoFit/>
           </a:bodyPr>
           <a:lstStyle/>
           <a:p>
             <a:r>
               <a:rPr lang="en-US" dirty="0"/>
-              <a:t>Create a 3D plot of height vs. weight vs. year and color code the points by position.</a:t>
-            </a:r>
-          </a:p>
-        </p:txBody>
-      </p:sp>
-      <p:sp>
-        <p:nvSpPr>
-          <p:cNvPr id="3" name="Text Placeholder 2">
-            <a:extLst>
-              <a:ext uri="{FF2B5EF4-FFF2-40B4-BE49-F238E27FC236}">
-                <a16:creationId xmlns:a16="http://schemas.microsoft.com/office/drawing/2014/main" id="{8604AC3D-0EA9-226B-5B99-3ED4095DED00}"/>
-              </a:ext>
-            </a:extLst>
-          </p:cNvPr>
-          <p:cNvSpPr>
-            <a:spLocks noGrp="1"/>
-          </p:cNvSpPr>
-          <p:nvPr>
-            <p:ph type="body" idx="1"/>
-          </p:nvPr>
-        </p:nvSpPr>
-        <p:spPr/>
-        <p:txBody>
-          <a:bodyPr/>
-          <a:lstStyle/>
-          <a:p>
-            <a:endParaRPr lang="en-US"/>
+              <a:t>It looks like the height increase started to level out. What’s up with that?</a:t>
+            </a:r>
           </a:p>
         </p:txBody>
       </p:sp>
     </p:spTree>
     <p:extLst>
       <p:ext uri="{BB962C8B-B14F-4D97-AF65-F5344CB8AC3E}">
-        <p14:creationId xmlns:p14="http://schemas.microsoft.com/office/powerpoint/2010/main" val="4032645203"/>
+        <p14:creationId xmlns:p14="http://schemas.microsoft.com/office/powerpoint/2010/main" val="434424728"/>
       </p:ext>
     </p:extLst>
   </p:cSld>
@@ -4130,7 +4152,7 @@
           <p:cNvPr id="2" name="Title 1">
             <a:extLst>
               <a:ext uri="{FF2B5EF4-FFF2-40B4-BE49-F238E27FC236}">
-                <a16:creationId xmlns:a16="http://schemas.microsoft.com/office/drawing/2014/main" id="{7CA920BC-C8A6-4BA0-58D8-04E1348B9606}"/>
+                <a16:creationId xmlns:a16="http://schemas.microsoft.com/office/drawing/2014/main" id="{67E89843-7680-DC6B-7247-610B38EC2999}"/>
               </a:ext>
             </a:extLst>
           </p:cNvPr>
@@ -4143,17 +4165,22 @@
         </p:nvSpPr>
         <p:spPr/>
         <p:txBody>
-          <a:bodyPr/>
-          <a:lstStyle/>
-          <a:p>
-            <a:endParaRPr lang="en-US"/>
+          <a:bodyPr>
+            <a:normAutofit/>
+          </a:bodyPr>
+          <a:lstStyle/>
+          <a:p>
+            <a:r>
+              <a:rPr lang="en-US" dirty="0"/>
+              <a:t>Create a 3D plot of height vs. weight vs. year and color code the points by position.</a:t>
+            </a:r>
           </a:p>
         </p:txBody>
       </p:sp>
     </p:spTree>
     <p:extLst>
       <p:ext uri="{BB962C8B-B14F-4D97-AF65-F5344CB8AC3E}">
-        <p14:creationId xmlns:p14="http://schemas.microsoft.com/office/powerpoint/2010/main" val="723924871"/>
+        <p14:creationId xmlns:p14="http://schemas.microsoft.com/office/powerpoint/2010/main" val="4032645203"/>
       </p:ext>
     </p:extLst>
   </p:cSld>
@@ -4207,31 +4234,6 @@
               <a:rPr lang="en-US" sz="2800" dirty="0"/>
               <a:t>Download into R Studio the PlayerBBall.csv dataset. This data set is every NBA basketball player from 1950 to present.  It contains their height, weight, position and the year they played (among other data.) (Position: F-Forward, C-Centers, F-C and C-F – Forward /Centers, G – Guards, F-G – Forward/Guards)  FYI: If you feel that these questions are open ended or at least a little vague, this is on purpose.  Answer the question as you understand it and make any assumptions you need to make to answer the question and record those assumptions. (3-5 hours)</a:t>
             </a:r>
-          </a:p>
-        </p:txBody>
-      </p:sp>
-      <p:sp>
-        <p:nvSpPr>
-          <p:cNvPr id="3" name="Text Placeholder 2">
-            <a:extLst>
-              <a:ext uri="{FF2B5EF4-FFF2-40B4-BE49-F238E27FC236}">
-                <a16:creationId xmlns:a16="http://schemas.microsoft.com/office/drawing/2014/main" id="{272B192A-21D1-AA26-41DC-18E4C59F3934}"/>
-              </a:ext>
-            </a:extLst>
-          </p:cNvPr>
-          <p:cNvSpPr>
-            <a:spLocks noGrp="1"/>
-          </p:cNvSpPr>
-          <p:nvPr>
-            <p:ph type="body" idx="1"/>
-          </p:nvPr>
-        </p:nvSpPr>
-        <p:spPr/>
-        <p:txBody>
-          <a:bodyPr/>
-          <a:lstStyle/>
-          <a:p>
-            <a:endParaRPr lang="en-US" dirty="0"/>
           </a:p>
         </p:txBody>
       </p:sp>
@@ -4265,72 +4267,40 @@
           <a:chExt cx="0" cy="0"/>
         </a:xfrm>
       </p:grpSpPr>
-      <p:sp>
-        <p:nvSpPr>
-          <p:cNvPr id="2" name="Title 1">
-            <a:extLst>
-              <a:ext uri="{FF2B5EF4-FFF2-40B4-BE49-F238E27FC236}">
-                <a16:creationId xmlns:a16="http://schemas.microsoft.com/office/drawing/2014/main" id="{0C0CB0A4-8A98-4814-D6EF-7D08435168E4}"/>
-              </a:ext>
-            </a:extLst>
-          </p:cNvPr>
-          <p:cNvSpPr>
-            <a:spLocks noGrp="1"/>
-          </p:cNvSpPr>
-          <p:nvPr>
-            <p:ph type="title"/>
-          </p:nvPr>
-        </p:nvSpPr>
-        <p:spPr/>
-        <p:txBody>
-          <a:bodyPr>
-            <a:noAutofit/>
-          </a:bodyPr>
-          <a:lstStyle/>
-          <a:p>
-            <a:r>
-              <a:rPr lang="en-US" sz="4800" dirty="0"/>
-              <a:t>Go to this website and use one of the 50 best plots to visualize some aspect of the data and provide at least one insight.  You will present your work in breakout! </a:t>
-            </a:r>
-            <a:r>
-              <a:rPr lang="en-US" sz="4800" dirty="0">
-                <a:hlinkClick r:id="rId2"/>
-              </a:rPr>
-              <a:t>http://r-statistics.co/Top50-Ggplot2-Visualizations-MasterList-R-Code.html</a:t>
-            </a:r>
-            <a:endParaRPr lang="en-US" sz="4800" dirty="0"/>
-          </a:p>
-        </p:txBody>
-      </p:sp>
-      <p:sp>
-        <p:nvSpPr>
-          <p:cNvPr id="3" name="Text Placeholder 2">
-            <a:extLst>
-              <a:ext uri="{FF2B5EF4-FFF2-40B4-BE49-F238E27FC236}">
-                <a16:creationId xmlns:a16="http://schemas.microsoft.com/office/drawing/2014/main" id="{82EA4A20-4B05-3581-C313-BBA2BBB66ACE}"/>
-              </a:ext>
-            </a:extLst>
-          </p:cNvPr>
-          <p:cNvSpPr>
-            <a:spLocks noGrp="1"/>
-          </p:cNvSpPr>
-          <p:nvPr>
-            <p:ph type="body" idx="1"/>
-          </p:nvPr>
-        </p:nvSpPr>
-        <p:spPr/>
-        <p:txBody>
-          <a:bodyPr/>
-          <a:lstStyle/>
-          <a:p>
-            <a:endParaRPr lang="en-US"/>
-          </a:p>
-        </p:txBody>
-      </p:sp>
+      <p:pic>
+        <p:nvPicPr>
+          <p:cNvPr id="4" name="Picture 3">
+            <a:extLst>
+              <a:ext uri="{FF2B5EF4-FFF2-40B4-BE49-F238E27FC236}">
+                <a16:creationId xmlns:a16="http://schemas.microsoft.com/office/drawing/2014/main" id="{B9640FDB-3636-7A9B-FE57-91417F2B6E0E}"/>
+              </a:ext>
+            </a:extLst>
+          </p:cNvPr>
+          <p:cNvPicPr>
+            <a:picLocks noChangeAspect="1"/>
+          </p:cNvPicPr>
+          <p:nvPr/>
+        </p:nvPicPr>
+        <p:blipFill>
+          <a:blip r:embed="rId2"/>
+          <a:stretch>
+            <a:fillRect/>
+          </a:stretch>
+        </p:blipFill>
+        <p:spPr>
+          <a:xfrm>
+            <a:off x="2647468" y="61442"/>
+            <a:ext cx="6897063" cy="6735115"/>
+          </a:xfrm>
+          <a:prstGeom prst="rect">
+            <a:avLst/>
+          </a:prstGeom>
+        </p:spPr>
+      </p:pic>
     </p:spTree>
     <p:extLst>
       <p:ext uri="{BB962C8B-B14F-4D97-AF65-F5344CB8AC3E}">
-        <p14:creationId xmlns:p14="http://schemas.microsoft.com/office/powerpoint/2010/main" val="1384826650"/>
+        <p14:creationId xmlns:p14="http://schemas.microsoft.com/office/powerpoint/2010/main" val="723924871"/>
       </p:ext>
     </p:extLst>
   </p:cSld>
@@ -4362,7 +4332,7 @@
           <p:cNvPr id="2" name="Title 1">
             <a:extLst>
               <a:ext uri="{FF2B5EF4-FFF2-40B4-BE49-F238E27FC236}">
-                <a16:creationId xmlns:a16="http://schemas.microsoft.com/office/drawing/2014/main" id="{6B6043A5-979B-3B03-C7F1-8F0603A6F5F4}"/>
+                <a16:creationId xmlns:a16="http://schemas.microsoft.com/office/drawing/2014/main" id="{0C0CB0A4-8A98-4814-D6EF-7D08435168E4}"/>
               </a:ext>
             </a:extLst>
           </p:cNvPr>
@@ -4375,10 +4345,170 @@
         </p:nvSpPr>
         <p:spPr/>
         <p:txBody>
-          <a:bodyPr/>
-          <a:lstStyle/>
-          <a:p>
-            <a:endParaRPr lang="en-US"/>
+          <a:bodyPr>
+            <a:noAutofit/>
+          </a:bodyPr>
+          <a:lstStyle/>
+          <a:p>
+            <a:r>
+              <a:rPr lang="en-US" sz="4800" dirty="0"/>
+              <a:t>Go to this website and use one of the 50 best plots to visualize some aspect of the data and provide at least one insight.  You will present your work in breakout! </a:t>
+            </a:r>
+            <a:r>
+              <a:rPr lang="en-US" sz="4800" dirty="0">
+                <a:hlinkClick r:id="rId2"/>
+              </a:rPr>
+              <a:t>http://r-statistics.co/Top50-Ggplot2-Visualizations-MasterList-R-Code.html</a:t>
+            </a:r>
+            <a:endParaRPr lang="en-US" sz="4800" dirty="0"/>
+          </a:p>
+        </p:txBody>
+      </p:sp>
+    </p:spTree>
+    <p:extLst>
+      <p:ext uri="{BB962C8B-B14F-4D97-AF65-F5344CB8AC3E}">
+        <p14:creationId xmlns:p14="http://schemas.microsoft.com/office/powerpoint/2010/main" val="1384826650"/>
+      </p:ext>
+    </p:extLst>
+  </p:cSld>
+  <p:clrMapOvr>
+    <a:masterClrMapping/>
+  </p:clrMapOvr>
+</p:sld>
+</file>
+
+<file path=ppt/slides/slide22.xml><?xml version="1.0" encoding="utf-8"?>
+<p:sld xmlns:a="http://schemas.openxmlformats.org/drawingml/2006/main" xmlns:r="http://schemas.openxmlformats.org/officeDocument/2006/relationships" xmlns:p="http://schemas.openxmlformats.org/presentationml/2006/main">
+  <p:cSld>
+    <p:spTree>
+      <p:nvGrpSpPr>
+        <p:cNvPr id="1" name=""/>
+        <p:cNvGrpSpPr/>
+        <p:nvPr/>
+      </p:nvGrpSpPr>
+      <p:grpSpPr>
+        <a:xfrm>
+          <a:off x="0" y="0"/>
+          <a:ext cx="0" cy="0"/>
+          <a:chOff x="0" y="0"/>
+          <a:chExt cx="0" cy="0"/>
+        </a:xfrm>
+      </p:grpSpPr>
+      <p:pic>
+        <p:nvPicPr>
+          <p:cNvPr id="4" name="Picture 3">
+            <a:extLst>
+              <a:ext uri="{FF2B5EF4-FFF2-40B4-BE49-F238E27FC236}">
+                <a16:creationId xmlns:a16="http://schemas.microsoft.com/office/drawing/2014/main" id="{022B32D3-FAD5-4A4E-AA93-85E64BEC9447}"/>
+              </a:ext>
+            </a:extLst>
+          </p:cNvPr>
+          <p:cNvPicPr>
+            <a:picLocks noChangeAspect="1"/>
+          </p:cNvPicPr>
+          <p:nvPr/>
+        </p:nvPicPr>
+        <p:blipFill>
+          <a:blip r:embed="rId2"/>
+          <a:stretch>
+            <a:fillRect/>
+          </a:stretch>
+        </p:blipFill>
+        <p:spPr>
+          <a:xfrm>
+            <a:off x="0" y="895520"/>
+            <a:ext cx="6552696" cy="5066960"/>
+          </a:xfrm>
+          <a:prstGeom prst="rect">
+            <a:avLst/>
+          </a:prstGeom>
+        </p:spPr>
+      </p:pic>
+      <p:sp>
+        <p:nvSpPr>
+          <p:cNvPr id="5" name="TextBox 4">
+            <a:extLst>
+              <a:ext uri="{FF2B5EF4-FFF2-40B4-BE49-F238E27FC236}">
+                <a16:creationId xmlns:a16="http://schemas.microsoft.com/office/drawing/2014/main" id="{BECE5536-C37B-89D9-638A-5BFFBDC3B75B}"/>
+              </a:ext>
+            </a:extLst>
+          </p:cNvPr>
+          <p:cNvSpPr txBox="1"/>
+          <p:nvPr/>
+        </p:nvSpPr>
+        <p:spPr>
+          <a:xfrm>
+            <a:off x="7303476" y="1822377"/>
+            <a:ext cx="4489939" cy="3416320"/>
+          </a:xfrm>
+          <a:prstGeom prst="rect">
+            <a:avLst/>
+          </a:prstGeom>
+          <a:noFill/>
+        </p:spPr>
+        <p:txBody>
+          <a:bodyPr wrap="square" rtlCol="0">
+            <a:spAutoFit/>
+          </a:bodyPr>
+          <a:lstStyle/>
+          <a:p>
+            <a:pPr marL="285750" indent="-285750">
+              <a:buFont typeface="Arial" panose="020B0604020202020204" pitchFamily="34" charset="0"/>
+              <a:buChar char="•"/>
+            </a:pPr>
+            <a:r>
+              <a:rPr lang="en-US" sz="2000" dirty="0"/>
+              <a:t>Classic visualization</a:t>
+            </a:r>
+          </a:p>
+          <a:p>
+            <a:pPr marL="285750" indent="-285750">
+              <a:buFont typeface="Arial" panose="020B0604020202020204" pitchFamily="34" charset="0"/>
+              <a:buChar char="•"/>
+            </a:pPr>
+            <a:r>
+              <a:rPr lang="en-US" sz="2000" dirty="0"/>
+              <a:t>Can be hard to read</a:t>
+            </a:r>
+          </a:p>
+          <a:p>
+            <a:pPr marL="285750" indent="-285750">
+              <a:buFont typeface="Arial" panose="020B0604020202020204" pitchFamily="34" charset="0"/>
+              <a:buChar char="•"/>
+            </a:pPr>
+            <a:r>
+              <a:rPr lang="en-US" sz="2000" dirty="0"/>
+              <a:t>Do not use with many categories</a:t>
+            </a:r>
+          </a:p>
+          <a:p>
+            <a:pPr marL="285750" indent="-285750">
+              <a:buFont typeface="Arial" panose="020B0604020202020204" pitchFamily="34" charset="0"/>
+              <a:buChar char="•"/>
+            </a:pPr>
+            <a:r>
+              <a:rPr lang="en-US" sz="2000" dirty="0"/>
+              <a:t>Color contrast should be immediately clear</a:t>
+            </a:r>
+            <a:endParaRPr lang="en-US" sz="2000" i="1" dirty="0"/>
+          </a:p>
+          <a:p>
+            <a:endParaRPr lang="en-US" i="1" dirty="0"/>
+          </a:p>
+          <a:p>
+            <a:r>
+              <a:rPr lang="en-US" sz="1400" i="1" dirty="0"/>
+              <a:t>The pie chart is classic, but some people find it hard to read because it requires you to distinguish between different hues, which can be difficult. </a:t>
+            </a:r>
+          </a:p>
+          <a:p>
+            <a:endParaRPr lang="en-US" sz="1400" i="1" dirty="0"/>
+          </a:p>
+          <a:p>
+            <a:r>
+              <a:rPr lang="en-US" sz="1400" i="1" dirty="0"/>
+              <a:t>Therefore, it works better when the colors contrast more, but if there are many different categories it becomes harder to select sufficiently contrasting colors.</a:t>
+            </a:r>
           </a:p>
         </p:txBody>
       </p:sp>
@@ -4395,7 +4525,7 @@
 </p:sld>
 </file>
 
-<file path=ppt/slides/slide22.xml><?xml version="1.0" encoding="utf-8"?>
+<file path=ppt/slides/slide23.xml><?xml version="1.0" encoding="utf-8"?>
 <p:sld xmlns:a="http://schemas.openxmlformats.org/drawingml/2006/main" xmlns:r="http://schemas.openxmlformats.org/officeDocument/2006/relationships" xmlns:p="http://schemas.openxmlformats.org/presentationml/2006/main">
   <p:cSld>
     <p:spTree>
@@ -4475,7 +4605,7 @@
           <p:cNvPr id="4" name="Title 3">
             <a:extLst>
               <a:ext uri="{FF2B5EF4-FFF2-40B4-BE49-F238E27FC236}">
-                <a16:creationId xmlns:a16="http://schemas.microsoft.com/office/drawing/2014/main" id="{77CD0054-A4A4-9CA5-9454-038E62D3A9FD}"/>
+                <a16:creationId xmlns:a16="http://schemas.microsoft.com/office/drawing/2014/main" id="{8ED1C4CC-A40E-4C8C-A657-7BFC8652B0FD}"/>
               </a:ext>
             </a:extLst>
           </p:cNvPr>
@@ -4488,17 +4618,22 @@
         </p:nvSpPr>
         <p:spPr/>
         <p:txBody>
-          <a:bodyPr/>
-          <a:lstStyle/>
-          <a:p>
-            <a:endParaRPr lang="en-US"/>
+          <a:bodyPr>
+            <a:normAutofit fontScale="90000"/>
+          </a:bodyPr>
+          <a:lstStyle/>
+          <a:p>
+            <a:r>
+              <a:rPr lang="en-US" dirty="0"/>
+              <a:t>Use the PlayerBBall.csv dataset to visually represent (summarize) the number of players in each position.</a:t>
+            </a:r>
           </a:p>
         </p:txBody>
       </p:sp>
     </p:spTree>
     <p:extLst>
       <p:ext uri="{BB962C8B-B14F-4D97-AF65-F5344CB8AC3E}">
-        <p14:creationId xmlns:p14="http://schemas.microsoft.com/office/powerpoint/2010/main" val="1300891083"/>
+        <p14:creationId xmlns:p14="http://schemas.microsoft.com/office/powerpoint/2010/main" val="1613393479"/>
       </p:ext>
     </p:extLst>
   </p:cSld>
@@ -4525,65 +4660,71 @@
           <a:chExt cx="0" cy="0"/>
         </a:xfrm>
       </p:grpSpPr>
-      <p:sp>
-        <p:nvSpPr>
-          <p:cNvPr id="4" name="Title 3">
-            <a:extLst>
-              <a:ext uri="{FF2B5EF4-FFF2-40B4-BE49-F238E27FC236}">
-                <a16:creationId xmlns:a16="http://schemas.microsoft.com/office/drawing/2014/main" id="{8ED1C4CC-A40E-4C8C-A657-7BFC8652B0FD}"/>
-              </a:ext>
-            </a:extLst>
-          </p:cNvPr>
-          <p:cNvSpPr>
-            <a:spLocks noGrp="1"/>
-          </p:cNvSpPr>
-          <p:nvPr>
-            <p:ph type="title"/>
-          </p:nvPr>
-        </p:nvSpPr>
-        <p:spPr/>
-        <p:txBody>
-          <a:bodyPr>
-            <a:normAutofit fontScale="90000"/>
-          </a:bodyPr>
-          <a:lstStyle/>
-          <a:p>
-            <a:r>
-              <a:rPr lang="en-US" dirty="0"/>
-              <a:t>Use the PlayerBBall.csv dataset to visually represent (summarize) the number of players in each position.</a:t>
-            </a:r>
-          </a:p>
-        </p:txBody>
-      </p:sp>
-      <p:sp>
-        <p:nvSpPr>
-          <p:cNvPr id="5" name="Text Placeholder 4">
-            <a:extLst>
-              <a:ext uri="{FF2B5EF4-FFF2-40B4-BE49-F238E27FC236}">
-                <a16:creationId xmlns:a16="http://schemas.microsoft.com/office/drawing/2014/main" id="{5477899D-44B4-1AA0-D602-E7DE97EF87D3}"/>
-              </a:ext>
-            </a:extLst>
-          </p:cNvPr>
-          <p:cNvSpPr>
-            <a:spLocks noGrp="1"/>
-          </p:cNvSpPr>
-          <p:nvPr>
-            <p:ph type="body" idx="1"/>
-          </p:nvPr>
-        </p:nvSpPr>
-        <p:spPr/>
-        <p:txBody>
-          <a:bodyPr/>
-          <a:lstStyle/>
-          <a:p>
-            <a:endParaRPr lang="en-US"/>
-          </a:p>
-        </p:txBody>
-      </p:sp>
+      <p:pic>
+        <p:nvPicPr>
+          <p:cNvPr id="6" name="Picture 5">
+            <a:extLst>
+              <a:ext uri="{FF2B5EF4-FFF2-40B4-BE49-F238E27FC236}">
+                <a16:creationId xmlns:a16="http://schemas.microsoft.com/office/drawing/2014/main" id="{5B2948BF-89DA-B54C-42BE-AFAD6D83647F}"/>
+              </a:ext>
+            </a:extLst>
+          </p:cNvPr>
+          <p:cNvPicPr>
+            <a:picLocks noChangeAspect="1"/>
+          </p:cNvPicPr>
+          <p:nvPr/>
+        </p:nvPicPr>
+        <p:blipFill>
+          <a:blip r:embed="rId2"/>
+          <a:srcRect b="86468"/>
+          <a:stretch>
+            <a:fillRect/>
+          </a:stretch>
+        </p:blipFill>
+        <p:spPr>
+          <a:xfrm>
+            <a:off x="2352543" y="728286"/>
+            <a:ext cx="7135221" cy="730940"/>
+          </a:xfrm>
+          <a:prstGeom prst="rect">
+            <a:avLst/>
+          </a:prstGeom>
+        </p:spPr>
+      </p:pic>
+      <p:pic>
+        <p:nvPicPr>
+          <p:cNvPr id="8" name="Picture 7">
+            <a:extLst>
+              <a:ext uri="{FF2B5EF4-FFF2-40B4-BE49-F238E27FC236}">
+                <a16:creationId xmlns:a16="http://schemas.microsoft.com/office/drawing/2014/main" id="{2E317755-CBD8-2304-95B0-661EA3D1E1D7}"/>
+              </a:ext>
+            </a:extLst>
+          </p:cNvPr>
+          <p:cNvPicPr>
+            <a:picLocks noChangeAspect="1"/>
+          </p:cNvPicPr>
+          <p:nvPr/>
+        </p:nvPicPr>
+        <p:blipFill>
+          <a:blip r:embed="rId3"/>
+          <a:stretch>
+            <a:fillRect/>
+          </a:stretch>
+        </p:blipFill>
+        <p:spPr>
+          <a:xfrm>
+            <a:off x="2514490" y="1611625"/>
+            <a:ext cx="6811326" cy="4267796"/>
+          </a:xfrm>
+          <a:prstGeom prst="rect">
+            <a:avLst/>
+          </a:prstGeom>
+        </p:spPr>
+      </p:pic>
     </p:spTree>
     <p:extLst>
       <p:ext uri="{BB962C8B-B14F-4D97-AF65-F5344CB8AC3E}">
-        <p14:creationId xmlns:p14="http://schemas.microsoft.com/office/powerpoint/2010/main" val="1613393479"/>
+        <p14:creationId xmlns:p14="http://schemas.microsoft.com/office/powerpoint/2010/main" val="2965440394"/>
       </p:ext>
     </p:extLst>
   </p:cSld>
@@ -4612,61 +4753,6 @@
       </p:grpSpPr>
       <p:sp>
         <p:nvSpPr>
-          <p:cNvPr id="4" name="Title 3">
-            <a:extLst>
-              <a:ext uri="{FF2B5EF4-FFF2-40B4-BE49-F238E27FC236}">
-                <a16:creationId xmlns:a16="http://schemas.microsoft.com/office/drawing/2014/main" id="{A4C85794-0DC9-BBCB-66F8-05FEC5926F3C}"/>
-              </a:ext>
-            </a:extLst>
-          </p:cNvPr>
-          <p:cNvSpPr>
-            <a:spLocks noGrp="1"/>
-          </p:cNvSpPr>
-          <p:nvPr>
-            <p:ph type="title"/>
-          </p:nvPr>
-        </p:nvSpPr>
-        <p:spPr/>
-        <p:txBody>
-          <a:bodyPr/>
-          <a:lstStyle/>
-          <a:p>
-            <a:endParaRPr lang="en-US"/>
-          </a:p>
-        </p:txBody>
-      </p:sp>
-    </p:spTree>
-    <p:extLst>
-      <p:ext uri="{BB962C8B-B14F-4D97-AF65-F5344CB8AC3E}">
-        <p14:creationId xmlns:p14="http://schemas.microsoft.com/office/powerpoint/2010/main" val="2965440394"/>
-      </p:ext>
-    </p:extLst>
-  </p:cSld>
-  <p:clrMapOvr>
-    <a:masterClrMapping/>
-  </p:clrMapOvr>
-</p:sld>
-</file>
-
-<file path=ppt/slides/slide6.xml><?xml version="1.0" encoding="utf-8"?>
-<p:sld xmlns:a="http://schemas.openxmlformats.org/drawingml/2006/main" xmlns:r="http://schemas.openxmlformats.org/officeDocument/2006/relationships" xmlns:p="http://schemas.openxmlformats.org/presentationml/2006/main">
-  <p:cSld>
-    <p:spTree>
-      <p:nvGrpSpPr>
-        <p:cNvPr id="1" name=""/>
-        <p:cNvGrpSpPr/>
-        <p:nvPr/>
-      </p:nvGrpSpPr>
-      <p:grpSpPr>
-        <a:xfrm>
-          <a:off x="0" y="0"/>
-          <a:ext cx="0" cy="0"/>
-          <a:chOff x="0" y="0"/>
-          <a:chExt cx="0" cy="0"/>
-        </a:xfrm>
-      </p:grpSpPr>
-      <p:sp>
-        <p:nvSpPr>
           <p:cNvPr id="2" name="Title 1">
             <a:extLst>
               <a:ext uri="{FF2B5EF4-FFF2-40B4-BE49-F238E27FC236}">
@@ -4716,7 +4802,20 @@
           <a:bodyPr/>
           <a:lstStyle/>
           <a:p>
-            <a:endParaRPr lang="en-US"/>
+            <a:r>
+              <a:rPr lang="en-US" dirty="0"/>
+              <a:t>Question: How do I filter the data so that only these positions appear on the graph?</a:t>
+            </a:r>
+            <a:br>
+              <a:rPr lang="en-US" dirty="0"/>
+            </a:br>
+            <a:br>
+              <a:rPr lang="en-US" dirty="0"/>
+            </a:br>
+            <a:r>
+              <a:rPr lang="en-US" dirty="0"/>
+              <a:t>The data show the distribution of weight of centers is greater than of forwards.</a:t>
+            </a:r>
           </a:p>
         </p:txBody>
       </p:sp>
@@ -4733,7 +4832,7 @@
 </p:sld>
 </file>
 
-<file path=ppt/slides/slide7.xml><?xml version="1.0" encoding="utf-8"?>
+<file path=ppt/slides/slide6.xml><?xml version="1.0" encoding="utf-8"?>
 <p:sld xmlns:a="http://schemas.openxmlformats.org/drawingml/2006/main" xmlns:r="http://schemas.openxmlformats.org/officeDocument/2006/relationships" xmlns:p="http://schemas.openxmlformats.org/presentationml/2006/main">
   <p:cSld>
     <p:spTree>
@@ -4756,31 +4855,66 @@
           <a:chExt cx="0" cy="0"/>
         </a:xfrm>
       </p:grpSpPr>
-      <p:sp>
-        <p:nvSpPr>
-          <p:cNvPr id="4" name="Title 3">
-            <a:extLst>
-              <a:ext uri="{FF2B5EF4-FFF2-40B4-BE49-F238E27FC236}">
-                <a16:creationId xmlns:a16="http://schemas.microsoft.com/office/drawing/2014/main" id="{EF72396F-334B-8E13-A2B5-D9B9190DE792}"/>
-              </a:ext>
-            </a:extLst>
-          </p:cNvPr>
-          <p:cNvSpPr>
-            <a:spLocks noGrp="1"/>
-          </p:cNvSpPr>
-          <p:nvPr>
-            <p:ph type="title"/>
-          </p:nvPr>
-        </p:nvSpPr>
-        <p:spPr/>
-        <p:txBody>
-          <a:bodyPr/>
-          <a:lstStyle/>
-          <a:p>
-            <a:endParaRPr lang="en-US"/>
-          </a:p>
-        </p:txBody>
-      </p:sp>
+      <p:pic>
+        <p:nvPicPr>
+          <p:cNvPr id="8" name="Picture 7">
+            <a:extLst>
+              <a:ext uri="{FF2B5EF4-FFF2-40B4-BE49-F238E27FC236}">
+                <a16:creationId xmlns:a16="http://schemas.microsoft.com/office/drawing/2014/main" id="{8DC66573-A1B9-948E-98EA-F9E622B53D91}"/>
+              </a:ext>
+            </a:extLst>
+          </p:cNvPr>
+          <p:cNvPicPr>
+            <a:picLocks noChangeAspect="1"/>
+          </p:cNvPicPr>
+          <p:nvPr/>
+        </p:nvPicPr>
+        <p:blipFill>
+          <a:blip r:embed="rId2"/>
+          <a:stretch>
+            <a:fillRect/>
+          </a:stretch>
+        </p:blipFill>
+        <p:spPr>
+          <a:xfrm>
+            <a:off x="63741" y="0"/>
+            <a:ext cx="6032259" cy="6858000"/>
+          </a:xfrm>
+          <a:prstGeom prst="rect">
+            <a:avLst/>
+          </a:prstGeom>
+        </p:spPr>
+      </p:pic>
+      <p:pic>
+        <p:nvPicPr>
+          <p:cNvPr id="10" name="Picture 9">
+            <a:extLst>
+              <a:ext uri="{FF2B5EF4-FFF2-40B4-BE49-F238E27FC236}">
+                <a16:creationId xmlns:a16="http://schemas.microsoft.com/office/drawing/2014/main" id="{6F429844-EED3-719D-C522-902066D50717}"/>
+              </a:ext>
+            </a:extLst>
+          </p:cNvPr>
+          <p:cNvPicPr>
+            <a:picLocks noChangeAspect="1"/>
+          </p:cNvPicPr>
+          <p:nvPr/>
+        </p:nvPicPr>
+        <p:blipFill>
+          <a:blip r:embed="rId3"/>
+          <a:stretch>
+            <a:fillRect/>
+          </a:stretch>
+        </p:blipFill>
+        <p:spPr>
+          <a:xfrm>
+            <a:off x="5883373" y="0"/>
+            <a:ext cx="6308627" cy="6858000"/>
+          </a:xfrm>
+          <a:prstGeom prst="rect">
+            <a:avLst/>
+          </a:prstGeom>
+        </p:spPr>
+      </p:pic>
     </p:spTree>
     <p:extLst>
       <p:ext uri="{BB962C8B-B14F-4D97-AF65-F5344CB8AC3E}">
@@ -4794,7 +4928,7 @@
 </p:sld>
 </file>
 
-<file path=ppt/slides/slide8.xml><?xml version="1.0" encoding="utf-8"?>
+<file path=ppt/slides/slide7.xml><?xml version="1.0" encoding="utf-8"?>
 <p:sld xmlns:a="http://schemas.openxmlformats.org/drawingml/2006/main" xmlns:r="http://schemas.openxmlformats.org/officeDocument/2006/relationships" xmlns:p="http://schemas.openxmlformats.org/presentationml/2006/main">
   <p:cSld>
     <p:spTree>
@@ -4862,7 +4996,16 @@
           <a:bodyPr/>
           <a:lstStyle/>
           <a:p>
-            <a:endParaRPr lang="en-US"/>
+            <a:r>
+              <a:rPr lang="en-US" dirty="0"/>
+              <a:t>Question: How do I convert the height from “6-10” to “6.833”?</a:t>
+            </a:r>
+          </a:p>
+          <a:p>
+            <a:r>
+              <a:rPr lang="en-US" dirty="0"/>
+              <a:t>The data show the distribution of height of centers is greater than of forwards.</a:t>
+            </a:r>
           </a:p>
         </p:txBody>
       </p:sp>
@@ -4879,7 +5022,7 @@
 </p:sld>
 </file>
 
-<file path=ppt/slides/slide9.xml><?xml version="1.0" encoding="utf-8"?>
+<file path=ppt/slides/slide8.xml><?xml version="1.0" encoding="utf-8"?>
 <p:sld xmlns:a="http://schemas.openxmlformats.org/drawingml/2006/main" xmlns:r="http://schemas.openxmlformats.org/officeDocument/2006/relationships" xmlns:p="http://schemas.openxmlformats.org/presentationml/2006/main">
   <p:cSld>
     <p:spTree>
@@ -4902,35 +5045,130 @@
           <a:chExt cx="0" cy="0"/>
         </a:xfrm>
       </p:grpSpPr>
-      <p:sp>
-        <p:nvSpPr>
-          <p:cNvPr id="4" name="Title 3">
-            <a:extLst>
-              <a:ext uri="{FF2B5EF4-FFF2-40B4-BE49-F238E27FC236}">
-                <a16:creationId xmlns:a16="http://schemas.microsoft.com/office/drawing/2014/main" id="{A6044175-9554-A3C4-0498-CB61F62CD077}"/>
-              </a:ext>
-            </a:extLst>
-          </p:cNvPr>
-          <p:cNvSpPr>
-            <a:spLocks noGrp="1"/>
-          </p:cNvSpPr>
-          <p:nvPr>
-            <p:ph type="title"/>
-          </p:nvPr>
-        </p:nvSpPr>
-        <p:spPr/>
-        <p:txBody>
-          <a:bodyPr/>
-          <a:lstStyle/>
-          <a:p>
-            <a:endParaRPr lang="en-US"/>
-          </a:p>
-        </p:txBody>
-      </p:sp>
+      <p:pic>
+        <p:nvPicPr>
+          <p:cNvPr id="7" name="Picture 6">
+            <a:extLst>
+              <a:ext uri="{FF2B5EF4-FFF2-40B4-BE49-F238E27FC236}">
+                <a16:creationId xmlns:a16="http://schemas.microsoft.com/office/drawing/2014/main" id="{1668001E-68F5-88A6-68DF-E806D814FCA5}"/>
+              </a:ext>
+            </a:extLst>
+          </p:cNvPr>
+          <p:cNvPicPr>
+            <a:picLocks noChangeAspect="1"/>
+          </p:cNvPicPr>
+          <p:nvPr/>
+        </p:nvPicPr>
+        <p:blipFill>
+          <a:blip r:embed="rId2"/>
+          <a:stretch>
+            <a:fillRect/>
+          </a:stretch>
+        </p:blipFill>
+        <p:spPr>
+          <a:xfrm>
+            <a:off x="1277815" y="1284087"/>
+            <a:ext cx="4818185" cy="5550774"/>
+          </a:xfrm>
+          <a:prstGeom prst="rect">
+            <a:avLst/>
+          </a:prstGeom>
+        </p:spPr>
+      </p:pic>
+      <p:pic>
+        <p:nvPicPr>
+          <p:cNvPr id="9" name="Picture 8">
+            <a:extLst>
+              <a:ext uri="{FF2B5EF4-FFF2-40B4-BE49-F238E27FC236}">
+                <a16:creationId xmlns:a16="http://schemas.microsoft.com/office/drawing/2014/main" id="{60FBAE4C-E8CF-F6D6-562C-ABCEEBB44DAF}"/>
+              </a:ext>
+            </a:extLst>
+          </p:cNvPr>
+          <p:cNvPicPr>
+            <a:picLocks noChangeAspect="1"/>
+          </p:cNvPicPr>
+          <p:nvPr/>
+        </p:nvPicPr>
+        <p:blipFill>
+          <a:blip r:embed="rId3"/>
+          <a:stretch>
+            <a:fillRect/>
+          </a:stretch>
+        </p:blipFill>
+        <p:spPr>
+          <a:xfrm>
+            <a:off x="6095999" y="1307226"/>
+            <a:ext cx="4818185" cy="5504496"/>
+          </a:xfrm>
+          <a:prstGeom prst="rect">
+            <a:avLst/>
+          </a:prstGeom>
+        </p:spPr>
+      </p:pic>
     </p:spTree>
     <p:extLst>
       <p:ext uri="{BB962C8B-B14F-4D97-AF65-F5344CB8AC3E}">
         <p14:creationId xmlns:p14="http://schemas.microsoft.com/office/powerpoint/2010/main" val="2304346035"/>
+      </p:ext>
+    </p:extLst>
+  </p:cSld>
+  <p:clrMapOvr>
+    <a:masterClrMapping/>
+  </p:clrMapOvr>
+</p:sld>
+</file>
+
+<file path=ppt/slides/slide9.xml><?xml version="1.0" encoding="utf-8"?>
+<p:sld xmlns:a="http://schemas.openxmlformats.org/drawingml/2006/main" xmlns:r="http://schemas.openxmlformats.org/officeDocument/2006/relationships" xmlns:p="http://schemas.openxmlformats.org/presentationml/2006/main">
+  <p:cSld>
+    <p:spTree>
+      <p:nvGrpSpPr>
+        <p:cNvPr id="1" name=""/>
+        <p:cNvGrpSpPr/>
+        <p:nvPr/>
+      </p:nvGrpSpPr>
+      <p:grpSpPr>
+        <a:xfrm>
+          <a:off x="0" y="0"/>
+          <a:ext cx="0" cy="0"/>
+          <a:chOff x="0" y="0"/>
+          <a:chExt cx="0" cy="0"/>
+        </a:xfrm>
+      </p:grpSpPr>
+      <p:pic>
+        <p:nvPicPr>
+          <p:cNvPr id="3" name="Picture 2">
+            <a:extLst>
+              <a:ext uri="{FF2B5EF4-FFF2-40B4-BE49-F238E27FC236}">
+                <a16:creationId xmlns:a16="http://schemas.microsoft.com/office/drawing/2014/main" id="{7A45123F-4838-4134-E4F2-7885B3621950}"/>
+              </a:ext>
+            </a:extLst>
+          </p:cNvPr>
+          <p:cNvPicPr>
+            <a:picLocks noChangeAspect="1"/>
+          </p:cNvPicPr>
+          <p:nvPr/>
+        </p:nvPicPr>
+        <p:blipFill>
+          <a:blip r:embed="rId2"/>
+          <a:stretch>
+            <a:fillRect/>
+          </a:stretch>
+        </p:blipFill>
+        <p:spPr>
+          <a:xfrm>
+            <a:off x="3340369" y="2749237"/>
+            <a:ext cx="5511262" cy="1359526"/>
+          </a:xfrm>
+          <a:prstGeom prst="rect">
+            <a:avLst/>
+          </a:prstGeom>
+        </p:spPr>
+      </p:pic>
+    </p:spTree>
+    <p:extLst>
+      <p:ext uri="{BB962C8B-B14F-4D97-AF65-F5344CB8AC3E}">
+        <p14:creationId xmlns:p14="http://schemas.microsoft.com/office/powerpoint/2010/main" val="873717824"/>
       </p:ext>
     </p:extLst>
   </p:cSld>

</xml_diff>

<commit_message>
more on unit 2
</commit_message>
<xml_diff>
--- a/Unit 2 Visualization/Isabella_Westlauer_FLS_Unit2.pptx
+++ b/Unit 2 Visualization/Isabella_Westlauer_FLS_Unit2.pptx
@@ -4,30 +4,24 @@
   <p:sldMasterIdLst>
     <p:sldMasterId id="2147483648" r:id="rId1"/>
   </p:sldMasterIdLst>
+  <p:notesMasterIdLst>
+    <p:notesMasterId r:id="rId16"/>
+  </p:notesMasterIdLst>
   <p:sldIdLst>
     <p:sldId id="256" r:id="rId2"/>
-    <p:sldId id="266" r:id="rId3"/>
-    <p:sldId id="257" r:id="rId4"/>
-    <p:sldId id="268" r:id="rId5"/>
-    <p:sldId id="258" r:id="rId6"/>
-    <p:sldId id="269" r:id="rId7"/>
-    <p:sldId id="259" r:id="rId8"/>
-    <p:sldId id="270" r:id="rId9"/>
-    <p:sldId id="278" r:id="rId10"/>
-    <p:sldId id="271" r:id="rId11"/>
-    <p:sldId id="260" r:id="rId12"/>
-    <p:sldId id="279" r:id="rId13"/>
-    <p:sldId id="261" r:id="rId14"/>
-    <p:sldId id="272" r:id="rId15"/>
-    <p:sldId id="262" r:id="rId16"/>
-    <p:sldId id="273" r:id="rId17"/>
-    <p:sldId id="263" r:id="rId18"/>
-    <p:sldId id="274" r:id="rId19"/>
-    <p:sldId id="264" r:id="rId20"/>
-    <p:sldId id="275" r:id="rId21"/>
-    <p:sldId id="265" r:id="rId22"/>
-    <p:sldId id="276" r:id="rId23"/>
-    <p:sldId id="277" r:id="rId24"/>
+    <p:sldId id="268" r:id="rId3"/>
+    <p:sldId id="269" r:id="rId4"/>
+    <p:sldId id="270" r:id="rId5"/>
+    <p:sldId id="278" r:id="rId6"/>
+    <p:sldId id="271" r:id="rId7"/>
+    <p:sldId id="279" r:id="rId8"/>
+    <p:sldId id="280" r:id="rId9"/>
+    <p:sldId id="272" r:id="rId10"/>
+    <p:sldId id="273" r:id="rId11"/>
+    <p:sldId id="274" r:id="rId12"/>
+    <p:sldId id="275" r:id="rId13"/>
+    <p:sldId id="276" r:id="rId14"/>
+    <p:sldId id="277" r:id="rId15"/>
   </p:sldIdLst>
   <p:sldSz cx="12192000" cy="6858000"/>
   <p:notesSz cx="6858000" cy="9144000"/>
@@ -132,26 +126,17 @@
         <p14:section name="Default Section" id="{FB164C65-F91C-4883-A894-30A7DD52B25B}">
           <p14:sldIdLst>
             <p14:sldId id="256"/>
-            <p14:sldId id="266"/>
-            <p14:sldId id="257"/>
             <p14:sldId id="268"/>
-            <p14:sldId id="258"/>
             <p14:sldId id="269"/>
-            <p14:sldId id="259"/>
             <p14:sldId id="270"/>
             <p14:sldId id="278"/>
             <p14:sldId id="271"/>
-            <p14:sldId id="260"/>
             <p14:sldId id="279"/>
-            <p14:sldId id="261"/>
+            <p14:sldId id="280"/>
             <p14:sldId id="272"/>
-            <p14:sldId id="262"/>
             <p14:sldId id="273"/>
-            <p14:sldId id="263"/>
             <p14:sldId id="274"/>
-            <p14:sldId id="264"/>
             <p14:sldId id="275"/>
-            <p14:sldId id="265"/>
             <p14:sldId id="276"/>
             <p14:sldId id="277"/>
           </p14:sldIdLst>
@@ -163,6 +148,1241 @@
     </p:ext>
   </p:extLst>
 </p:presentation>
+</file>
+
+<file path=ppt/notesMasters/notesMaster1.xml><?xml version="1.0" encoding="utf-8"?>
+<p:notesMaster xmlns:a="http://schemas.openxmlformats.org/drawingml/2006/main" xmlns:r="http://schemas.openxmlformats.org/officeDocument/2006/relationships" xmlns:p="http://schemas.openxmlformats.org/presentationml/2006/main">
+  <p:cSld>
+    <p:bg>
+      <p:bgRef idx="1001">
+        <a:schemeClr val="bg1"/>
+      </p:bgRef>
+    </p:bg>
+    <p:spTree>
+      <p:nvGrpSpPr>
+        <p:cNvPr id="1" name=""/>
+        <p:cNvGrpSpPr/>
+        <p:nvPr/>
+      </p:nvGrpSpPr>
+      <p:grpSpPr>
+        <a:xfrm>
+          <a:off x="0" y="0"/>
+          <a:ext cx="0" cy="0"/>
+          <a:chOff x="0" y="0"/>
+          <a:chExt cx="0" cy="0"/>
+        </a:xfrm>
+      </p:grpSpPr>
+      <p:sp>
+        <p:nvSpPr>
+          <p:cNvPr id="2" name="Header Placeholder 1"/>
+          <p:cNvSpPr>
+            <a:spLocks noGrp="1"/>
+          </p:cNvSpPr>
+          <p:nvPr>
+            <p:ph type="hdr" sz="quarter"/>
+          </p:nvPr>
+        </p:nvSpPr>
+        <p:spPr>
+          <a:xfrm>
+            <a:off x="0" y="0"/>
+            <a:ext cx="2971800" cy="458788"/>
+          </a:xfrm>
+          <a:prstGeom prst="rect">
+            <a:avLst/>
+          </a:prstGeom>
+        </p:spPr>
+        <p:txBody>
+          <a:bodyPr vert="horz" lIns="91440" tIns="45720" rIns="91440" bIns="45720" rtlCol="0"/>
+          <a:lstStyle>
+            <a:lvl1pPr algn="l">
+              <a:defRPr sz="1200"/>
+            </a:lvl1pPr>
+          </a:lstStyle>
+          <a:p>
+            <a:endParaRPr lang="en-US"/>
+          </a:p>
+        </p:txBody>
+      </p:sp>
+      <p:sp>
+        <p:nvSpPr>
+          <p:cNvPr id="3" name="Date Placeholder 2"/>
+          <p:cNvSpPr>
+            <a:spLocks noGrp="1"/>
+          </p:cNvSpPr>
+          <p:nvPr>
+            <p:ph type="dt" idx="1"/>
+          </p:nvPr>
+        </p:nvSpPr>
+        <p:spPr>
+          <a:xfrm>
+            <a:off x="3884613" y="0"/>
+            <a:ext cx="2971800" cy="458788"/>
+          </a:xfrm>
+          <a:prstGeom prst="rect">
+            <a:avLst/>
+          </a:prstGeom>
+        </p:spPr>
+        <p:txBody>
+          <a:bodyPr vert="horz" lIns="91440" tIns="45720" rIns="91440" bIns="45720" rtlCol="0"/>
+          <a:lstStyle>
+            <a:lvl1pPr algn="r">
+              <a:defRPr sz="1200"/>
+            </a:lvl1pPr>
+          </a:lstStyle>
+          <a:p>
+            <a:fld id="{94695DFB-DA12-417A-ABB9-527E670CCF3D}" type="datetimeFigureOut">
+              <a:rPr lang="en-US" smtClean="0"/>
+              <a:t>1/26/2026</a:t>
+            </a:fld>
+            <a:endParaRPr lang="en-US"/>
+          </a:p>
+        </p:txBody>
+      </p:sp>
+      <p:sp>
+        <p:nvSpPr>
+          <p:cNvPr id="4" name="Slide Image Placeholder 3"/>
+          <p:cNvSpPr>
+            <a:spLocks noGrp="1" noRot="1" noChangeAspect="1"/>
+          </p:cNvSpPr>
+          <p:nvPr>
+            <p:ph type="sldImg" idx="2"/>
+          </p:nvPr>
+        </p:nvSpPr>
+        <p:spPr>
+          <a:xfrm>
+            <a:off x="685800" y="1143000"/>
+            <a:ext cx="5486400" cy="3086100"/>
+          </a:xfrm>
+          <a:prstGeom prst="rect">
+            <a:avLst/>
+          </a:prstGeom>
+          <a:noFill/>
+          <a:ln w="12700">
+            <a:solidFill>
+              <a:prstClr val="black"/>
+            </a:solidFill>
+          </a:ln>
+        </p:spPr>
+        <p:txBody>
+          <a:bodyPr vert="horz" lIns="91440" tIns="45720" rIns="91440" bIns="45720" rtlCol="0" anchor="ctr"/>
+          <a:lstStyle/>
+          <a:p>
+            <a:endParaRPr lang="en-US"/>
+          </a:p>
+        </p:txBody>
+      </p:sp>
+      <p:sp>
+        <p:nvSpPr>
+          <p:cNvPr id="5" name="Notes Placeholder 4"/>
+          <p:cNvSpPr>
+            <a:spLocks noGrp="1"/>
+          </p:cNvSpPr>
+          <p:nvPr>
+            <p:ph type="body" sz="quarter" idx="3"/>
+          </p:nvPr>
+        </p:nvSpPr>
+        <p:spPr>
+          <a:xfrm>
+            <a:off x="685800" y="4400550"/>
+            <a:ext cx="5486400" cy="3600450"/>
+          </a:xfrm>
+          <a:prstGeom prst="rect">
+            <a:avLst/>
+          </a:prstGeom>
+        </p:spPr>
+        <p:txBody>
+          <a:bodyPr vert="horz" lIns="91440" tIns="45720" rIns="91440" bIns="45720" rtlCol="0"/>
+          <a:lstStyle/>
+          <a:p>
+            <a:pPr lvl="0"/>
+            <a:r>
+              <a:rPr lang="en-US"/>
+              <a:t>Click to edit Master text styles</a:t>
+            </a:r>
+          </a:p>
+          <a:p>
+            <a:pPr lvl="1"/>
+            <a:r>
+              <a:rPr lang="en-US"/>
+              <a:t>Second level</a:t>
+            </a:r>
+          </a:p>
+          <a:p>
+            <a:pPr lvl="2"/>
+            <a:r>
+              <a:rPr lang="en-US"/>
+              <a:t>Third level</a:t>
+            </a:r>
+          </a:p>
+          <a:p>
+            <a:pPr lvl="3"/>
+            <a:r>
+              <a:rPr lang="en-US"/>
+              <a:t>Fourth level</a:t>
+            </a:r>
+          </a:p>
+          <a:p>
+            <a:pPr lvl="4"/>
+            <a:r>
+              <a:rPr lang="en-US"/>
+              <a:t>Fifth level</a:t>
+            </a:r>
+          </a:p>
+        </p:txBody>
+      </p:sp>
+      <p:sp>
+        <p:nvSpPr>
+          <p:cNvPr id="6" name="Footer Placeholder 5"/>
+          <p:cNvSpPr>
+            <a:spLocks noGrp="1"/>
+          </p:cNvSpPr>
+          <p:nvPr>
+            <p:ph type="ftr" sz="quarter" idx="4"/>
+          </p:nvPr>
+        </p:nvSpPr>
+        <p:spPr>
+          <a:xfrm>
+            <a:off x="0" y="8685213"/>
+            <a:ext cx="2971800" cy="458787"/>
+          </a:xfrm>
+          <a:prstGeom prst="rect">
+            <a:avLst/>
+          </a:prstGeom>
+        </p:spPr>
+        <p:txBody>
+          <a:bodyPr vert="horz" lIns="91440" tIns="45720" rIns="91440" bIns="45720" rtlCol="0" anchor="b"/>
+          <a:lstStyle>
+            <a:lvl1pPr algn="l">
+              <a:defRPr sz="1200"/>
+            </a:lvl1pPr>
+          </a:lstStyle>
+          <a:p>
+            <a:endParaRPr lang="en-US"/>
+          </a:p>
+        </p:txBody>
+      </p:sp>
+      <p:sp>
+        <p:nvSpPr>
+          <p:cNvPr id="7" name="Slide Number Placeholder 6"/>
+          <p:cNvSpPr>
+            <a:spLocks noGrp="1"/>
+          </p:cNvSpPr>
+          <p:nvPr>
+            <p:ph type="sldNum" sz="quarter" idx="5"/>
+          </p:nvPr>
+        </p:nvSpPr>
+        <p:spPr>
+          <a:xfrm>
+            <a:off x="3884613" y="8685213"/>
+            <a:ext cx="2971800" cy="458787"/>
+          </a:xfrm>
+          <a:prstGeom prst="rect">
+            <a:avLst/>
+          </a:prstGeom>
+        </p:spPr>
+        <p:txBody>
+          <a:bodyPr vert="horz" lIns="91440" tIns="45720" rIns="91440" bIns="45720" rtlCol="0" anchor="b"/>
+          <a:lstStyle>
+            <a:lvl1pPr algn="r">
+              <a:defRPr sz="1200"/>
+            </a:lvl1pPr>
+          </a:lstStyle>
+          <a:p>
+            <a:fld id="{B591C2DA-F1BD-4D59-B843-77A045F87FD8}" type="slidenum">
+              <a:rPr lang="en-US" smtClean="0"/>
+              <a:t>‹#›</a:t>
+            </a:fld>
+            <a:endParaRPr lang="en-US"/>
+          </a:p>
+        </p:txBody>
+      </p:sp>
+    </p:spTree>
+    <p:extLst>
+      <p:ext uri="{BB962C8B-B14F-4D97-AF65-F5344CB8AC3E}">
+        <p14:creationId xmlns:p14="http://schemas.microsoft.com/office/powerpoint/2010/main" val="1092411454"/>
+      </p:ext>
+    </p:extLst>
+  </p:cSld>
+  <p:clrMap bg1="lt1" tx1="dk1" bg2="lt2" tx2="dk2" accent1="accent1" accent2="accent2" accent3="accent3" accent4="accent4" accent5="accent5" accent6="accent6" hlink="hlink" folHlink="folHlink"/>
+  <p:notesStyle>
+    <a:lvl1pPr marL="0" algn="l" defTabSz="914400" rtl="0" eaLnBrk="1" latinLnBrk="0" hangingPunct="1">
+      <a:defRPr sz="1200" kern="1200">
+        <a:solidFill>
+          <a:schemeClr val="tx1"/>
+        </a:solidFill>
+        <a:latin typeface="+mn-lt"/>
+        <a:ea typeface="+mn-ea"/>
+        <a:cs typeface="+mn-cs"/>
+      </a:defRPr>
+    </a:lvl1pPr>
+    <a:lvl2pPr marL="457200" algn="l" defTabSz="914400" rtl="0" eaLnBrk="1" latinLnBrk="0" hangingPunct="1">
+      <a:defRPr sz="1200" kern="1200">
+        <a:solidFill>
+          <a:schemeClr val="tx1"/>
+        </a:solidFill>
+        <a:latin typeface="+mn-lt"/>
+        <a:ea typeface="+mn-ea"/>
+        <a:cs typeface="+mn-cs"/>
+      </a:defRPr>
+    </a:lvl2pPr>
+    <a:lvl3pPr marL="914400" algn="l" defTabSz="914400" rtl="0" eaLnBrk="1" latinLnBrk="0" hangingPunct="1">
+      <a:defRPr sz="1200" kern="1200">
+        <a:solidFill>
+          <a:schemeClr val="tx1"/>
+        </a:solidFill>
+        <a:latin typeface="+mn-lt"/>
+        <a:ea typeface="+mn-ea"/>
+        <a:cs typeface="+mn-cs"/>
+      </a:defRPr>
+    </a:lvl3pPr>
+    <a:lvl4pPr marL="1371600" algn="l" defTabSz="914400" rtl="0" eaLnBrk="1" latinLnBrk="0" hangingPunct="1">
+      <a:defRPr sz="1200" kern="1200">
+        <a:solidFill>
+          <a:schemeClr val="tx1"/>
+        </a:solidFill>
+        <a:latin typeface="+mn-lt"/>
+        <a:ea typeface="+mn-ea"/>
+        <a:cs typeface="+mn-cs"/>
+      </a:defRPr>
+    </a:lvl4pPr>
+    <a:lvl5pPr marL="1828800" algn="l" defTabSz="914400" rtl="0" eaLnBrk="1" latinLnBrk="0" hangingPunct="1">
+      <a:defRPr sz="1200" kern="1200">
+        <a:solidFill>
+          <a:schemeClr val="tx1"/>
+        </a:solidFill>
+        <a:latin typeface="+mn-lt"/>
+        <a:ea typeface="+mn-ea"/>
+        <a:cs typeface="+mn-cs"/>
+      </a:defRPr>
+    </a:lvl5pPr>
+    <a:lvl6pPr marL="2286000" algn="l" defTabSz="914400" rtl="0" eaLnBrk="1" latinLnBrk="0" hangingPunct="1">
+      <a:defRPr sz="1200" kern="1200">
+        <a:solidFill>
+          <a:schemeClr val="tx1"/>
+        </a:solidFill>
+        <a:latin typeface="+mn-lt"/>
+        <a:ea typeface="+mn-ea"/>
+        <a:cs typeface="+mn-cs"/>
+      </a:defRPr>
+    </a:lvl6pPr>
+    <a:lvl7pPr marL="2743200" algn="l" defTabSz="914400" rtl="0" eaLnBrk="1" latinLnBrk="0" hangingPunct="1">
+      <a:defRPr sz="1200" kern="1200">
+        <a:solidFill>
+          <a:schemeClr val="tx1"/>
+        </a:solidFill>
+        <a:latin typeface="+mn-lt"/>
+        <a:ea typeface="+mn-ea"/>
+        <a:cs typeface="+mn-cs"/>
+      </a:defRPr>
+    </a:lvl7pPr>
+    <a:lvl8pPr marL="3200400" algn="l" defTabSz="914400" rtl="0" eaLnBrk="1" latinLnBrk="0" hangingPunct="1">
+      <a:defRPr sz="1200" kern="1200">
+        <a:solidFill>
+          <a:schemeClr val="tx1"/>
+        </a:solidFill>
+        <a:latin typeface="+mn-lt"/>
+        <a:ea typeface="+mn-ea"/>
+        <a:cs typeface="+mn-cs"/>
+      </a:defRPr>
+    </a:lvl8pPr>
+    <a:lvl9pPr marL="3657600" algn="l" defTabSz="914400" rtl="0" eaLnBrk="1" latinLnBrk="0" hangingPunct="1">
+      <a:defRPr sz="1200" kern="1200">
+        <a:solidFill>
+          <a:schemeClr val="tx1"/>
+        </a:solidFill>
+        <a:latin typeface="+mn-lt"/>
+        <a:ea typeface="+mn-ea"/>
+        <a:cs typeface="+mn-cs"/>
+      </a:defRPr>
+    </a:lvl9pPr>
+  </p:notesStyle>
+</p:notesMaster>
+</file>
+
+<file path=ppt/notesSlides/notesSlide1.xml><?xml version="1.0" encoding="utf-8"?>
+<p:notes xmlns:a="http://schemas.openxmlformats.org/drawingml/2006/main" xmlns:r="http://schemas.openxmlformats.org/officeDocument/2006/relationships" xmlns:p="http://schemas.openxmlformats.org/presentationml/2006/main">
+  <p:cSld>
+    <p:spTree>
+      <p:nvGrpSpPr>
+        <p:cNvPr id="1" name=""/>
+        <p:cNvGrpSpPr/>
+        <p:nvPr/>
+      </p:nvGrpSpPr>
+      <p:grpSpPr>
+        <a:xfrm>
+          <a:off x="0" y="0"/>
+          <a:ext cx="0" cy="0"/>
+          <a:chOff x="0" y="0"/>
+          <a:chExt cx="0" cy="0"/>
+        </a:xfrm>
+      </p:grpSpPr>
+      <p:sp>
+        <p:nvSpPr>
+          <p:cNvPr id="2" name="Slide Image Placeholder 1"/>
+          <p:cNvSpPr>
+            <a:spLocks noGrp="1" noRot="1" noChangeAspect="1"/>
+          </p:cNvSpPr>
+          <p:nvPr>
+            <p:ph type="sldImg"/>
+          </p:nvPr>
+        </p:nvSpPr>
+        <p:spPr/>
+      </p:sp>
+      <p:sp>
+        <p:nvSpPr>
+          <p:cNvPr id="3" name="Notes Placeholder 2"/>
+          <p:cNvSpPr>
+            <a:spLocks noGrp="1"/>
+          </p:cNvSpPr>
+          <p:nvPr>
+            <p:ph type="body" idx="1"/>
+          </p:nvPr>
+        </p:nvSpPr>
+        <p:spPr/>
+        <p:txBody>
+          <a:bodyPr/>
+          <a:lstStyle/>
+          <a:p>
+            <a:r>
+              <a:rPr lang="en-US" sz="1200" dirty="0"/>
+              <a:t>Download into R Studio the PlayerBBall.csv dataset. This data set is every NBA basketball player from 1950 to present.  It contains their height, weight, position and the year they played (among other data.) (Position: F-Forward, C-Centers, F-C and C-F – Forward /Centers, G – Guards, F-G – Forward/Guards)  FYI: If you feel that these questions are open ended or at least a little vague, this is on purpose.  Answer the question as you understand it and make any assumptions you need to make to answer the question and record those assumptions. (3-5 hours)</a:t>
+            </a:r>
+            <a:endParaRPr lang="en-US" dirty="0"/>
+          </a:p>
+        </p:txBody>
+      </p:sp>
+      <p:sp>
+        <p:nvSpPr>
+          <p:cNvPr id="4" name="Slide Number Placeholder 3"/>
+          <p:cNvSpPr>
+            <a:spLocks noGrp="1"/>
+          </p:cNvSpPr>
+          <p:nvPr>
+            <p:ph type="sldNum" sz="quarter" idx="5"/>
+          </p:nvPr>
+        </p:nvSpPr>
+        <p:spPr/>
+        <p:txBody>
+          <a:bodyPr/>
+          <a:lstStyle/>
+          <a:p>
+            <a:fld id="{B591C2DA-F1BD-4D59-B843-77A045F87FD8}" type="slidenum">
+              <a:rPr lang="en-US" smtClean="0"/>
+              <a:t>1</a:t>
+            </a:fld>
+            <a:endParaRPr lang="en-US"/>
+          </a:p>
+        </p:txBody>
+      </p:sp>
+    </p:spTree>
+    <p:extLst>
+      <p:ext uri="{BB962C8B-B14F-4D97-AF65-F5344CB8AC3E}">
+        <p14:creationId xmlns:p14="http://schemas.microsoft.com/office/powerpoint/2010/main" val="2772455782"/>
+      </p:ext>
+    </p:extLst>
+  </p:cSld>
+  <p:clrMapOvr>
+    <a:masterClrMapping/>
+  </p:clrMapOvr>
+</p:notes>
+</file>
+
+<file path=ppt/notesSlides/notesSlide10.xml><?xml version="1.0" encoding="utf-8"?>
+<p:notes xmlns:a="http://schemas.openxmlformats.org/drawingml/2006/main" xmlns:r="http://schemas.openxmlformats.org/officeDocument/2006/relationships" xmlns:p="http://schemas.openxmlformats.org/presentationml/2006/main">
+  <p:cSld>
+    <p:spTree>
+      <p:nvGrpSpPr>
+        <p:cNvPr id="1" name=""/>
+        <p:cNvGrpSpPr/>
+        <p:nvPr/>
+      </p:nvGrpSpPr>
+      <p:grpSpPr>
+        <a:xfrm>
+          <a:off x="0" y="0"/>
+          <a:ext cx="0" cy="0"/>
+          <a:chOff x="0" y="0"/>
+          <a:chExt cx="0" cy="0"/>
+        </a:xfrm>
+      </p:grpSpPr>
+      <p:sp>
+        <p:nvSpPr>
+          <p:cNvPr id="2" name="Slide Image Placeholder 1"/>
+          <p:cNvSpPr>
+            <a:spLocks noGrp="1" noRot="1" noChangeAspect="1"/>
+          </p:cNvSpPr>
+          <p:nvPr>
+            <p:ph type="sldImg"/>
+          </p:nvPr>
+        </p:nvSpPr>
+        <p:spPr/>
+      </p:sp>
+      <p:sp>
+        <p:nvSpPr>
+          <p:cNvPr id="3" name="Notes Placeholder 2"/>
+          <p:cNvSpPr>
+            <a:spLocks noGrp="1"/>
+          </p:cNvSpPr>
+          <p:nvPr>
+            <p:ph type="body" idx="1"/>
+          </p:nvPr>
+        </p:nvSpPr>
+        <p:spPr/>
+        <p:txBody>
+          <a:bodyPr/>
+          <a:lstStyle/>
+          <a:p>
+            <a:r>
+              <a:rPr lang="en-US" sz="1200" dirty="0"/>
+              <a:t>Go to this website and use one of the 50 best plots to visualize some aspect of the data and provide at least one insight.  You will present your work in breakout! </a:t>
+            </a:r>
+            <a:r>
+              <a:rPr lang="en-US" sz="1200" dirty="0">
+                <a:hlinkClick r:id="rId3"/>
+              </a:rPr>
+              <a:t>http://r-statistics.co/Top50-Ggplot2-Visualizations-MasterList-R-Code.html</a:t>
+            </a:r>
+            <a:endParaRPr lang="en-US" dirty="0"/>
+          </a:p>
+        </p:txBody>
+      </p:sp>
+      <p:sp>
+        <p:nvSpPr>
+          <p:cNvPr id="4" name="Slide Number Placeholder 3"/>
+          <p:cNvSpPr>
+            <a:spLocks noGrp="1"/>
+          </p:cNvSpPr>
+          <p:nvPr>
+            <p:ph type="sldNum" sz="quarter" idx="5"/>
+          </p:nvPr>
+        </p:nvSpPr>
+        <p:spPr/>
+        <p:txBody>
+          <a:bodyPr/>
+          <a:lstStyle/>
+          <a:p>
+            <a:fld id="{B591C2DA-F1BD-4D59-B843-77A045F87FD8}" type="slidenum">
+              <a:rPr lang="en-US" smtClean="0"/>
+              <a:t>13</a:t>
+            </a:fld>
+            <a:endParaRPr lang="en-US"/>
+          </a:p>
+        </p:txBody>
+      </p:sp>
+    </p:spTree>
+    <p:extLst>
+      <p:ext uri="{BB962C8B-B14F-4D97-AF65-F5344CB8AC3E}">
+        <p14:creationId xmlns:p14="http://schemas.microsoft.com/office/powerpoint/2010/main" val="1394687883"/>
+      </p:ext>
+    </p:extLst>
+  </p:cSld>
+  <p:clrMapOvr>
+    <a:masterClrMapping/>
+  </p:clrMapOvr>
+</p:notes>
+</file>
+
+<file path=ppt/notesSlides/notesSlide2.xml><?xml version="1.0" encoding="utf-8"?>
+<p:notes xmlns:a="http://schemas.openxmlformats.org/drawingml/2006/main" xmlns:r="http://schemas.openxmlformats.org/officeDocument/2006/relationships" xmlns:p="http://schemas.openxmlformats.org/presentationml/2006/main">
+  <p:cSld>
+    <p:spTree>
+      <p:nvGrpSpPr>
+        <p:cNvPr id="1" name=""/>
+        <p:cNvGrpSpPr/>
+        <p:nvPr/>
+      </p:nvGrpSpPr>
+      <p:grpSpPr>
+        <a:xfrm>
+          <a:off x="0" y="0"/>
+          <a:ext cx="0" cy="0"/>
+          <a:chOff x="0" y="0"/>
+          <a:chExt cx="0" cy="0"/>
+        </a:xfrm>
+      </p:grpSpPr>
+      <p:sp>
+        <p:nvSpPr>
+          <p:cNvPr id="2" name="Slide Image Placeholder 1"/>
+          <p:cNvSpPr>
+            <a:spLocks noGrp="1" noRot="1" noChangeAspect="1"/>
+          </p:cNvSpPr>
+          <p:nvPr>
+            <p:ph type="sldImg"/>
+          </p:nvPr>
+        </p:nvSpPr>
+        <p:spPr/>
+      </p:sp>
+      <p:sp>
+        <p:nvSpPr>
+          <p:cNvPr id="3" name="Notes Placeholder 2"/>
+          <p:cNvSpPr>
+            <a:spLocks noGrp="1"/>
+          </p:cNvSpPr>
+          <p:nvPr>
+            <p:ph type="body" idx="1"/>
+          </p:nvPr>
+        </p:nvSpPr>
+        <p:spPr/>
+        <p:txBody>
+          <a:bodyPr/>
+          <a:lstStyle/>
+          <a:p>
+            <a:r>
+              <a:rPr lang="en-US" dirty="0"/>
+              <a:t>Use the PlayerBBall.csv dataset to visually represent (summarize) the number of players in each position.</a:t>
+            </a:r>
+          </a:p>
+        </p:txBody>
+      </p:sp>
+      <p:sp>
+        <p:nvSpPr>
+          <p:cNvPr id="4" name="Slide Number Placeholder 3"/>
+          <p:cNvSpPr>
+            <a:spLocks noGrp="1"/>
+          </p:cNvSpPr>
+          <p:nvPr>
+            <p:ph type="sldNum" sz="quarter" idx="5"/>
+          </p:nvPr>
+        </p:nvSpPr>
+        <p:spPr/>
+        <p:txBody>
+          <a:bodyPr/>
+          <a:lstStyle/>
+          <a:p>
+            <a:fld id="{B591C2DA-F1BD-4D59-B843-77A045F87FD8}" type="slidenum">
+              <a:rPr lang="en-US" smtClean="0"/>
+              <a:t>2</a:t>
+            </a:fld>
+            <a:endParaRPr lang="en-US"/>
+          </a:p>
+        </p:txBody>
+      </p:sp>
+    </p:spTree>
+    <p:extLst>
+      <p:ext uri="{BB962C8B-B14F-4D97-AF65-F5344CB8AC3E}">
+        <p14:creationId xmlns:p14="http://schemas.microsoft.com/office/powerpoint/2010/main" val="2040258838"/>
+      </p:ext>
+    </p:extLst>
+  </p:cSld>
+  <p:clrMapOvr>
+    <a:masterClrMapping/>
+  </p:clrMapOvr>
+</p:notes>
+</file>
+
+<file path=ppt/notesSlides/notesSlide3.xml><?xml version="1.0" encoding="utf-8"?>
+<p:notes xmlns:a="http://schemas.openxmlformats.org/drawingml/2006/main" xmlns:r="http://schemas.openxmlformats.org/officeDocument/2006/relationships" xmlns:p="http://schemas.openxmlformats.org/presentationml/2006/main">
+  <p:cSld>
+    <p:spTree>
+      <p:nvGrpSpPr>
+        <p:cNvPr id="1" name=""/>
+        <p:cNvGrpSpPr/>
+        <p:nvPr/>
+      </p:nvGrpSpPr>
+      <p:grpSpPr>
+        <a:xfrm>
+          <a:off x="0" y="0"/>
+          <a:ext cx="0" cy="0"/>
+          <a:chOff x="0" y="0"/>
+          <a:chExt cx="0" cy="0"/>
+        </a:xfrm>
+      </p:grpSpPr>
+      <p:sp>
+        <p:nvSpPr>
+          <p:cNvPr id="2" name="Slide Image Placeholder 1"/>
+          <p:cNvSpPr>
+            <a:spLocks noGrp="1" noRot="1" noChangeAspect="1"/>
+          </p:cNvSpPr>
+          <p:nvPr>
+            <p:ph type="sldImg"/>
+          </p:nvPr>
+        </p:nvSpPr>
+        <p:spPr/>
+      </p:sp>
+      <p:sp>
+        <p:nvSpPr>
+          <p:cNvPr id="3" name="Notes Placeholder 2"/>
+          <p:cNvSpPr>
+            <a:spLocks noGrp="1"/>
+          </p:cNvSpPr>
+          <p:nvPr>
+            <p:ph type="body" idx="1"/>
+          </p:nvPr>
+        </p:nvSpPr>
+        <p:spPr/>
+        <p:txBody>
+          <a:bodyPr/>
+          <a:lstStyle/>
+          <a:p>
+            <a:r>
+              <a:rPr lang="en-US" dirty="0"/>
+              <a:t>Use the dataset to visually investigate the distribution of the weight of centers (C) is greater than the distribution of the weight of forwards (F).</a:t>
+            </a:r>
+          </a:p>
+        </p:txBody>
+      </p:sp>
+      <p:sp>
+        <p:nvSpPr>
+          <p:cNvPr id="4" name="Slide Number Placeholder 3"/>
+          <p:cNvSpPr>
+            <a:spLocks noGrp="1"/>
+          </p:cNvSpPr>
+          <p:nvPr>
+            <p:ph type="sldNum" sz="quarter" idx="5"/>
+          </p:nvPr>
+        </p:nvSpPr>
+        <p:spPr/>
+        <p:txBody>
+          <a:bodyPr/>
+          <a:lstStyle/>
+          <a:p>
+            <a:fld id="{B591C2DA-F1BD-4D59-B843-77A045F87FD8}" type="slidenum">
+              <a:rPr lang="en-US" smtClean="0"/>
+              <a:t>3</a:t>
+            </a:fld>
+            <a:endParaRPr lang="en-US"/>
+          </a:p>
+        </p:txBody>
+      </p:sp>
+    </p:spTree>
+    <p:extLst>
+      <p:ext uri="{BB962C8B-B14F-4D97-AF65-F5344CB8AC3E}">
+        <p14:creationId xmlns:p14="http://schemas.microsoft.com/office/powerpoint/2010/main" val="1511792227"/>
+      </p:ext>
+    </p:extLst>
+  </p:cSld>
+  <p:clrMapOvr>
+    <a:masterClrMapping/>
+  </p:clrMapOvr>
+</p:notes>
+</file>
+
+<file path=ppt/notesSlides/notesSlide4.xml><?xml version="1.0" encoding="utf-8"?>
+<p:notes xmlns:a="http://schemas.openxmlformats.org/drawingml/2006/main" xmlns:r="http://schemas.openxmlformats.org/officeDocument/2006/relationships" xmlns:p="http://schemas.openxmlformats.org/presentationml/2006/main">
+  <p:cSld>
+    <p:spTree>
+      <p:nvGrpSpPr>
+        <p:cNvPr id="1" name=""/>
+        <p:cNvGrpSpPr/>
+        <p:nvPr/>
+      </p:nvGrpSpPr>
+      <p:grpSpPr>
+        <a:xfrm>
+          <a:off x="0" y="0"/>
+          <a:ext cx="0" cy="0"/>
+          <a:chOff x="0" y="0"/>
+          <a:chExt cx="0" cy="0"/>
+        </a:xfrm>
+      </p:grpSpPr>
+      <p:sp>
+        <p:nvSpPr>
+          <p:cNvPr id="2" name="Slide Image Placeholder 1"/>
+          <p:cNvSpPr>
+            <a:spLocks noGrp="1" noRot="1" noChangeAspect="1"/>
+          </p:cNvSpPr>
+          <p:nvPr>
+            <p:ph type="sldImg"/>
+          </p:nvPr>
+        </p:nvSpPr>
+        <p:spPr/>
+      </p:sp>
+      <p:sp>
+        <p:nvSpPr>
+          <p:cNvPr id="3" name="Notes Placeholder 2"/>
+          <p:cNvSpPr>
+            <a:spLocks noGrp="1"/>
+          </p:cNvSpPr>
+          <p:nvPr>
+            <p:ph type="body" idx="1"/>
+          </p:nvPr>
+        </p:nvSpPr>
+        <p:spPr/>
+        <p:txBody>
+          <a:bodyPr/>
+          <a:lstStyle/>
+          <a:p>
+            <a:r>
+              <a:rPr lang="en-US" dirty="0"/>
+              <a:t>Use the dataset to visually investigate if the distribution of the height of centers (C) is greater than the distribution of the height of forwards (F).</a:t>
+            </a:r>
+          </a:p>
+        </p:txBody>
+      </p:sp>
+      <p:sp>
+        <p:nvSpPr>
+          <p:cNvPr id="4" name="Slide Number Placeholder 3"/>
+          <p:cNvSpPr>
+            <a:spLocks noGrp="1"/>
+          </p:cNvSpPr>
+          <p:nvPr>
+            <p:ph type="sldNum" sz="quarter" idx="5"/>
+          </p:nvPr>
+        </p:nvSpPr>
+        <p:spPr/>
+        <p:txBody>
+          <a:bodyPr/>
+          <a:lstStyle/>
+          <a:p>
+            <a:fld id="{B591C2DA-F1BD-4D59-B843-77A045F87FD8}" type="slidenum">
+              <a:rPr lang="en-US" smtClean="0"/>
+              <a:t>4</a:t>
+            </a:fld>
+            <a:endParaRPr lang="en-US"/>
+          </a:p>
+        </p:txBody>
+      </p:sp>
+    </p:spTree>
+    <p:extLst>
+      <p:ext uri="{BB962C8B-B14F-4D97-AF65-F5344CB8AC3E}">
+        <p14:creationId xmlns:p14="http://schemas.microsoft.com/office/powerpoint/2010/main" val="1183841345"/>
+      </p:ext>
+    </p:extLst>
+  </p:cSld>
+  <p:clrMapOvr>
+    <a:masterClrMapping/>
+  </p:clrMapOvr>
+</p:notes>
+</file>
+
+<file path=ppt/notesSlides/notesSlide5.xml><?xml version="1.0" encoding="utf-8"?>
+<p:notes xmlns:a="http://schemas.openxmlformats.org/drawingml/2006/main" xmlns:r="http://schemas.openxmlformats.org/officeDocument/2006/relationships" xmlns:p="http://schemas.openxmlformats.org/presentationml/2006/main">
+  <p:cSld>
+    <p:spTree>
+      <p:nvGrpSpPr>
+        <p:cNvPr id="1" name=""/>
+        <p:cNvGrpSpPr/>
+        <p:nvPr/>
+      </p:nvGrpSpPr>
+      <p:grpSpPr>
+        <a:xfrm>
+          <a:off x="0" y="0"/>
+          <a:ext cx="0" cy="0"/>
+          <a:chOff x="0" y="0"/>
+          <a:chExt cx="0" cy="0"/>
+        </a:xfrm>
+      </p:grpSpPr>
+      <p:sp>
+        <p:nvSpPr>
+          <p:cNvPr id="2" name="Slide Image Placeholder 1"/>
+          <p:cNvSpPr>
+            <a:spLocks noGrp="1" noRot="1" noChangeAspect="1"/>
+          </p:cNvSpPr>
+          <p:nvPr>
+            <p:ph type="sldImg"/>
+          </p:nvPr>
+        </p:nvSpPr>
+        <p:spPr/>
+      </p:sp>
+      <p:sp>
+        <p:nvSpPr>
+          <p:cNvPr id="3" name="Notes Placeholder 2"/>
+          <p:cNvSpPr>
+            <a:spLocks noGrp="1"/>
+          </p:cNvSpPr>
+          <p:nvPr>
+            <p:ph type="body" idx="1"/>
+          </p:nvPr>
+        </p:nvSpPr>
+        <p:spPr/>
+        <p:txBody>
+          <a:bodyPr/>
+          <a:lstStyle/>
+          <a:p>
+            <a:r>
+              <a:rPr lang="en-US" dirty="0"/>
+              <a:t>Use the dataset to visually investigate if the distribution of height is different between </a:t>
+            </a:r>
+            <a:r>
+              <a:rPr lang="en-US" i="1" dirty="0"/>
+              <a:t>any </a:t>
+            </a:r>
+            <a:r>
+              <a:rPr lang="en-US" dirty="0"/>
+              <a:t>of the positions.</a:t>
+            </a:r>
+          </a:p>
+        </p:txBody>
+      </p:sp>
+      <p:sp>
+        <p:nvSpPr>
+          <p:cNvPr id="4" name="Slide Number Placeholder 3"/>
+          <p:cNvSpPr>
+            <a:spLocks noGrp="1"/>
+          </p:cNvSpPr>
+          <p:nvPr>
+            <p:ph type="sldNum" sz="quarter" idx="5"/>
+          </p:nvPr>
+        </p:nvSpPr>
+        <p:spPr/>
+        <p:txBody>
+          <a:bodyPr/>
+          <a:lstStyle/>
+          <a:p>
+            <a:fld id="{B591C2DA-F1BD-4D59-B843-77A045F87FD8}" type="slidenum">
+              <a:rPr lang="en-US" smtClean="0"/>
+              <a:t>7</a:t>
+            </a:fld>
+            <a:endParaRPr lang="en-US"/>
+          </a:p>
+        </p:txBody>
+      </p:sp>
+    </p:spTree>
+    <p:extLst>
+      <p:ext uri="{BB962C8B-B14F-4D97-AF65-F5344CB8AC3E}">
+        <p14:creationId xmlns:p14="http://schemas.microsoft.com/office/powerpoint/2010/main" val="3759618905"/>
+      </p:ext>
+    </p:extLst>
+  </p:cSld>
+  <p:clrMapOvr>
+    <a:masterClrMapping/>
+  </p:clrMapOvr>
+</p:notes>
+</file>
+
+<file path=ppt/notesSlides/notesSlide6.xml><?xml version="1.0" encoding="utf-8"?>
+<p:notes xmlns:a="http://schemas.openxmlformats.org/drawingml/2006/main" xmlns:r="http://schemas.openxmlformats.org/officeDocument/2006/relationships" xmlns:p="http://schemas.openxmlformats.org/presentationml/2006/main">
+  <p:cSld>
+    <p:spTree>
+      <p:nvGrpSpPr>
+        <p:cNvPr id="1" name=""/>
+        <p:cNvGrpSpPr/>
+        <p:nvPr/>
+      </p:nvGrpSpPr>
+      <p:grpSpPr>
+        <a:xfrm>
+          <a:off x="0" y="0"/>
+          <a:ext cx="0" cy="0"/>
+          <a:chOff x="0" y="0"/>
+          <a:chExt cx="0" cy="0"/>
+        </a:xfrm>
+      </p:grpSpPr>
+      <p:sp>
+        <p:nvSpPr>
+          <p:cNvPr id="2" name="Slide Image Placeholder 1"/>
+          <p:cNvSpPr>
+            <a:spLocks noGrp="1" noRot="1" noChangeAspect="1"/>
+          </p:cNvSpPr>
+          <p:nvPr>
+            <p:ph type="sldImg"/>
+          </p:nvPr>
+        </p:nvSpPr>
+        <p:spPr/>
+      </p:sp>
+      <p:sp>
+        <p:nvSpPr>
+          <p:cNvPr id="3" name="Notes Placeholder 2"/>
+          <p:cNvSpPr>
+            <a:spLocks noGrp="1"/>
+          </p:cNvSpPr>
+          <p:nvPr>
+            <p:ph type="body" idx="1"/>
+          </p:nvPr>
+        </p:nvSpPr>
+        <p:spPr/>
+        <p:txBody>
+          <a:bodyPr/>
+          <a:lstStyle/>
+          <a:p>
+            <a:r>
+              <a:rPr lang="en-US" dirty="0"/>
+              <a:t>Use the dataset to investigate how the player’s height is related to the player’s weight. How does height change as the weight changes?</a:t>
+            </a:r>
+          </a:p>
+        </p:txBody>
+      </p:sp>
+      <p:sp>
+        <p:nvSpPr>
+          <p:cNvPr id="4" name="Slide Number Placeholder 3"/>
+          <p:cNvSpPr>
+            <a:spLocks noGrp="1"/>
+          </p:cNvSpPr>
+          <p:nvPr>
+            <p:ph type="sldNum" sz="quarter" idx="5"/>
+          </p:nvPr>
+        </p:nvSpPr>
+        <p:spPr/>
+        <p:txBody>
+          <a:bodyPr/>
+          <a:lstStyle/>
+          <a:p>
+            <a:fld id="{B591C2DA-F1BD-4D59-B843-77A045F87FD8}" type="slidenum">
+              <a:rPr lang="en-US" smtClean="0"/>
+              <a:t>9</a:t>
+            </a:fld>
+            <a:endParaRPr lang="en-US"/>
+          </a:p>
+        </p:txBody>
+      </p:sp>
+    </p:spTree>
+    <p:extLst>
+      <p:ext uri="{BB962C8B-B14F-4D97-AF65-F5344CB8AC3E}">
+        <p14:creationId xmlns:p14="http://schemas.microsoft.com/office/powerpoint/2010/main" val="2189129594"/>
+      </p:ext>
+    </p:extLst>
+  </p:cSld>
+  <p:clrMapOvr>
+    <a:masterClrMapping/>
+  </p:clrMapOvr>
+</p:notes>
+</file>
+
+<file path=ppt/notesSlides/notesSlide7.xml><?xml version="1.0" encoding="utf-8"?>
+<p:notes xmlns:a="http://schemas.openxmlformats.org/drawingml/2006/main" xmlns:r="http://schemas.openxmlformats.org/officeDocument/2006/relationships" xmlns:p="http://schemas.openxmlformats.org/presentationml/2006/main">
+  <p:cSld>
+    <p:spTree>
+      <p:nvGrpSpPr>
+        <p:cNvPr id="1" name=""/>
+        <p:cNvGrpSpPr/>
+        <p:nvPr/>
+      </p:nvGrpSpPr>
+      <p:grpSpPr>
+        <a:xfrm>
+          <a:off x="0" y="0"/>
+          <a:ext cx="0" cy="0"/>
+          <a:chOff x="0" y="0"/>
+          <a:chExt cx="0" cy="0"/>
+        </a:xfrm>
+      </p:grpSpPr>
+      <p:sp>
+        <p:nvSpPr>
+          <p:cNvPr id="2" name="Slide Image Placeholder 1"/>
+          <p:cNvSpPr>
+            <a:spLocks noGrp="1" noRot="1" noChangeAspect="1"/>
+          </p:cNvSpPr>
+          <p:nvPr>
+            <p:ph type="sldImg"/>
+          </p:nvPr>
+        </p:nvSpPr>
+        <p:spPr/>
+      </p:sp>
+      <p:sp>
+        <p:nvSpPr>
+          <p:cNvPr id="3" name="Notes Placeholder 2"/>
+          <p:cNvSpPr>
+            <a:spLocks noGrp="1"/>
+          </p:cNvSpPr>
+          <p:nvPr>
+            <p:ph type="body" idx="1"/>
+          </p:nvPr>
+        </p:nvSpPr>
+        <p:spPr/>
+        <p:txBody>
+          <a:bodyPr/>
+          <a:lstStyle/>
+          <a:p>
+            <a:r>
+              <a:rPr lang="en-US" dirty="0"/>
+              <a:t>Is their any difference in the relationship between height and weight between positions?  Are height and weight related differently for different positions.</a:t>
+            </a:r>
+          </a:p>
+        </p:txBody>
+      </p:sp>
+      <p:sp>
+        <p:nvSpPr>
+          <p:cNvPr id="4" name="Slide Number Placeholder 3"/>
+          <p:cNvSpPr>
+            <a:spLocks noGrp="1"/>
+          </p:cNvSpPr>
+          <p:nvPr>
+            <p:ph type="sldNum" sz="quarter" idx="5"/>
+          </p:nvPr>
+        </p:nvSpPr>
+        <p:spPr/>
+        <p:txBody>
+          <a:bodyPr/>
+          <a:lstStyle/>
+          <a:p>
+            <a:fld id="{B591C2DA-F1BD-4D59-B843-77A045F87FD8}" type="slidenum">
+              <a:rPr lang="en-US" smtClean="0"/>
+              <a:t>10</a:t>
+            </a:fld>
+            <a:endParaRPr lang="en-US"/>
+          </a:p>
+        </p:txBody>
+      </p:sp>
+    </p:spTree>
+    <p:extLst>
+      <p:ext uri="{BB962C8B-B14F-4D97-AF65-F5344CB8AC3E}">
+        <p14:creationId xmlns:p14="http://schemas.microsoft.com/office/powerpoint/2010/main" val="2471206858"/>
+      </p:ext>
+    </p:extLst>
+  </p:cSld>
+  <p:clrMapOvr>
+    <a:masterClrMapping/>
+  </p:clrMapOvr>
+</p:notes>
+</file>
+
+<file path=ppt/notesSlides/notesSlide8.xml><?xml version="1.0" encoding="utf-8"?>
+<p:notes xmlns:a="http://schemas.openxmlformats.org/drawingml/2006/main" xmlns:r="http://schemas.openxmlformats.org/officeDocument/2006/relationships" xmlns:p="http://schemas.openxmlformats.org/presentationml/2006/main">
+  <p:cSld>
+    <p:spTree>
+      <p:nvGrpSpPr>
+        <p:cNvPr id="1" name=""/>
+        <p:cNvGrpSpPr/>
+        <p:nvPr/>
+      </p:nvGrpSpPr>
+      <p:grpSpPr>
+        <a:xfrm>
+          <a:off x="0" y="0"/>
+          <a:ext cx="0" cy="0"/>
+          <a:chOff x="0" y="0"/>
+          <a:chExt cx="0" cy="0"/>
+        </a:xfrm>
+      </p:grpSpPr>
+      <p:sp>
+        <p:nvSpPr>
+          <p:cNvPr id="2" name="Slide Image Placeholder 1"/>
+          <p:cNvSpPr>
+            <a:spLocks noGrp="1" noRot="1" noChangeAspect="1"/>
+          </p:cNvSpPr>
+          <p:nvPr>
+            <p:ph type="sldImg"/>
+          </p:nvPr>
+        </p:nvSpPr>
+        <p:spPr/>
+      </p:sp>
+      <p:sp>
+        <p:nvSpPr>
+          <p:cNvPr id="3" name="Notes Placeholder 2"/>
+          <p:cNvSpPr>
+            <a:spLocks noGrp="1"/>
+          </p:cNvSpPr>
+          <p:nvPr>
+            <p:ph type="body" idx="1"/>
+          </p:nvPr>
+        </p:nvSpPr>
+        <p:spPr/>
+        <p:txBody>
+          <a:bodyPr/>
+          <a:lstStyle/>
+          <a:p>
+            <a:r>
+              <a:rPr lang="en-US" dirty="0"/>
+              <a:t>A historian would like to investigate the claim that the heights of players have increased over the years.  Analyze this claim graphically / visually.</a:t>
+            </a:r>
+          </a:p>
+        </p:txBody>
+      </p:sp>
+      <p:sp>
+        <p:nvSpPr>
+          <p:cNvPr id="4" name="Slide Number Placeholder 3"/>
+          <p:cNvSpPr>
+            <a:spLocks noGrp="1"/>
+          </p:cNvSpPr>
+          <p:nvPr>
+            <p:ph type="sldNum" sz="quarter" idx="5"/>
+          </p:nvPr>
+        </p:nvSpPr>
+        <p:spPr/>
+        <p:txBody>
+          <a:bodyPr/>
+          <a:lstStyle/>
+          <a:p>
+            <a:fld id="{B591C2DA-F1BD-4D59-B843-77A045F87FD8}" type="slidenum">
+              <a:rPr lang="en-US" smtClean="0"/>
+              <a:t>11</a:t>
+            </a:fld>
+            <a:endParaRPr lang="en-US"/>
+          </a:p>
+        </p:txBody>
+      </p:sp>
+    </p:spTree>
+    <p:extLst>
+      <p:ext uri="{BB962C8B-B14F-4D97-AF65-F5344CB8AC3E}">
+        <p14:creationId xmlns:p14="http://schemas.microsoft.com/office/powerpoint/2010/main" val="144509258"/>
+      </p:ext>
+    </p:extLst>
+  </p:cSld>
+  <p:clrMapOvr>
+    <a:masterClrMapping/>
+  </p:clrMapOvr>
+</p:notes>
+</file>
+
+<file path=ppt/notesSlides/notesSlide9.xml><?xml version="1.0" encoding="utf-8"?>
+<p:notes xmlns:a="http://schemas.openxmlformats.org/drawingml/2006/main" xmlns:r="http://schemas.openxmlformats.org/officeDocument/2006/relationships" xmlns:p="http://schemas.openxmlformats.org/presentationml/2006/main">
+  <p:cSld>
+    <p:spTree>
+      <p:nvGrpSpPr>
+        <p:cNvPr id="1" name=""/>
+        <p:cNvGrpSpPr/>
+        <p:nvPr/>
+      </p:nvGrpSpPr>
+      <p:grpSpPr>
+        <a:xfrm>
+          <a:off x="0" y="0"/>
+          <a:ext cx="0" cy="0"/>
+          <a:chOff x="0" y="0"/>
+          <a:chExt cx="0" cy="0"/>
+        </a:xfrm>
+      </p:grpSpPr>
+      <p:sp>
+        <p:nvSpPr>
+          <p:cNvPr id="2" name="Slide Image Placeholder 1"/>
+          <p:cNvSpPr>
+            <a:spLocks noGrp="1" noRot="1" noChangeAspect="1"/>
+          </p:cNvSpPr>
+          <p:nvPr>
+            <p:ph type="sldImg"/>
+          </p:nvPr>
+        </p:nvSpPr>
+        <p:spPr/>
+      </p:sp>
+      <p:sp>
+        <p:nvSpPr>
+          <p:cNvPr id="3" name="Notes Placeholder 2"/>
+          <p:cNvSpPr>
+            <a:spLocks noGrp="1"/>
+          </p:cNvSpPr>
+          <p:nvPr>
+            <p:ph type="body" idx="1"/>
+          </p:nvPr>
+        </p:nvSpPr>
+        <p:spPr/>
+        <p:txBody>
+          <a:bodyPr/>
+          <a:lstStyle/>
+          <a:p>
+            <a:r>
+              <a:rPr lang="en-US" dirty="0"/>
+              <a:t>Create a 3D plot of height vs. weight vs. year and color code the points by position.</a:t>
+            </a:r>
+          </a:p>
+        </p:txBody>
+      </p:sp>
+      <p:sp>
+        <p:nvSpPr>
+          <p:cNvPr id="4" name="Slide Number Placeholder 3"/>
+          <p:cNvSpPr>
+            <a:spLocks noGrp="1"/>
+          </p:cNvSpPr>
+          <p:nvPr>
+            <p:ph type="sldNum" sz="quarter" idx="5"/>
+          </p:nvPr>
+        </p:nvSpPr>
+        <p:spPr/>
+        <p:txBody>
+          <a:bodyPr/>
+          <a:lstStyle/>
+          <a:p>
+            <a:fld id="{B591C2DA-F1BD-4D59-B843-77A045F87FD8}" type="slidenum">
+              <a:rPr lang="en-US" smtClean="0"/>
+              <a:t>12</a:t>
+            </a:fld>
+            <a:endParaRPr lang="en-US"/>
+          </a:p>
+        </p:txBody>
+      </p:sp>
+    </p:spTree>
+    <p:extLst>
+      <p:ext uri="{BB962C8B-B14F-4D97-AF65-F5344CB8AC3E}">
+        <p14:creationId xmlns:p14="http://schemas.microsoft.com/office/powerpoint/2010/main" val="182059589"/>
+      </p:ext>
+    </p:extLst>
+  </p:cSld>
+  <p:clrMapOvr>
+    <a:masterClrMapping/>
+  </p:clrMapOvr>
+</p:notes>
 </file>
 
 <file path=ppt/slideLayouts/slideLayout1.xml><?xml version="1.0" encoding="utf-8"?>
@@ -312,7 +1532,7 @@
           <a:p>
             <a:fld id="{A095E84C-799E-434B-B555-A2CE91254D07}" type="datetimeFigureOut">
               <a:rPr lang="en-US" smtClean="0"/>
-              <a:t>1/25/2026</a:t>
+              <a:t>1/26/2026</a:t>
             </a:fld>
             <a:endParaRPr lang="en-US"/>
           </a:p>
@@ -510,7 +1730,7 @@
           <a:p>
             <a:fld id="{A095E84C-799E-434B-B555-A2CE91254D07}" type="datetimeFigureOut">
               <a:rPr lang="en-US" smtClean="0"/>
-              <a:t>1/25/2026</a:t>
+              <a:t>1/26/2026</a:t>
             </a:fld>
             <a:endParaRPr lang="en-US"/>
           </a:p>
@@ -718,7 +1938,7 @@
           <a:p>
             <a:fld id="{A095E84C-799E-434B-B555-A2CE91254D07}" type="datetimeFigureOut">
               <a:rPr lang="en-US" smtClean="0"/>
-              <a:t>1/25/2026</a:t>
+              <a:t>1/26/2026</a:t>
             </a:fld>
             <a:endParaRPr lang="en-US"/>
           </a:p>
@@ -916,7 +2136,7 @@
           <a:p>
             <a:fld id="{A095E84C-799E-434B-B555-A2CE91254D07}" type="datetimeFigureOut">
               <a:rPr lang="en-US" smtClean="0"/>
-              <a:t>1/25/2026</a:t>
+              <a:t>1/26/2026</a:t>
             </a:fld>
             <a:endParaRPr lang="en-US"/>
           </a:p>
@@ -1191,7 +2411,7 @@
           <a:p>
             <a:fld id="{A095E84C-799E-434B-B555-A2CE91254D07}" type="datetimeFigureOut">
               <a:rPr lang="en-US" smtClean="0"/>
-              <a:t>1/25/2026</a:t>
+              <a:t>1/26/2026</a:t>
             </a:fld>
             <a:endParaRPr lang="en-US"/>
           </a:p>
@@ -1456,7 +2676,7 @@
           <a:p>
             <a:fld id="{A095E84C-799E-434B-B555-A2CE91254D07}" type="datetimeFigureOut">
               <a:rPr lang="en-US" smtClean="0"/>
-              <a:t>1/25/2026</a:t>
+              <a:t>1/26/2026</a:t>
             </a:fld>
             <a:endParaRPr lang="en-US"/>
           </a:p>
@@ -1868,7 +3088,7 @@
           <a:p>
             <a:fld id="{A095E84C-799E-434B-B555-A2CE91254D07}" type="datetimeFigureOut">
               <a:rPr lang="en-US" smtClean="0"/>
-              <a:t>1/25/2026</a:t>
+              <a:t>1/26/2026</a:t>
             </a:fld>
             <a:endParaRPr lang="en-US"/>
           </a:p>
@@ -2009,7 +3229,7 @@
           <a:p>
             <a:fld id="{A095E84C-799E-434B-B555-A2CE91254D07}" type="datetimeFigureOut">
               <a:rPr lang="en-US" smtClean="0"/>
-              <a:t>1/25/2026</a:t>
+              <a:t>1/26/2026</a:t>
             </a:fld>
             <a:endParaRPr lang="en-US"/>
           </a:p>
@@ -2122,7 +3342,7 @@
           <a:p>
             <a:fld id="{A095E84C-799E-434B-B555-A2CE91254D07}" type="datetimeFigureOut">
               <a:rPr lang="en-US" smtClean="0"/>
-              <a:t>1/25/2026</a:t>
+              <a:t>1/26/2026</a:t>
             </a:fld>
             <a:endParaRPr lang="en-US"/>
           </a:p>
@@ -2433,7 +3653,7 @@
           <a:p>
             <a:fld id="{A095E84C-799E-434B-B555-A2CE91254D07}" type="datetimeFigureOut">
               <a:rPr lang="en-US" smtClean="0"/>
-              <a:t>1/25/2026</a:t>
+              <a:t>1/26/2026</a:t>
             </a:fld>
             <a:endParaRPr lang="en-US"/>
           </a:p>
@@ -2721,7 +3941,7 @@
           <a:p>
             <a:fld id="{A095E84C-799E-434B-B555-A2CE91254D07}" type="datetimeFigureOut">
               <a:rPr lang="en-US" smtClean="0"/>
-              <a:t>1/25/2026</a:t>
+              <a:t>1/26/2026</a:t>
             </a:fld>
             <a:endParaRPr lang="en-US"/>
           </a:p>
@@ -2962,7 +4182,7 @@
           <a:p>
             <a:fld id="{A095E84C-799E-434B-B555-A2CE91254D07}" type="datetimeFigureOut">
               <a:rPr lang="en-US" smtClean="0"/>
-              <a:t>1/25/2026</a:t>
+              <a:t>1/26/2026</a:t>
             </a:fld>
             <a:endParaRPr lang="en-US"/>
           </a:p>
@@ -3434,6 +4654,10 @@
             </a:r>
           </a:p>
           <a:p>
+            <a:r>
+              <a:rPr lang="en-US"/>
+              <a:t>1/26/2026</a:t>
+            </a:r>
             <a:endParaRPr lang="en-US" dirty="0"/>
           </a:p>
         </p:txBody>
@@ -3452,6 +4676,1095 @@
 </file>
 
 <file path=ppt/slides/slide10.xml><?xml version="1.0" encoding="utf-8"?>
+<p:sld xmlns:a="http://schemas.openxmlformats.org/drawingml/2006/main" xmlns:r="http://schemas.openxmlformats.org/officeDocument/2006/relationships" xmlns:p="http://schemas.openxmlformats.org/presentationml/2006/main">
+  <p:cSld>
+    <p:spTree>
+      <p:nvGrpSpPr>
+        <p:cNvPr id="1" name=""/>
+        <p:cNvGrpSpPr/>
+        <p:nvPr/>
+      </p:nvGrpSpPr>
+      <p:grpSpPr>
+        <a:xfrm>
+          <a:off x="0" y="0"/>
+          <a:ext cx="0" cy="0"/>
+          <a:chOff x="0" y="0"/>
+          <a:chExt cx="0" cy="0"/>
+        </a:xfrm>
+      </p:grpSpPr>
+      <p:pic>
+        <p:nvPicPr>
+          <p:cNvPr id="4" name="Picture 3">
+            <a:extLst>
+              <a:ext uri="{FF2B5EF4-FFF2-40B4-BE49-F238E27FC236}">
+                <a16:creationId xmlns:a16="http://schemas.microsoft.com/office/drawing/2014/main" id="{5392273D-FD59-CD29-858C-E8EF9E0F796C}"/>
+              </a:ext>
+            </a:extLst>
+          </p:cNvPr>
+          <p:cNvPicPr>
+            <a:picLocks noChangeAspect="1"/>
+          </p:cNvPicPr>
+          <p:nvPr/>
+        </p:nvPicPr>
+        <p:blipFill>
+          <a:blip r:embed="rId3"/>
+          <a:stretch>
+            <a:fillRect/>
+          </a:stretch>
+        </p:blipFill>
+        <p:spPr>
+          <a:xfrm>
+            <a:off x="465939" y="383460"/>
+            <a:ext cx="5630061" cy="1495634"/>
+          </a:xfrm>
+          <a:prstGeom prst="rect">
+            <a:avLst/>
+          </a:prstGeom>
+        </p:spPr>
+      </p:pic>
+      <p:pic>
+        <p:nvPicPr>
+          <p:cNvPr id="6" name="Picture 5">
+            <a:extLst>
+              <a:ext uri="{FF2B5EF4-FFF2-40B4-BE49-F238E27FC236}">
+                <a16:creationId xmlns:a16="http://schemas.microsoft.com/office/drawing/2014/main" id="{CE8F9093-49AF-39F8-8277-C829D4761C4B}"/>
+              </a:ext>
+            </a:extLst>
+          </p:cNvPr>
+          <p:cNvPicPr>
+            <a:picLocks noChangeAspect="1"/>
+          </p:cNvPicPr>
+          <p:nvPr/>
+        </p:nvPicPr>
+        <p:blipFill>
+          <a:blip r:embed="rId4"/>
+          <a:stretch>
+            <a:fillRect/>
+          </a:stretch>
+        </p:blipFill>
+        <p:spPr>
+          <a:xfrm>
+            <a:off x="305440" y="2031493"/>
+            <a:ext cx="6563641" cy="4582164"/>
+          </a:xfrm>
+          <a:prstGeom prst="rect">
+            <a:avLst/>
+          </a:prstGeom>
+        </p:spPr>
+      </p:pic>
+      <p:pic>
+        <p:nvPicPr>
+          <p:cNvPr id="3" name="Picture 2">
+            <a:extLst>
+              <a:ext uri="{FF2B5EF4-FFF2-40B4-BE49-F238E27FC236}">
+                <a16:creationId xmlns:a16="http://schemas.microsoft.com/office/drawing/2014/main" id="{70445D4C-4D47-8629-DF24-E596C4457EA5}"/>
+              </a:ext>
+            </a:extLst>
+          </p:cNvPr>
+          <p:cNvPicPr>
+            <a:picLocks noChangeAspect="1"/>
+          </p:cNvPicPr>
+          <p:nvPr/>
+        </p:nvPicPr>
+        <p:blipFill>
+          <a:blip r:embed="rId5"/>
+          <a:stretch>
+            <a:fillRect/>
+          </a:stretch>
+        </p:blipFill>
+        <p:spPr>
+          <a:xfrm>
+            <a:off x="6161236" y="772655"/>
+            <a:ext cx="5725324" cy="1800476"/>
+          </a:xfrm>
+          <a:prstGeom prst="rect">
+            <a:avLst/>
+          </a:prstGeom>
+        </p:spPr>
+      </p:pic>
+      <p:pic>
+        <p:nvPicPr>
+          <p:cNvPr id="7" name="Picture 6">
+            <a:extLst>
+              <a:ext uri="{FF2B5EF4-FFF2-40B4-BE49-F238E27FC236}">
+                <a16:creationId xmlns:a16="http://schemas.microsoft.com/office/drawing/2014/main" id="{7D247A11-6A41-1C79-0931-CB1F201BC074}"/>
+              </a:ext>
+            </a:extLst>
+          </p:cNvPr>
+          <p:cNvPicPr>
+            <a:picLocks noChangeAspect="1"/>
+          </p:cNvPicPr>
+          <p:nvPr/>
+        </p:nvPicPr>
+        <p:blipFill>
+          <a:blip r:embed="rId6"/>
+          <a:stretch>
+            <a:fillRect/>
+          </a:stretch>
+        </p:blipFill>
+        <p:spPr>
+          <a:xfrm>
+            <a:off x="6096000" y="2649330"/>
+            <a:ext cx="5725324" cy="3964327"/>
+          </a:xfrm>
+          <a:prstGeom prst="rect">
+            <a:avLst/>
+          </a:prstGeom>
+        </p:spPr>
+      </p:pic>
+      <p:sp>
+        <p:nvSpPr>
+          <p:cNvPr id="8" name="TextBox 7">
+            <a:extLst>
+              <a:ext uri="{FF2B5EF4-FFF2-40B4-BE49-F238E27FC236}">
+                <a16:creationId xmlns:a16="http://schemas.microsoft.com/office/drawing/2014/main" id="{36081247-D337-28E1-ABD1-82DDC602ABEA}"/>
+              </a:ext>
+            </a:extLst>
+          </p:cNvPr>
+          <p:cNvSpPr txBox="1"/>
+          <p:nvPr/>
+        </p:nvSpPr>
+        <p:spPr>
+          <a:xfrm>
+            <a:off x="6260123" y="126324"/>
+            <a:ext cx="5626437" cy="646331"/>
+          </a:xfrm>
+          <a:prstGeom prst="rect">
+            <a:avLst/>
+          </a:prstGeom>
+          <a:noFill/>
+          <a:ln>
+            <a:solidFill>
+              <a:schemeClr val="tx1"/>
+            </a:solidFill>
+          </a:ln>
+        </p:spPr>
+        <p:txBody>
+          <a:bodyPr wrap="square" rtlCol="0">
+            <a:spAutoFit/>
+          </a:bodyPr>
+          <a:lstStyle/>
+          <a:p>
+            <a:r>
+              <a:rPr lang="en-US" dirty="0"/>
+              <a:t>Based on these plots, the relationship between height and weight does not seem to vary between positions.</a:t>
+            </a:r>
+          </a:p>
+        </p:txBody>
+      </p:sp>
+    </p:spTree>
+    <p:extLst>
+      <p:ext uri="{BB962C8B-B14F-4D97-AF65-F5344CB8AC3E}">
+        <p14:creationId xmlns:p14="http://schemas.microsoft.com/office/powerpoint/2010/main" val="2162116713"/>
+      </p:ext>
+    </p:extLst>
+  </p:cSld>
+  <p:clrMapOvr>
+    <a:masterClrMapping/>
+  </p:clrMapOvr>
+</p:sld>
+</file>
+
+<file path=ppt/slides/slide11.xml><?xml version="1.0" encoding="utf-8"?>
+<p:sld xmlns:a="http://schemas.openxmlformats.org/drawingml/2006/main" xmlns:r="http://schemas.openxmlformats.org/officeDocument/2006/relationships" xmlns:p="http://schemas.openxmlformats.org/presentationml/2006/main">
+  <p:cSld>
+    <p:spTree>
+      <p:nvGrpSpPr>
+        <p:cNvPr id="1" name=""/>
+        <p:cNvGrpSpPr/>
+        <p:nvPr/>
+      </p:nvGrpSpPr>
+      <p:grpSpPr>
+        <a:xfrm>
+          <a:off x="0" y="0"/>
+          <a:ext cx="0" cy="0"/>
+          <a:chOff x="0" y="0"/>
+          <a:chExt cx="0" cy="0"/>
+        </a:xfrm>
+      </p:grpSpPr>
+      <p:pic>
+        <p:nvPicPr>
+          <p:cNvPr id="4" name="Picture 3">
+            <a:extLst>
+              <a:ext uri="{FF2B5EF4-FFF2-40B4-BE49-F238E27FC236}">
+                <a16:creationId xmlns:a16="http://schemas.microsoft.com/office/drawing/2014/main" id="{585752C8-EEF0-5F45-E86A-65914070EB2B}"/>
+              </a:ext>
+            </a:extLst>
+          </p:cNvPr>
+          <p:cNvPicPr>
+            <a:picLocks noChangeAspect="1"/>
+          </p:cNvPicPr>
+          <p:nvPr/>
+        </p:nvPicPr>
+        <p:blipFill>
+          <a:blip r:embed="rId3"/>
+          <a:stretch>
+            <a:fillRect/>
+          </a:stretch>
+        </p:blipFill>
+        <p:spPr>
+          <a:xfrm>
+            <a:off x="65833" y="671127"/>
+            <a:ext cx="6030167" cy="5515745"/>
+          </a:xfrm>
+          <a:prstGeom prst="rect">
+            <a:avLst/>
+          </a:prstGeom>
+        </p:spPr>
+      </p:pic>
+      <p:pic>
+        <p:nvPicPr>
+          <p:cNvPr id="6" name="Picture 5">
+            <a:extLst>
+              <a:ext uri="{FF2B5EF4-FFF2-40B4-BE49-F238E27FC236}">
+                <a16:creationId xmlns:a16="http://schemas.microsoft.com/office/drawing/2014/main" id="{F872338E-F87E-58E0-D189-66E020E29AF1}"/>
+              </a:ext>
+            </a:extLst>
+          </p:cNvPr>
+          <p:cNvPicPr>
+            <a:picLocks noChangeAspect="1"/>
+          </p:cNvPicPr>
+          <p:nvPr/>
+        </p:nvPicPr>
+        <p:blipFill>
+          <a:blip r:embed="rId4"/>
+          <a:stretch>
+            <a:fillRect/>
+          </a:stretch>
+        </p:blipFill>
+        <p:spPr>
+          <a:xfrm>
+            <a:off x="6096000" y="1443161"/>
+            <a:ext cx="6030167" cy="3971676"/>
+          </a:xfrm>
+          <a:prstGeom prst="rect">
+            <a:avLst/>
+          </a:prstGeom>
+        </p:spPr>
+      </p:pic>
+      <p:sp>
+        <p:nvSpPr>
+          <p:cNvPr id="7" name="TextBox 6">
+            <a:extLst>
+              <a:ext uri="{FF2B5EF4-FFF2-40B4-BE49-F238E27FC236}">
+                <a16:creationId xmlns:a16="http://schemas.microsoft.com/office/drawing/2014/main" id="{6C4B2D1C-7778-53B8-10C4-4111AD14DC9E}"/>
+              </a:ext>
+            </a:extLst>
+          </p:cNvPr>
+          <p:cNvSpPr txBox="1"/>
+          <p:nvPr/>
+        </p:nvSpPr>
+        <p:spPr>
+          <a:xfrm>
+            <a:off x="6271846" y="5477689"/>
+            <a:ext cx="5627077" cy="646331"/>
+          </a:xfrm>
+          <a:prstGeom prst="rect">
+            <a:avLst/>
+          </a:prstGeom>
+          <a:noFill/>
+        </p:spPr>
+        <p:txBody>
+          <a:bodyPr wrap="square" rtlCol="0">
+            <a:spAutoFit/>
+          </a:bodyPr>
+          <a:lstStyle/>
+          <a:p>
+            <a:r>
+              <a:rPr lang="en-US" dirty="0"/>
+              <a:t>It looks like the height increase started to level out. What’s up with that?</a:t>
+            </a:r>
+          </a:p>
+        </p:txBody>
+      </p:sp>
+    </p:spTree>
+    <p:extLst>
+      <p:ext uri="{BB962C8B-B14F-4D97-AF65-F5344CB8AC3E}">
+        <p14:creationId xmlns:p14="http://schemas.microsoft.com/office/powerpoint/2010/main" val="434424728"/>
+      </p:ext>
+    </p:extLst>
+  </p:cSld>
+  <p:clrMapOvr>
+    <a:masterClrMapping/>
+  </p:clrMapOvr>
+</p:sld>
+</file>
+
+<file path=ppt/slides/slide12.xml><?xml version="1.0" encoding="utf-8"?>
+<p:sld xmlns:a="http://schemas.openxmlformats.org/drawingml/2006/main" xmlns:r="http://schemas.openxmlformats.org/officeDocument/2006/relationships" xmlns:p="http://schemas.openxmlformats.org/presentationml/2006/main">
+  <p:cSld>
+    <p:spTree>
+      <p:nvGrpSpPr>
+        <p:cNvPr id="1" name=""/>
+        <p:cNvGrpSpPr/>
+        <p:nvPr/>
+      </p:nvGrpSpPr>
+      <p:grpSpPr>
+        <a:xfrm>
+          <a:off x="0" y="0"/>
+          <a:ext cx="0" cy="0"/>
+          <a:chOff x="0" y="0"/>
+          <a:chExt cx="0" cy="0"/>
+        </a:xfrm>
+      </p:grpSpPr>
+      <p:pic>
+        <p:nvPicPr>
+          <p:cNvPr id="4" name="Picture 3">
+            <a:extLst>
+              <a:ext uri="{FF2B5EF4-FFF2-40B4-BE49-F238E27FC236}">
+                <a16:creationId xmlns:a16="http://schemas.microsoft.com/office/drawing/2014/main" id="{B9640FDB-3636-7A9B-FE57-91417F2B6E0E}"/>
+              </a:ext>
+            </a:extLst>
+          </p:cNvPr>
+          <p:cNvPicPr>
+            <a:picLocks noChangeAspect="1"/>
+          </p:cNvPicPr>
+          <p:nvPr/>
+        </p:nvPicPr>
+        <p:blipFill>
+          <a:blip r:embed="rId3"/>
+          <a:stretch>
+            <a:fillRect/>
+          </a:stretch>
+        </p:blipFill>
+        <p:spPr>
+          <a:xfrm>
+            <a:off x="0" y="0"/>
+            <a:ext cx="6897063" cy="6735115"/>
+          </a:xfrm>
+          <a:prstGeom prst="rect">
+            <a:avLst/>
+          </a:prstGeom>
+        </p:spPr>
+      </p:pic>
+      <p:pic>
+        <p:nvPicPr>
+          <p:cNvPr id="6" name="Picture 5">
+            <a:extLst>
+              <a:ext uri="{FF2B5EF4-FFF2-40B4-BE49-F238E27FC236}">
+                <a16:creationId xmlns:a16="http://schemas.microsoft.com/office/drawing/2014/main" id="{16440A94-C578-8942-0A7E-FD6EEDC5D7A2}"/>
+              </a:ext>
+            </a:extLst>
+          </p:cNvPr>
+          <p:cNvPicPr>
+            <a:picLocks noChangeAspect="1"/>
+          </p:cNvPicPr>
+          <p:nvPr/>
+        </p:nvPicPr>
+        <p:blipFill>
+          <a:blip r:embed="rId4"/>
+          <a:stretch>
+            <a:fillRect/>
+          </a:stretch>
+        </p:blipFill>
+        <p:spPr>
+          <a:xfrm>
+            <a:off x="7050505" y="1939325"/>
+            <a:ext cx="5141495" cy="3533758"/>
+          </a:xfrm>
+          <a:prstGeom prst="rect">
+            <a:avLst/>
+          </a:prstGeom>
+        </p:spPr>
+      </p:pic>
+      <p:sp>
+        <p:nvSpPr>
+          <p:cNvPr id="7" name="TextBox 6">
+            <a:extLst>
+              <a:ext uri="{FF2B5EF4-FFF2-40B4-BE49-F238E27FC236}">
+                <a16:creationId xmlns:a16="http://schemas.microsoft.com/office/drawing/2014/main" id="{4B103115-5EC8-9AB4-43B8-122355042346}"/>
+              </a:ext>
+            </a:extLst>
+          </p:cNvPr>
+          <p:cNvSpPr txBox="1"/>
+          <p:nvPr/>
+        </p:nvSpPr>
+        <p:spPr>
+          <a:xfrm>
+            <a:off x="7832558" y="5618747"/>
+            <a:ext cx="3850105" cy="369332"/>
+          </a:xfrm>
+          <a:prstGeom prst="rect">
+            <a:avLst/>
+          </a:prstGeom>
+          <a:noFill/>
+        </p:spPr>
+        <p:txBody>
+          <a:bodyPr wrap="square" rtlCol="0">
+            <a:spAutoFit/>
+          </a:bodyPr>
+          <a:lstStyle/>
+          <a:p>
+            <a:r>
+              <a:rPr lang="en-US" dirty="0" err="1"/>
+              <a:t>ggplotly</a:t>
+            </a:r>
+            <a:r>
+              <a:rPr lang="en-US" dirty="0"/>
+              <a:t>(p) inspecting outliers</a:t>
+            </a:r>
+          </a:p>
+        </p:txBody>
+      </p:sp>
+    </p:spTree>
+    <p:extLst>
+      <p:ext uri="{BB962C8B-B14F-4D97-AF65-F5344CB8AC3E}">
+        <p14:creationId xmlns:p14="http://schemas.microsoft.com/office/powerpoint/2010/main" val="723924871"/>
+      </p:ext>
+    </p:extLst>
+  </p:cSld>
+  <p:clrMapOvr>
+    <a:masterClrMapping/>
+  </p:clrMapOvr>
+</p:sld>
+</file>
+
+<file path=ppt/slides/slide13.xml><?xml version="1.0" encoding="utf-8"?>
+<p:sld xmlns:a="http://schemas.openxmlformats.org/drawingml/2006/main" xmlns:r="http://schemas.openxmlformats.org/officeDocument/2006/relationships" xmlns:p="http://schemas.openxmlformats.org/presentationml/2006/main">
+  <p:cSld>
+    <p:spTree>
+      <p:nvGrpSpPr>
+        <p:cNvPr id="1" name=""/>
+        <p:cNvGrpSpPr/>
+        <p:nvPr/>
+      </p:nvGrpSpPr>
+      <p:grpSpPr>
+        <a:xfrm>
+          <a:off x="0" y="0"/>
+          <a:ext cx="0" cy="0"/>
+          <a:chOff x="0" y="0"/>
+          <a:chExt cx="0" cy="0"/>
+        </a:xfrm>
+      </p:grpSpPr>
+      <p:pic>
+        <p:nvPicPr>
+          <p:cNvPr id="4" name="Picture 3">
+            <a:extLst>
+              <a:ext uri="{FF2B5EF4-FFF2-40B4-BE49-F238E27FC236}">
+                <a16:creationId xmlns:a16="http://schemas.microsoft.com/office/drawing/2014/main" id="{022B32D3-FAD5-4A4E-AA93-85E64BEC9447}"/>
+              </a:ext>
+            </a:extLst>
+          </p:cNvPr>
+          <p:cNvPicPr>
+            <a:picLocks noChangeAspect="1"/>
+          </p:cNvPicPr>
+          <p:nvPr/>
+        </p:nvPicPr>
+        <p:blipFill>
+          <a:blip r:embed="rId3"/>
+          <a:stretch>
+            <a:fillRect/>
+          </a:stretch>
+        </p:blipFill>
+        <p:spPr>
+          <a:xfrm>
+            <a:off x="0" y="895520"/>
+            <a:ext cx="6552696" cy="5066960"/>
+          </a:xfrm>
+          <a:prstGeom prst="rect">
+            <a:avLst/>
+          </a:prstGeom>
+        </p:spPr>
+      </p:pic>
+      <p:sp>
+        <p:nvSpPr>
+          <p:cNvPr id="5" name="TextBox 4">
+            <a:extLst>
+              <a:ext uri="{FF2B5EF4-FFF2-40B4-BE49-F238E27FC236}">
+                <a16:creationId xmlns:a16="http://schemas.microsoft.com/office/drawing/2014/main" id="{BECE5536-C37B-89D9-638A-5BFFBDC3B75B}"/>
+              </a:ext>
+            </a:extLst>
+          </p:cNvPr>
+          <p:cNvSpPr txBox="1"/>
+          <p:nvPr/>
+        </p:nvSpPr>
+        <p:spPr>
+          <a:xfrm>
+            <a:off x="7303476" y="1822377"/>
+            <a:ext cx="4489939" cy="3416320"/>
+          </a:xfrm>
+          <a:prstGeom prst="rect">
+            <a:avLst/>
+          </a:prstGeom>
+          <a:noFill/>
+        </p:spPr>
+        <p:txBody>
+          <a:bodyPr wrap="square" rtlCol="0">
+            <a:spAutoFit/>
+          </a:bodyPr>
+          <a:lstStyle/>
+          <a:p>
+            <a:pPr marL="285750" indent="-285750">
+              <a:buFont typeface="Arial" panose="020B0604020202020204" pitchFamily="34" charset="0"/>
+              <a:buChar char="•"/>
+            </a:pPr>
+            <a:r>
+              <a:rPr lang="en-US" sz="2000" dirty="0"/>
+              <a:t>Classic visualization</a:t>
+            </a:r>
+          </a:p>
+          <a:p>
+            <a:pPr marL="285750" indent="-285750">
+              <a:buFont typeface="Arial" panose="020B0604020202020204" pitchFamily="34" charset="0"/>
+              <a:buChar char="•"/>
+            </a:pPr>
+            <a:r>
+              <a:rPr lang="en-US" sz="2000" dirty="0"/>
+              <a:t>Can be hard to read</a:t>
+            </a:r>
+          </a:p>
+          <a:p>
+            <a:pPr marL="285750" indent="-285750">
+              <a:buFont typeface="Arial" panose="020B0604020202020204" pitchFamily="34" charset="0"/>
+              <a:buChar char="•"/>
+            </a:pPr>
+            <a:r>
+              <a:rPr lang="en-US" sz="2000" dirty="0"/>
+              <a:t>Do not use with many categories</a:t>
+            </a:r>
+          </a:p>
+          <a:p>
+            <a:pPr marL="285750" indent="-285750">
+              <a:buFont typeface="Arial" panose="020B0604020202020204" pitchFamily="34" charset="0"/>
+              <a:buChar char="•"/>
+            </a:pPr>
+            <a:r>
+              <a:rPr lang="en-US" sz="2000" dirty="0"/>
+              <a:t>Color contrast should be immediately clear</a:t>
+            </a:r>
+            <a:endParaRPr lang="en-US" sz="2000" i="1" dirty="0"/>
+          </a:p>
+          <a:p>
+            <a:endParaRPr lang="en-US" i="1" dirty="0"/>
+          </a:p>
+          <a:p>
+            <a:r>
+              <a:rPr lang="en-US" sz="1400" i="1" dirty="0"/>
+              <a:t>The pie chart is classic, but some people find it hard to read because it requires you to distinguish between different hues, which can be difficult. </a:t>
+            </a:r>
+          </a:p>
+          <a:p>
+            <a:endParaRPr lang="en-US" sz="1400" i="1" dirty="0"/>
+          </a:p>
+          <a:p>
+            <a:r>
+              <a:rPr lang="en-US" sz="1400" i="1" dirty="0"/>
+              <a:t>Therefore, it works better when the colors contrast more, but if there are many different categories it becomes harder to select sufficiently contrasting colors.</a:t>
+            </a:r>
+          </a:p>
+        </p:txBody>
+      </p:sp>
+    </p:spTree>
+    <p:extLst>
+      <p:ext uri="{BB962C8B-B14F-4D97-AF65-F5344CB8AC3E}">
+        <p14:creationId xmlns:p14="http://schemas.microsoft.com/office/powerpoint/2010/main" val="1831087003"/>
+      </p:ext>
+    </p:extLst>
+  </p:cSld>
+  <p:clrMapOvr>
+    <a:masterClrMapping/>
+  </p:clrMapOvr>
+</p:sld>
+</file>
+
+<file path=ppt/slides/slide14.xml><?xml version="1.0" encoding="utf-8"?>
+<p:sld xmlns:a="http://schemas.openxmlformats.org/drawingml/2006/main" xmlns:r="http://schemas.openxmlformats.org/officeDocument/2006/relationships" xmlns:p="http://schemas.openxmlformats.org/presentationml/2006/main">
+  <p:cSld>
+    <p:spTree>
+      <p:nvGrpSpPr>
+        <p:cNvPr id="1" name=""/>
+        <p:cNvGrpSpPr/>
+        <p:nvPr/>
+      </p:nvGrpSpPr>
+      <p:grpSpPr>
+        <a:xfrm>
+          <a:off x="0" y="0"/>
+          <a:ext cx="0" cy="0"/>
+          <a:chOff x="0" y="0"/>
+          <a:chExt cx="0" cy="0"/>
+        </a:xfrm>
+      </p:grpSpPr>
+      <p:sp>
+        <p:nvSpPr>
+          <p:cNvPr id="2" name="Title 1">
+            <a:extLst>
+              <a:ext uri="{FF2B5EF4-FFF2-40B4-BE49-F238E27FC236}">
+                <a16:creationId xmlns:a16="http://schemas.microsoft.com/office/drawing/2014/main" id="{C12FA1FA-C722-263F-B54D-B11CDEC64D53}"/>
+              </a:ext>
+            </a:extLst>
+          </p:cNvPr>
+          <p:cNvSpPr>
+            <a:spLocks noGrp="1"/>
+          </p:cNvSpPr>
+          <p:nvPr>
+            <p:ph type="title"/>
+          </p:nvPr>
+        </p:nvSpPr>
+        <p:spPr/>
+        <p:txBody>
+          <a:bodyPr/>
+          <a:lstStyle/>
+          <a:p>
+            <a:r>
+              <a:rPr lang="en-US" dirty="0"/>
+              <a:t>Takeaways and Questions</a:t>
+            </a:r>
+          </a:p>
+        </p:txBody>
+      </p:sp>
+      <p:sp>
+        <p:nvSpPr>
+          <p:cNvPr id="3" name="TextBox 2">
+            <a:extLst>
+              <a:ext uri="{FF2B5EF4-FFF2-40B4-BE49-F238E27FC236}">
+                <a16:creationId xmlns:a16="http://schemas.microsoft.com/office/drawing/2014/main" id="{B2056608-8FC6-D16A-4BB6-337053D05156}"/>
+              </a:ext>
+            </a:extLst>
+          </p:cNvPr>
+          <p:cNvSpPr txBox="1"/>
+          <p:nvPr/>
+        </p:nvSpPr>
+        <p:spPr>
+          <a:xfrm>
+            <a:off x="926122" y="1690688"/>
+            <a:ext cx="10427677" cy="4247317"/>
+          </a:xfrm>
+          <a:prstGeom prst="rect">
+            <a:avLst/>
+          </a:prstGeom>
+          <a:noFill/>
+        </p:spPr>
+        <p:txBody>
+          <a:bodyPr wrap="square" rtlCol="0">
+            <a:spAutoFit/>
+          </a:bodyPr>
+          <a:lstStyle/>
+          <a:p>
+            <a:r>
+              <a:rPr lang="en-US" dirty="0"/>
+              <a:t>Inspect the data first. Look at the summary of the data and notice the min, max, mean. Think about the data types and whether they should be converted for better analysis.</a:t>
+            </a:r>
+          </a:p>
+          <a:p>
+            <a:endParaRPr lang="en-US" dirty="0"/>
+          </a:p>
+          <a:p>
+            <a:r>
+              <a:rPr lang="en-US" dirty="0"/>
+              <a:t>What’s a good way to compare distributions? Other than simply noticing where they’re centered.</a:t>
+            </a:r>
+          </a:p>
+          <a:p>
+            <a:endParaRPr lang="en-US" dirty="0"/>
+          </a:p>
+          <a:p>
+            <a:r>
+              <a:rPr lang="en-US" dirty="0"/>
+              <a:t>Layering density plots of height distribution was easier and looked better than trying to layer histograms of weight distribution.</a:t>
+            </a:r>
+          </a:p>
+          <a:p>
+            <a:endParaRPr lang="en-US" dirty="0"/>
+          </a:p>
+          <a:p>
+            <a:r>
+              <a:rPr lang="en-US" dirty="0"/>
+              <a:t>Maybe putting labels on the lines in the density plot could be easier to read than trying to match the color to the legend. How to do that? Maybe add </a:t>
+            </a:r>
+            <a:r>
+              <a:rPr lang="en-US" dirty="0" err="1"/>
+              <a:t>geom_text</a:t>
+            </a:r>
+            <a:r>
+              <a:rPr lang="en-US" dirty="0"/>
+              <a:t>(), or just apply </a:t>
+            </a:r>
+            <a:r>
+              <a:rPr lang="en-US" dirty="0" err="1"/>
+              <a:t>ggplotly</a:t>
+            </a:r>
+            <a:r>
+              <a:rPr lang="en-US" dirty="0"/>
+              <a:t>.</a:t>
+            </a:r>
+          </a:p>
+          <a:p>
+            <a:endParaRPr lang="en-US" dirty="0"/>
+          </a:p>
+          <a:p>
+            <a:r>
+              <a:rPr lang="en-US" dirty="0"/>
+              <a:t>Does the distribution of player heights by year look like it’s starting to level out in the late 1960s?</a:t>
+            </a:r>
+          </a:p>
+          <a:p>
+            <a:endParaRPr lang="en-US" dirty="0"/>
+          </a:p>
+          <a:p>
+            <a:endParaRPr lang="en-US" dirty="0"/>
+          </a:p>
+          <a:p>
+            <a:endParaRPr lang="en-US" dirty="0"/>
+          </a:p>
+        </p:txBody>
+      </p:sp>
+    </p:spTree>
+    <p:extLst>
+      <p:ext uri="{BB962C8B-B14F-4D97-AF65-F5344CB8AC3E}">
+        <p14:creationId xmlns:p14="http://schemas.microsoft.com/office/powerpoint/2010/main" val="1824888273"/>
+      </p:ext>
+    </p:extLst>
+  </p:cSld>
+  <p:clrMapOvr>
+    <a:masterClrMapping/>
+  </p:clrMapOvr>
+</p:sld>
+</file>
+
+<file path=ppt/slides/slide2.xml><?xml version="1.0" encoding="utf-8"?>
+<p:sld xmlns:a="http://schemas.openxmlformats.org/drawingml/2006/main" xmlns:r="http://schemas.openxmlformats.org/officeDocument/2006/relationships" xmlns:p="http://schemas.openxmlformats.org/presentationml/2006/main">
+  <p:cSld>
+    <p:spTree>
+      <p:nvGrpSpPr>
+        <p:cNvPr id="1" name=""/>
+        <p:cNvGrpSpPr/>
+        <p:nvPr/>
+      </p:nvGrpSpPr>
+      <p:grpSpPr>
+        <a:xfrm>
+          <a:off x="0" y="0"/>
+          <a:ext cx="0" cy="0"/>
+          <a:chOff x="0" y="0"/>
+          <a:chExt cx="0" cy="0"/>
+        </a:xfrm>
+      </p:grpSpPr>
+      <p:pic>
+        <p:nvPicPr>
+          <p:cNvPr id="6" name="Picture 5">
+            <a:extLst>
+              <a:ext uri="{FF2B5EF4-FFF2-40B4-BE49-F238E27FC236}">
+                <a16:creationId xmlns:a16="http://schemas.microsoft.com/office/drawing/2014/main" id="{5B2948BF-89DA-B54C-42BE-AFAD6D83647F}"/>
+              </a:ext>
+            </a:extLst>
+          </p:cNvPr>
+          <p:cNvPicPr>
+            <a:picLocks noChangeAspect="1"/>
+          </p:cNvPicPr>
+          <p:nvPr/>
+        </p:nvPicPr>
+        <p:blipFill>
+          <a:blip r:embed="rId3"/>
+          <a:srcRect b="86468"/>
+          <a:stretch>
+            <a:fillRect/>
+          </a:stretch>
+        </p:blipFill>
+        <p:spPr>
+          <a:xfrm>
+            <a:off x="2352543" y="728286"/>
+            <a:ext cx="7135221" cy="730940"/>
+          </a:xfrm>
+          <a:prstGeom prst="rect">
+            <a:avLst/>
+          </a:prstGeom>
+        </p:spPr>
+      </p:pic>
+      <p:pic>
+        <p:nvPicPr>
+          <p:cNvPr id="8" name="Picture 7">
+            <a:extLst>
+              <a:ext uri="{FF2B5EF4-FFF2-40B4-BE49-F238E27FC236}">
+                <a16:creationId xmlns:a16="http://schemas.microsoft.com/office/drawing/2014/main" id="{2E317755-CBD8-2304-95B0-661EA3D1E1D7}"/>
+              </a:ext>
+            </a:extLst>
+          </p:cNvPr>
+          <p:cNvPicPr>
+            <a:picLocks noChangeAspect="1"/>
+          </p:cNvPicPr>
+          <p:nvPr/>
+        </p:nvPicPr>
+        <p:blipFill>
+          <a:blip r:embed="rId4"/>
+          <a:stretch>
+            <a:fillRect/>
+          </a:stretch>
+        </p:blipFill>
+        <p:spPr>
+          <a:xfrm>
+            <a:off x="2514490" y="1611625"/>
+            <a:ext cx="6811326" cy="4267796"/>
+          </a:xfrm>
+          <a:prstGeom prst="rect">
+            <a:avLst/>
+          </a:prstGeom>
+        </p:spPr>
+      </p:pic>
+    </p:spTree>
+    <p:extLst>
+      <p:ext uri="{BB962C8B-B14F-4D97-AF65-F5344CB8AC3E}">
+        <p14:creationId xmlns:p14="http://schemas.microsoft.com/office/powerpoint/2010/main" val="2965440394"/>
+      </p:ext>
+    </p:extLst>
+  </p:cSld>
+  <p:clrMapOvr>
+    <a:masterClrMapping/>
+  </p:clrMapOvr>
+</p:sld>
+</file>
+
+<file path=ppt/slides/slide3.xml><?xml version="1.0" encoding="utf-8"?>
+<p:sld xmlns:a="http://schemas.openxmlformats.org/drawingml/2006/main" xmlns:r="http://schemas.openxmlformats.org/officeDocument/2006/relationships" xmlns:p="http://schemas.openxmlformats.org/presentationml/2006/main">
+  <p:cSld>
+    <p:spTree>
+      <p:nvGrpSpPr>
+        <p:cNvPr id="1" name="">
+          <a:extLst>
+            <a:ext uri="{FF2B5EF4-FFF2-40B4-BE49-F238E27FC236}">
+              <a16:creationId xmlns:a16="http://schemas.microsoft.com/office/drawing/2014/main" id="{5994AC10-FC2A-88C1-28BE-2B739E11B5D2}"/>
+            </a:ext>
+          </a:extLst>
+        </p:cNvPr>
+        <p:cNvGrpSpPr/>
+        <p:nvPr/>
+      </p:nvGrpSpPr>
+      <p:grpSpPr>
+        <a:xfrm>
+          <a:off x="0" y="0"/>
+          <a:ext cx="0" cy="0"/>
+          <a:chOff x="0" y="0"/>
+          <a:chExt cx="0" cy="0"/>
+        </a:xfrm>
+      </p:grpSpPr>
+      <p:pic>
+        <p:nvPicPr>
+          <p:cNvPr id="8" name="Picture 7">
+            <a:extLst>
+              <a:ext uri="{FF2B5EF4-FFF2-40B4-BE49-F238E27FC236}">
+                <a16:creationId xmlns:a16="http://schemas.microsoft.com/office/drawing/2014/main" id="{8DC66573-A1B9-948E-98EA-F9E622B53D91}"/>
+              </a:ext>
+            </a:extLst>
+          </p:cNvPr>
+          <p:cNvPicPr>
+            <a:picLocks noChangeAspect="1"/>
+          </p:cNvPicPr>
+          <p:nvPr/>
+        </p:nvPicPr>
+        <p:blipFill>
+          <a:blip r:embed="rId3"/>
+          <a:stretch>
+            <a:fillRect/>
+          </a:stretch>
+        </p:blipFill>
+        <p:spPr>
+          <a:xfrm>
+            <a:off x="63741" y="0"/>
+            <a:ext cx="6032259" cy="6858000"/>
+          </a:xfrm>
+          <a:prstGeom prst="rect">
+            <a:avLst/>
+          </a:prstGeom>
+        </p:spPr>
+      </p:pic>
+      <p:pic>
+        <p:nvPicPr>
+          <p:cNvPr id="10" name="Picture 9">
+            <a:extLst>
+              <a:ext uri="{FF2B5EF4-FFF2-40B4-BE49-F238E27FC236}">
+                <a16:creationId xmlns:a16="http://schemas.microsoft.com/office/drawing/2014/main" id="{6F429844-EED3-719D-C522-902066D50717}"/>
+              </a:ext>
+            </a:extLst>
+          </p:cNvPr>
+          <p:cNvPicPr>
+            <a:picLocks noChangeAspect="1"/>
+          </p:cNvPicPr>
+          <p:nvPr/>
+        </p:nvPicPr>
+        <p:blipFill>
+          <a:blip r:embed="rId4"/>
+          <a:stretch>
+            <a:fillRect/>
+          </a:stretch>
+        </p:blipFill>
+        <p:spPr>
+          <a:xfrm>
+            <a:off x="5883373" y="0"/>
+            <a:ext cx="6308627" cy="6858000"/>
+          </a:xfrm>
+          <a:prstGeom prst="rect">
+            <a:avLst/>
+          </a:prstGeom>
+        </p:spPr>
+      </p:pic>
+    </p:spTree>
+    <p:extLst>
+      <p:ext uri="{BB962C8B-B14F-4D97-AF65-F5344CB8AC3E}">
+        <p14:creationId xmlns:p14="http://schemas.microsoft.com/office/powerpoint/2010/main" val="2825713841"/>
+      </p:ext>
+    </p:extLst>
+  </p:cSld>
+  <p:clrMapOvr>
+    <a:masterClrMapping/>
+  </p:clrMapOvr>
+</p:sld>
+</file>
+
+<file path=ppt/slides/slide4.xml><?xml version="1.0" encoding="utf-8"?>
+<p:sld xmlns:a="http://schemas.openxmlformats.org/drawingml/2006/main" xmlns:r="http://schemas.openxmlformats.org/officeDocument/2006/relationships" xmlns:p="http://schemas.openxmlformats.org/presentationml/2006/main">
+  <p:cSld>
+    <p:spTree>
+      <p:nvGrpSpPr>
+        <p:cNvPr id="1" name="">
+          <a:extLst>
+            <a:ext uri="{FF2B5EF4-FFF2-40B4-BE49-F238E27FC236}">
+              <a16:creationId xmlns:a16="http://schemas.microsoft.com/office/drawing/2014/main" id="{F792626B-4EB3-7039-FE06-836B706ADDE3}"/>
+            </a:ext>
+          </a:extLst>
+        </p:cNvPr>
+        <p:cNvGrpSpPr/>
+        <p:nvPr/>
+      </p:nvGrpSpPr>
+      <p:grpSpPr>
+        <a:xfrm>
+          <a:off x="0" y="0"/>
+          <a:ext cx="0" cy="0"/>
+          <a:chOff x="0" y="0"/>
+          <a:chExt cx="0" cy="0"/>
+        </a:xfrm>
+      </p:grpSpPr>
+      <p:pic>
+        <p:nvPicPr>
+          <p:cNvPr id="7" name="Picture 6">
+            <a:extLst>
+              <a:ext uri="{FF2B5EF4-FFF2-40B4-BE49-F238E27FC236}">
+                <a16:creationId xmlns:a16="http://schemas.microsoft.com/office/drawing/2014/main" id="{1668001E-68F5-88A6-68DF-E806D814FCA5}"/>
+              </a:ext>
+            </a:extLst>
+          </p:cNvPr>
+          <p:cNvPicPr>
+            <a:picLocks noChangeAspect="1"/>
+          </p:cNvPicPr>
+          <p:nvPr/>
+        </p:nvPicPr>
+        <p:blipFill>
+          <a:blip r:embed="rId3"/>
+          <a:stretch>
+            <a:fillRect/>
+          </a:stretch>
+        </p:blipFill>
+        <p:spPr>
+          <a:xfrm>
+            <a:off x="1277815" y="1284087"/>
+            <a:ext cx="4818185" cy="5550774"/>
+          </a:xfrm>
+          <a:prstGeom prst="rect">
+            <a:avLst/>
+          </a:prstGeom>
+        </p:spPr>
+      </p:pic>
+      <p:pic>
+        <p:nvPicPr>
+          <p:cNvPr id="9" name="Picture 8">
+            <a:extLst>
+              <a:ext uri="{FF2B5EF4-FFF2-40B4-BE49-F238E27FC236}">
+                <a16:creationId xmlns:a16="http://schemas.microsoft.com/office/drawing/2014/main" id="{60FBAE4C-E8CF-F6D6-562C-ABCEEBB44DAF}"/>
+              </a:ext>
+            </a:extLst>
+          </p:cNvPr>
+          <p:cNvPicPr>
+            <a:picLocks noChangeAspect="1"/>
+          </p:cNvPicPr>
+          <p:nvPr/>
+        </p:nvPicPr>
+        <p:blipFill>
+          <a:blip r:embed="rId4"/>
+          <a:stretch>
+            <a:fillRect/>
+          </a:stretch>
+        </p:blipFill>
+        <p:spPr>
+          <a:xfrm>
+            <a:off x="6095999" y="1307226"/>
+            <a:ext cx="4818185" cy="5504496"/>
+          </a:xfrm>
+          <a:prstGeom prst="rect">
+            <a:avLst/>
+          </a:prstGeom>
+        </p:spPr>
+      </p:pic>
+    </p:spTree>
+    <p:extLst>
+      <p:ext uri="{BB962C8B-B14F-4D97-AF65-F5344CB8AC3E}">
+        <p14:creationId xmlns:p14="http://schemas.microsoft.com/office/powerpoint/2010/main" val="2304346035"/>
+      </p:ext>
+    </p:extLst>
+  </p:cSld>
+  <p:clrMapOvr>
+    <a:masterClrMapping/>
+  </p:clrMapOvr>
+</p:sld>
+</file>
+
+<file path=ppt/slides/slide5.xml><?xml version="1.0" encoding="utf-8"?>
+<p:sld xmlns:a="http://schemas.openxmlformats.org/drawingml/2006/main" xmlns:r="http://schemas.openxmlformats.org/officeDocument/2006/relationships" xmlns:p="http://schemas.openxmlformats.org/presentationml/2006/main">
+  <p:cSld>
+    <p:spTree>
+      <p:nvGrpSpPr>
+        <p:cNvPr id="1" name=""/>
+        <p:cNvGrpSpPr/>
+        <p:nvPr/>
+      </p:nvGrpSpPr>
+      <p:grpSpPr>
+        <a:xfrm>
+          <a:off x="0" y="0"/>
+          <a:ext cx="0" cy="0"/>
+          <a:chOff x="0" y="0"/>
+          <a:chExt cx="0" cy="0"/>
+        </a:xfrm>
+      </p:grpSpPr>
+      <p:pic>
+        <p:nvPicPr>
+          <p:cNvPr id="3" name="Picture 2">
+            <a:extLst>
+              <a:ext uri="{FF2B5EF4-FFF2-40B4-BE49-F238E27FC236}">
+                <a16:creationId xmlns:a16="http://schemas.microsoft.com/office/drawing/2014/main" id="{7A45123F-4838-4134-E4F2-7885B3621950}"/>
+              </a:ext>
+            </a:extLst>
+          </p:cNvPr>
+          <p:cNvPicPr>
+            <a:picLocks noChangeAspect="1"/>
+          </p:cNvPicPr>
+          <p:nvPr/>
+        </p:nvPicPr>
+        <p:blipFill>
+          <a:blip r:embed="rId2"/>
+          <a:stretch>
+            <a:fillRect/>
+          </a:stretch>
+        </p:blipFill>
+        <p:spPr>
+          <a:xfrm>
+            <a:off x="690597" y="2095587"/>
+            <a:ext cx="10810806" cy="2666825"/>
+          </a:xfrm>
+          <a:prstGeom prst="rect">
+            <a:avLst/>
+          </a:prstGeom>
+        </p:spPr>
+      </p:pic>
+    </p:spTree>
+    <p:extLst>
+      <p:ext uri="{BB962C8B-B14F-4D97-AF65-F5344CB8AC3E}">
+        <p14:creationId xmlns:p14="http://schemas.microsoft.com/office/powerpoint/2010/main" val="873717824"/>
+      </p:ext>
+    </p:extLst>
+  </p:cSld>
+  <p:clrMapOvr>
+    <a:masterClrMapping/>
+  </p:clrMapOvr>
+</p:sld>
+</file>
+
+<file path=ppt/slides/slide6.xml><?xml version="1.0" encoding="utf-8"?>
 <p:sld xmlns:a="http://schemas.openxmlformats.org/drawingml/2006/main" xmlns:r="http://schemas.openxmlformats.org/officeDocument/2006/relationships" xmlns:p="http://schemas.openxmlformats.org/presentationml/2006/main">
   <p:cSld>
     <p:spTree>
@@ -3547,75 +5860,7 @@
 </p:sld>
 </file>
 
-<file path=ppt/slides/slide11.xml><?xml version="1.0" encoding="utf-8"?>
-<p:sld xmlns:a="http://schemas.openxmlformats.org/drawingml/2006/main" xmlns:r="http://schemas.openxmlformats.org/officeDocument/2006/relationships" xmlns:p="http://schemas.openxmlformats.org/presentationml/2006/main">
-  <p:cSld>
-    <p:spTree>
-      <p:nvGrpSpPr>
-        <p:cNvPr id="1" name=""/>
-        <p:cNvGrpSpPr/>
-        <p:nvPr/>
-      </p:nvGrpSpPr>
-      <p:grpSpPr>
-        <a:xfrm>
-          <a:off x="0" y="0"/>
-          <a:ext cx="0" cy="0"/>
-          <a:chOff x="0" y="0"/>
-          <a:chExt cx="0" cy="0"/>
-        </a:xfrm>
-      </p:grpSpPr>
-      <p:sp>
-        <p:nvSpPr>
-          <p:cNvPr id="2" name="Title 1">
-            <a:extLst>
-              <a:ext uri="{FF2B5EF4-FFF2-40B4-BE49-F238E27FC236}">
-                <a16:creationId xmlns:a16="http://schemas.microsoft.com/office/drawing/2014/main" id="{57A23C56-3CF7-E665-CC81-B5794343CF51}"/>
-              </a:ext>
-            </a:extLst>
-          </p:cNvPr>
-          <p:cNvSpPr>
-            <a:spLocks noGrp="1"/>
-          </p:cNvSpPr>
-          <p:nvPr>
-            <p:ph type="title"/>
-          </p:nvPr>
-        </p:nvSpPr>
-        <p:spPr/>
-        <p:txBody>
-          <a:bodyPr>
-            <a:normAutofit fontScale="90000"/>
-          </a:bodyPr>
-          <a:lstStyle/>
-          <a:p>
-            <a:r>
-              <a:rPr lang="en-US" dirty="0"/>
-              <a:t>Use the dataset to visually investigate if the distribution of height is different between </a:t>
-            </a:r>
-            <a:r>
-              <a:rPr lang="en-US" i="1" dirty="0"/>
-              <a:t>any </a:t>
-            </a:r>
-            <a:r>
-              <a:rPr lang="en-US" dirty="0"/>
-              <a:t>of the positions.</a:t>
-            </a:r>
-          </a:p>
-        </p:txBody>
-      </p:sp>
-    </p:spTree>
-    <p:extLst>
-      <p:ext uri="{BB962C8B-B14F-4D97-AF65-F5344CB8AC3E}">
-        <p14:creationId xmlns:p14="http://schemas.microsoft.com/office/powerpoint/2010/main" val="1459221153"/>
-      </p:ext>
-    </p:extLst>
-  </p:cSld>
-  <p:clrMapOvr>
-    <a:masterClrMapping/>
-  </p:clrMapOvr>
-</p:sld>
-</file>
-
-<file path=ppt/slides/slide12.xml><?xml version="1.0" encoding="utf-8"?>
+<file path=ppt/slides/slide7.xml><?xml version="1.0" encoding="utf-8"?>
 <p:sld xmlns:a="http://schemas.openxmlformats.org/drawingml/2006/main" xmlns:r="http://schemas.openxmlformats.org/officeDocument/2006/relationships" xmlns:p="http://schemas.openxmlformats.org/presentationml/2006/main">
   <p:cSld>
     <p:spTree>
@@ -3647,7 +5892,7 @@
           <p:nvPr/>
         </p:nvPicPr>
         <p:blipFill>
-          <a:blip r:embed="rId2"/>
+          <a:blip r:embed="rId3"/>
           <a:stretch>
             <a:fillRect/>
           </a:stretch>
@@ -3675,67 +5920,7 @@
 </p:sld>
 </file>
 
-<file path=ppt/slides/slide13.xml><?xml version="1.0" encoding="utf-8"?>
-<p:sld xmlns:a="http://schemas.openxmlformats.org/drawingml/2006/main" xmlns:r="http://schemas.openxmlformats.org/officeDocument/2006/relationships" xmlns:p="http://schemas.openxmlformats.org/presentationml/2006/main">
-  <p:cSld>
-    <p:spTree>
-      <p:nvGrpSpPr>
-        <p:cNvPr id="1" name=""/>
-        <p:cNvGrpSpPr/>
-        <p:nvPr/>
-      </p:nvGrpSpPr>
-      <p:grpSpPr>
-        <a:xfrm>
-          <a:off x="0" y="0"/>
-          <a:ext cx="0" cy="0"/>
-          <a:chOff x="0" y="0"/>
-          <a:chExt cx="0" cy="0"/>
-        </a:xfrm>
-      </p:grpSpPr>
-      <p:sp>
-        <p:nvSpPr>
-          <p:cNvPr id="2" name="Title 1">
-            <a:extLst>
-              <a:ext uri="{FF2B5EF4-FFF2-40B4-BE49-F238E27FC236}">
-                <a16:creationId xmlns:a16="http://schemas.microsoft.com/office/drawing/2014/main" id="{C4569DDD-0071-EC55-D735-1835EE6237E2}"/>
-              </a:ext>
-            </a:extLst>
-          </p:cNvPr>
-          <p:cNvSpPr>
-            <a:spLocks noGrp="1"/>
-          </p:cNvSpPr>
-          <p:nvPr>
-            <p:ph type="title"/>
-          </p:nvPr>
-        </p:nvSpPr>
-        <p:spPr/>
-        <p:txBody>
-          <a:bodyPr>
-            <a:normAutofit fontScale="90000"/>
-          </a:bodyPr>
-          <a:lstStyle/>
-          <a:p>
-            <a:r>
-              <a:rPr lang="en-US" dirty="0"/>
-              <a:t>Use the dataset to investigate how the player’s height is related to the player’s weight. How does height change as the weight changes?</a:t>
-            </a:r>
-          </a:p>
-        </p:txBody>
-      </p:sp>
-    </p:spTree>
-    <p:extLst>
-      <p:ext uri="{BB962C8B-B14F-4D97-AF65-F5344CB8AC3E}">
-        <p14:creationId xmlns:p14="http://schemas.microsoft.com/office/powerpoint/2010/main" val="2280422974"/>
-      </p:ext>
-    </p:extLst>
-  </p:cSld>
-  <p:clrMapOvr>
-    <a:masterClrMapping/>
-  </p:clrMapOvr>
-</p:sld>
-</file>
-
-<file path=ppt/slides/slide14.xml><?xml version="1.0" encoding="utf-8"?>
+<file path=ppt/slides/slide8.xml><?xml version="1.0" encoding="utf-8"?>
 <p:sld xmlns:a="http://schemas.openxmlformats.org/drawingml/2006/main" xmlns:r="http://schemas.openxmlformats.org/officeDocument/2006/relationships" xmlns:p="http://schemas.openxmlformats.org/presentationml/2006/main">
   <p:cSld>
     <p:spTree>
@@ -3754,10 +5939,10 @@
       </p:grpSpPr>
       <p:pic>
         <p:nvPicPr>
-          <p:cNvPr id="4" name="Picture 3">
-            <a:extLst>
-              <a:ext uri="{FF2B5EF4-FFF2-40B4-BE49-F238E27FC236}">
-                <a16:creationId xmlns:a16="http://schemas.microsoft.com/office/drawing/2014/main" id="{5B7F0E65-FA81-13AC-1881-59C65DF2CACF}"/>
+          <p:cNvPr id="3" name="Picture 2">
+            <a:extLst>
+              <a:ext uri="{FF2B5EF4-FFF2-40B4-BE49-F238E27FC236}">
+                <a16:creationId xmlns:a16="http://schemas.microsoft.com/office/drawing/2014/main" id="{56DD4381-997C-036E-A2FD-4BE776FD5C83}"/>
               </a:ext>
             </a:extLst>
           </p:cNvPr>
@@ -3774,128 +5959,8 @@
         </p:blipFill>
         <p:spPr>
           <a:xfrm>
-            <a:off x="2230244" y="0"/>
-            <a:ext cx="7731512" cy="6858000"/>
-          </a:xfrm>
-          <a:prstGeom prst="rect">
-            <a:avLst/>
-          </a:prstGeom>
-        </p:spPr>
-      </p:pic>
-    </p:spTree>
-    <p:extLst>
-      <p:ext uri="{BB962C8B-B14F-4D97-AF65-F5344CB8AC3E}">
-        <p14:creationId xmlns:p14="http://schemas.microsoft.com/office/powerpoint/2010/main" val="89551103"/>
-      </p:ext>
-    </p:extLst>
-  </p:cSld>
-  <p:clrMapOvr>
-    <a:masterClrMapping/>
-  </p:clrMapOvr>
-</p:sld>
-</file>
-
-<file path=ppt/slides/slide15.xml><?xml version="1.0" encoding="utf-8"?>
-<p:sld xmlns:a="http://schemas.openxmlformats.org/drawingml/2006/main" xmlns:r="http://schemas.openxmlformats.org/officeDocument/2006/relationships" xmlns:p="http://schemas.openxmlformats.org/presentationml/2006/main">
-  <p:cSld>
-    <p:spTree>
-      <p:nvGrpSpPr>
-        <p:cNvPr id="1" name=""/>
-        <p:cNvGrpSpPr/>
-        <p:nvPr/>
-      </p:nvGrpSpPr>
-      <p:grpSpPr>
-        <a:xfrm>
-          <a:off x="0" y="0"/>
-          <a:ext cx="0" cy="0"/>
-          <a:chOff x="0" y="0"/>
-          <a:chExt cx="0" cy="0"/>
-        </a:xfrm>
-      </p:grpSpPr>
-      <p:sp>
-        <p:nvSpPr>
-          <p:cNvPr id="2" name="Title 1">
-            <a:extLst>
-              <a:ext uri="{FF2B5EF4-FFF2-40B4-BE49-F238E27FC236}">
-                <a16:creationId xmlns:a16="http://schemas.microsoft.com/office/drawing/2014/main" id="{223B0F22-36F3-C0C6-0960-FE53686440DD}"/>
-              </a:ext>
-            </a:extLst>
-          </p:cNvPr>
-          <p:cNvSpPr>
-            <a:spLocks noGrp="1"/>
-          </p:cNvSpPr>
-          <p:nvPr>
-            <p:ph type="title"/>
-          </p:nvPr>
-        </p:nvSpPr>
-        <p:spPr/>
-        <p:txBody>
-          <a:bodyPr>
-            <a:normAutofit fontScale="90000"/>
-          </a:bodyPr>
-          <a:lstStyle/>
-          <a:p>
-            <a:r>
-              <a:rPr lang="en-US" dirty="0"/>
-              <a:t>Is their any difference in the relationship between height and weight between positions?  Are height and weight related differently for different positions.</a:t>
-            </a:r>
-          </a:p>
-        </p:txBody>
-      </p:sp>
-    </p:spTree>
-    <p:extLst>
-      <p:ext uri="{BB962C8B-B14F-4D97-AF65-F5344CB8AC3E}">
-        <p14:creationId xmlns:p14="http://schemas.microsoft.com/office/powerpoint/2010/main" val="2004947187"/>
-      </p:ext>
-    </p:extLst>
-  </p:cSld>
-  <p:clrMapOvr>
-    <a:masterClrMapping/>
-  </p:clrMapOvr>
-</p:sld>
-</file>
-
-<file path=ppt/slides/slide16.xml><?xml version="1.0" encoding="utf-8"?>
-<p:sld xmlns:a="http://schemas.openxmlformats.org/drawingml/2006/main" xmlns:r="http://schemas.openxmlformats.org/officeDocument/2006/relationships" xmlns:p="http://schemas.openxmlformats.org/presentationml/2006/main">
-  <p:cSld>
-    <p:spTree>
-      <p:nvGrpSpPr>
-        <p:cNvPr id="1" name=""/>
-        <p:cNvGrpSpPr/>
-        <p:nvPr/>
-      </p:nvGrpSpPr>
-      <p:grpSpPr>
-        <a:xfrm>
-          <a:off x="0" y="0"/>
-          <a:ext cx="0" cy="0"/>
-          <a:chOff x="0" y="0"/>
-          <a:chExt cx="0" cy="0"/>
-        </a:xfrm>
-      </p:grpSpPr>
-      <p:pic>
-        <p:nvPicPr>
-          <p:cNvPr id="4" name="Picture 3">
-            <a:extLst>
-              <a:ext uri="{FF2B5EF4-FFF2-40B4-BE49-F238E27FC236}">
-                <a16:creationId xmlns:a16="http://schemas.microsoft.com/office/drawing/2014/main" id="{5392273D-FD59-CD29-858C-E8EF9E0F796C}"/>
-              </a:ext>
-            </a:extLst>
-          </p:cNvPr>
-          <p:cNvPicPr>
-            <a:picLocks noChangeAspect="1"/>
-          </p:cNvPicPr>
-          <p:nvPr/>
-        </p:nvPicPr>
-        <p:blipFill>
-          <a:blip r:embed="rId2"/>
-          <a:stretch>
-            <a:fillRect/>
-          </a:stretch>
-        </p:blipFill>
-        <p:spPr>
-          <a:xfrm>
-            <a:off x="3280969" y="113829"/>
-            <a:ext cx="5630061" cy="1495634"/>
+            <a:off x="5685517" y="1109339"/>
+            <a:ext cx="6506483" cy="4639322"/>
           </a:xfrm>
           <a:prstGeom prst="rect">
             <a:avLst/>
@@ -3904,10 +5969,10 @@
       </p:pic>
       <p:pic>
         <p:nvPicPr>
-          <p:cNvPr id="6" name="Picture 5">
-            <a:extLst>
-              <a:ext uri="{FF2B5EF4-FFF2-40B4-BE49-F238E27FC236}">
-                <a16:creationId xmlns:a16="http://schemas.microsoft.com/office/drawing/2014/main" id="{CE8F9093-49AF-39F8-8277-C829D4761C4B}"/>
+          <p:cNvPr id="5" name="Picture 4">
+            <a:extLst>
+              <a:ext uri="{FF2B5EF4-FFF2-40B4-BE49-F238E27FC236}">
+                <a16:creationId xmlns:a16="http://schemas.microsoft.com/office/drawing/2014/main" id="{5F19A338-28C8-33E9-6F95-485E7B0D4F3C}"/>
               </a:ext>
             </a:extLst>
           </p:cNvPr>
@@ -3924,8 +5989,8 @@
         </p:blipFill>
         <p:spPr>
           <a:xfrm>
-            <a:off x="2814178" y="1609463"/>
-            <a:ext cx="6563641" cy="4582164"/>
+            <a:off x="0" y="452022"/>
+            <a:ext cx="5820587" cy="5953956"/>
           </a:xfrm>
           <a:prstGeom prst="rect">
             <a:avLst/>
@@ -3935,1180 +6000,7 @@
     </p:spTree>
     <p:extLst>
       <p:ext uri="{BB962C8B-B14F-4D97-AF65-F5344CB8AC3E}">
-        <p14:creationId xmlns:p14="http://schemas.microsoft.com/office/powerpoint/2010/main" val="2162116713"/>
-      </p:ext>
-    </p:extLst>
-  </p:cSld>
-  <p:clrMapOvr>
-    <a:masterClrMapping/>
-  </p:clrMapOvr>
-</p:sld>
-</file>
-
-<file path=ppt/slides/slide17.xml><?xml version="1.0" encoding="utf-8"?>
-<p:sld xmlns:a="http://schemas.openxmlformats.org/drawingml/2006/main" xmlns:r="http://schemas.openxmlformats.org/officeDocument/2006/relationships" xmlns:p="http://schemas.openxmlformats.org/presentationml/2006/main">
-  <p:cSld>
-    <p:spTree>
-      <p:nvGrpSpPr>
-        <p:cNvPr id="1" name=""/>
-        <p:cNvGrpSpPr/>
-        <p:nvPr/>
-      </p:nvGrpSpPr>
-      <p:grpSpPr>
-        <a:xfrm>
-          <a:off x="0" y="0"/>
-          <a:ext cx="0" cy="0"/>
-          <a:chOff x="0" y="0"/>
-          <a:chExt cx="0" cy="0"/>
-        </a:xfrm>
-      </p:grpSpPr>
-      <p:sp>
-        <p:nvSpPr>
-          <p:cNvPr id="2" name="Title 1">
-            <a:extLst>
-              <a:ext uri="{FF2B5EF4-FFF2-40B4-BE49-F238E27FC236}">
-                <a16:creationId xmlns:a16="http://schemas.microsoft.com/office/drawing/2014/main" id="{A2946D8E-31E3-BCF6-1B70-0C34F68C8399}"/>
-              </a:ext>
-            </a:extLst>
-          </p:cNvPr>
-          <p:cNvSpPr>
-            <a:spLocks noGrp="1"/>
-          </p:cNvSpPr>
-          <p:nvPr>
-            <p:ph type="title"/>
-          </p:nvPr>
-        </p:nvSpPr>
-        <p:spPr/>
-        <p:txBody>
-          <a:bodyPr>
-            <a:normAutofit fontScale="90000"/>
-          </a:bodyPr>
-          <a:lstStyle/>
-          <a:p>
-            <a:r>
-              <a:rPr lang="en-US" dirty="0"/>
-              <a:t>A historian would like to investigate the claim that the heights of players have increased over the years.  Analyze this claim graphically / visually.</a:t>
-            </a:r>
-          </a:p>
-        </p:txBody>
-      </p:sp>
-    </p:spTree>
-    <p:extLst>
-      <p:ext uri="{BB962C8B-B14F-4D97-AF65-F5344CB8AC3E}">
-        <p14:creationId xmlns:p14="http://schemas.microsoft.com/office/powerpoint/2010/main" val="3384548216"/>
-      </p:ext>
-    </p:extLst>
-  </p:cSld>
-  <p:clrMapOvr>
-    <a:masterClrMapping/>
-  </p:clrMapOvr>
-</p:sld>
-</file>
-
-<file path=ppt/slides/slide18.xml><?xml version="1.0" encoding="utf-8"?>
-<p:sld xmlns:a="http://schemas.openxmlformats.org/drawingml/2006/main" xmlns:r="http://schemas.openxmlformats.org/officeDocument/2006/relationships" xmlns:p="http://schemas.openxmlformats.org/presentationml/2006/main">
-  <p:cSld>
-    <p:spTree>
-      <p:nvGrpSpPr>
-        <p:cNvPr id="1" name=""/>
-        <p:cNvGrpSpPr/>
-        <p:nvPr/>
-      </p:nvGrpSpPr>
-      <p:grpSpPr>
-        <a:xfrm>
-          <a:off x="0" y="0"/>
-          <a:ext cx="0" cy="0"/>
-          <a:chOff x="0" y="0"/>
-          <a:chExt cx="0" cy="0"/>
-        </a:xfrm>
-      </p:grpSpPr>
-      <p:pic>
-        <p:nvPicPr>
-          <p:cNvPr id="4" name="Picture 3">
-            <a:extLst>
-              <a:ext uri="{FF2B5EF4-FFF2-40B4-BE49-F238E27FC236}">
-                <a16:creationId xmlns:a16="http://schemas.microsoft.com/office/drawing/2014/main" id="{585752C8-EEF0-5F45-E86A-65914070EB2B}"/>
-              </a:ext>
-            </a:extLst>
-          </p:cNvPr>
-          <p:cNvPicPr>
-            <a:picLocks noChangeAspect="1"/>
-          </p:cNvPicPr>
-          <p:nvPr/>
-        </p:nvPicPr>
-        <p:blipFill>
-          <a:blip r:embed="rId2"/>
-          <a:stretch>
-            <a:fillRect/>
-          </a:stretch>
-        </p:blipFill>
-        <p:spPr>
-          <a:xfrm>
-            <a:off x="65833" y="671127"/>
-            <a:ext cx="6030167" cy="5515745"/>
-          </a:xfrm>
-          <a:prstGeom prst="rect">
-            <a:avLst/>
-          </a:prstGeom>
-        </p:spPr>
-      </p:pic>
-      <p:pic>
-        <p:nvPicPr>
-          <p:cNvPr id="6" name="Picture 5">
-            <a:extLst>
-              <a:ext uri="{FF2B5EF4-FFF2-40B4-BE49-F238E27FC236}">
-                <a16:creationId xmlns:a16="http://schemas.microsoft.com/office/drawing/2014/main" id="{F872338E-F87E-58E0-D189-66E020E29AF1}"/>
-              </a:ext>
-            </a:extLst>
-          </p:cNvPr>
-          <p:cNvPicPr>
-            <a:picLocks noChangeAspect="1"/>
-          </p:cNvPicPr>
-          <p:nvPr/>
-        </p:nvPicPr>
-        <p:blipFill>
-          <a:blip r:embed="rId3"/>
-          <a:stretch>
-            <a:fillRect/>
-          </a:stretch>
-        </p:blipFill>
-        <p:spPr>
-          <a:xfrm>
-            <a:off x="6096000" y="1443161"/>
-            <a:ext cx="6030167" cy="3971676"/>
-          </a:xfrm>
-          <a:prstGeom prst="rect">
-            <a:avLst/>
-          </a:prstGeom>
-        </p:spPr>
-      </p:pic>
-      <p:sp>
-        <p:nvSpPr>
-          <p:cNvPr id="7" name="TextBox 6">
-            <a:extLst>
-              <a:ext uri="{FF2B5EF4-FFF2-40B4-BE49-F238E27FC236}">
-                <a16:creationId xmlns:a16="http://schemas.microsoft.com/office/drawing/2014/main" id="{6C4B2D1C-7778-53B8-10C4-4111AD14DC9E}"/>
-              </a:ext>
-            </a:extLst>
-          </p:cNvPr>
-          <p:cNvSpPr txBox="1"/>
-          <p:nvPr/>
-        </p:nvSpPr>
-        <p:spPr>
-          <a:xfrm>
-            <a:off x="6271846" y="5477689"/>
-            <a:ext cx="5627077" cy="646331"/>
-          </a:xfrm>
-          <a:prstGeom prst="rect">
-            <a:avLst/>
-          </a:prstGeom>
-          <a:noFill/>
-        </p:spPr>
-        <p:txBody>
-          <a:bodyPr wrap="square" rtlCol="0">
-            <a:spAutoFit/>
-          </a:bodyPr>
-          <a:lstStyle/>
-          <a:p>
-            <a:r>
-              <a:rPr lang="en-US" dirty="0"/>
-              <a:t>It looks like the height increase started to level out. What’s up with that?</a:t>
-            </a:r>
-          </a:p>
-        </p:txBody>
-      </p:sp>
-    </p:spTree>
-    <p:extLst>
-      <p:ext uri="{BB962C8B-B14F-4D97-AF65-F5344CB8AC3E}">
-        <p14:creationId xmlns:p14="http://schemas.microsoft.com/office/powerpoint/2010/main" val="434424728"/>
-      </p:ext>
-    </p:extLst>
-  </p:cSld>
-  <p:clrMapOvr>
-    <a:masterClrMapping/>
-  </p:clrMapOvr>
-</p:sld>
-</file>
-
-<file path=ppt/slides/slide19.xml><?xml version="1.0" encoding="utf-8"?>
-<p:sld xmlns:a="http://schemas.openxmlformats.org/drawingml/2006/main" xmlns:r="http://schemas.openxmlformats.org/officeDocument/2006/relationships" xmlns:p="http://schemas.openxmlformats.org/presentationml/2006/main">
-  <p:cSld>
-    <p:spTree>
-      <p:nvGrpSpPr>
-        <p:cNvPr id="1" name=""/>
-        <p:cNvGrpSpPr/>
-        <p:nvPr/>
-      </p:nvGrpSpPr>
-      <p:grpSpPr>
-        <a:xfrm>
-          <a:off x="0" y="0"/>
-          <a:ext cx="0" cy="0"/>
-          <a:chOff x="0" y="0"/>
-          <a:chExt cx="0" cy="0"/>
-        </a:xfrm>
-      </p:grpSpPr>
-      <p:sp>
-        <p:nvSpPr>
-          <p:cNvPr id="2" name="Title 1">
-            <a:extLst>
-              <a:ext uri="{FF2B5EF4-FFF2-40B4-BE49-F238E27FC236}">
-                <a16:creationId xmlns:a16="http://schemas.microsoft.com/office/drawing/2014/main" id="{67E89843-7680-DC6B-7247-610B38EC2999}"/>
-              </a:ext>
-            </a:extLst>
-          </p:cNvPr>
-          <p:cNvSpPr>
-            <a:spLocks noGrp="1"/>
-          </p:cNvSpPr>
-          <p:nvPr>
-            <p:ph type="title"/>
-          </p:nvPr>
-        </p:nvSpPr>
-        <p:spPr/>
-        <p:txBody>
-          <a:bodyPr>
-            <a:normAutofit/>
-          </a:bodyPr>
-          <a:lstStyle/>
-          <a:p>
-            <a:r>
-              <a:rPr lang="en-US" dirty="0"/>
-              <a:t>Create a 3D plot of height vs. weight vs. year and color code the points by position.</a:t>
-            </a:r>
-          </a:p>
-        </p:txBody>
-      </p:sp>
-    </p:spTree>
-    <p:extLst>
-      <p:ext uri="{BB962C8B-B14F-4D97-AF65-F5344CB8AC3E}">
-        <p14:creationId xmlns:p14="http://schemas.microsoft.com/office/powerpoint/2010/main" val="4032645203"/>
-      </p:ext>
-    </p:extLst>
-  </p:cSld>
-  <p:clrMapOvr>
-    <a:masterClrMapping/>
-  </p:clrMapOvr>
-</p:sld>
-</file>
-
-<file path=ppt/slides/slide2.xml><?xml version="1.0" encoding="utf-8"?>
-<p:sld xmlns:a="http://schemas.openxmlformats.org/drawingml/2006/main" xmlns:r="http://schemas.openxmlformats.org/officeDocument/2006/relationships" xmlns:p="http://schemas.openxmlformats.org/presentationml/2006/main">
-  <p:cSld>
-    <p:spTree>
-      <p:nvGrpSpPr>
-        <p:cNvPr id="1" name=""/>
-        <p:cNvGrpSpPr/>
-        <p:nvPr/>
-      </p:nvGrpSpPr>
-      <p:grpSpPr>
-        <a:xfrm>
-          <a:off x="0" y="0"/>
-          <a:ext cx="0" cy="0"/>
-          <a:chOff x="0" y="0"/>
-          <a:chExt cx="0" cy="0"/>
-        </a:xfrm>
-      </p:grpSpPr>
-      <p:sp>
-        <p:nvSpPr>
-          <p:cNvPr id="2" name="Title 1">
-            <a:extLst>
-              <a:ext uri="{FF2B5EF4-FFF2-40B4-BE49-F238E27FC236}">
-                <a16:creationId xmlns:a16="http://schemas.microsoft.com/office/drawing/2014/main" id="{143D11A9-1399-3756-F85B-4265A176EF67}"/>
-              </a:ext>
-            </a:extLst>
-          </p:cNvPr>
-          <p:cNvSpPr>
-            <a:spLocks noGrp="1"/>
-          </p:cNvSpPr>
-          <p:nvPr>
-            <p:ph type="title"/>
-          </p:nvPr>
-        </p:nvSpPr>
-        <p:spPr/>
-        <p:txBody>
-          <a:bodyPr>
-            <a:noAutofit/>
-          </a:bodyPr>
-          <a:lstStyle/>
-          <a:p>
-            <a:r>
-              <a:rPr lang="en-US" sz="2800" dirty="0"/>
-              <a:t>Download into R Studio the PlayerBBall.csv dataset. This data set is every NBA basketball player from 1950 to present.  It contains their height, weight, position and the year they played (among other data.) (Position: F-Forward, C-Centers, F-C and C-F – Forward /Centers, G – Guards, F-G – Forward/Guards)  FYI: If you feel that these questions are open ended or at least a little vague, this is on purpose.  Answer the question as you understand it and make any assumptions you need to make to answer the question and record those assumptions. (3-5 hours)</a:t>
-            </a:r>
-          </a:p>
-        </p:txBody>
-      </p:sp>
-    </p:spTree>
-    <p:extLst>
-      <p:ext uri="{BB962C8B-B14F-4D97-AF65-F5344CB8AC3E}">
-        <p14:creationId xmlns:p14="http://schemas.microsoft.com/office/powerpoint/2010/main" val="2880927962"/>
-      </p:ext>
-    </p:extLst>
-  </p:cSld>
-  <p:clrMapOvr>
-    <a:masterClrMapping/>
-  </p:clrMapOvr>
-</p:sld>
-</file>
-
-<file path=ppt/slides/slide20.xml><?xml version="1.0" encoding="utf-8"?>
-<p:sld xmlns:a="http://schemas.openxmlformats.org/drawingml/2006/main" xmlns:r="http://schemas.openxmlformats.org/officeDocument/2006/relationships" xmlns:p="http://schemas.openxmlformats.org/presentationml/2006/main">
-  <p:cSld>
-    <p:spTree>
-      <p:nvGrpSpPr>
-        <p:cNvPr id="1" name=""/>
-        <p:cNvGrpSpPr/>
-        <p:nvPr/>
-      </p:nvGrpSpPr>
-      <p:grpSpPr>
-        <a:xfrm>
-          <a:off x="0" y="0"/>
-          <a:ext cx="0" cy="0"/>
-          <a:chOff x="0" y="0"/>
-          <a:chExt cx="0" cy="0"/>
-        </a:xfrm>
-      </p:grpSpPr>
-      <p:pic>
-        <p:nvPicPr>
-          <p:cNvPr id="4" name="Picture 3">
-            <a:extLst>
-              <a:ext uri="{FF2B5EF4-FFF2-40B4-BE49-F238E27FC236}">
-                <a16:creationId xmlns:a16="http://schemas.microsoft.com/office/drawing/2014/main" id="{B9640FDB-3636-7A9B-FE57-91417F2B6E0E}"/>
-              </a:ext>
-            </a:extLst>
-          </p:cNvPr>
-          <p:cNvPicPr>
-            <a:picLocks noChangeAspect="1"/>
-          </p:cNvPicPr>
-          <p:nvPr/>
-        </p:nvPicPr>
-        <p:blipFill>
-          <a:blip r:embed="rId2"/>
-          <a:stretch>
-            <a:fillRect/>
-          </a:stretch>
-        </p:blipFill>
-        <p:spPr>
-          <a:xfrm>
-            <a:off x="2647468" y="61442"/>
-            <a:ext cx="6897063" cy="6735115"/>
-          </a:xfrm>
-          <a:prstGeom prst="rect">
-            <a:avLst/>
-          </a:prstGeom>
-        </p:spPr>
-      </p:pic>
-    </p:spTree>
-    <p:extLst>
-      <p:ext uri="{BB962C8B-B14F-4D97-AF65-F5344CB8AC3E}">
-        <p14:creationId xmlns:p14="http://schemas.microsoft.com/office/powerpoint/2010/main" val="723924871"/>
-      </p:ext>
-    </p:extLst>
-  </p:cSld>
-  <p:clrMapOvr>
-    <a:masterClrMapping/>
-  </p:clrMapOvr>
-</p:sld>
-</file>
-
-<file path=ppt/slides/slide21.xml><?xml version="1.0" encoding="utf-8"?>
-<p:sld xmlns:a="http://schemas.openxmlformats.org/drawingml/2006/main" xmlns:r="http://schemas.openxmlformats.org/officeDocument/2006/relationships" xmlns:p="http://schemas.openxmlformats.org/presentationml/2006/main">
-  <p:cSld>
-    <p:spTree>
-      <p:nvGrpSpPr>
-        <p:cNvPr id="1" name=""/>
-        <p:cNvGrpSpPr/>
-        <p:nvPr/>
-      </p:nvGrpSpPr>
-      <p:grpSpPr>
-        <a:xfrm>
-          <a:off x="0" y="0"/>
-          <a:ext cx="0" cy="0"/>
-          <a:chOff x="0" y="0"/>
-          <a:chExt cx="0" cy="0"/>
-        </a:xfrm>
-      </p:grpSpPr>
-      <p:sp>
-        <p:nvSpPr>
-          <p:cNvPr id="2" name="Title 1">
-            <a:extLst>
-              <a:ext uri="{FF2B5EF4-FFF2-40B4-BE49-F238E27FC236}">
-                <a16:creationId xmlns:a16="http://schemas.microsoft.com/office/drawing/2014/main" id="{0C0CB0A4-8A98-4814-D6EF-7D08435168E4}"/>
-              </a:ext>
-            </a:extLst>
-          </p:cNvPr>
-          <p:cNvSpPr>
-            <a:spLocks noGrp="1"/>
-          </p:cNvSpPr>
-          <p:nvPr>
-            <p:ph type="title"/>
-          </p:nvPr>
-        </p:nvSpPr>
-        <p:spPr/>
-        <p:txBody>
-          <a:bodyPr>
-            <a:noAutofit/>
-          </a:bodyPr>
-          <a:lstStyle/>
-          <a:p>
-            <a:r>
-              <a:rPr lang="en-US" sz="4800" dirty="0"/>
-              <a:t>Go to this website and use one of the 50 best plots to visualize some aspect of the data and provide at least one insight.  You will present your work in breakout! </a:t>
-            </a:r>
-            <a:r>
-              <a:rPr lang="en-US" sz="4800" dirty="0">
-                <a:hlinkClick r:id="rId2"/>
-              </a:rPr>
-              <a:t>http://r-statistics.co/Top50-Ggplot2-Visualizations-MasterList-R-Code.html</a:t>
-            </a:r>
-            <a:endParaRPr lang="en-US" sz="4800" dirty="0"/>
-          </a:p>
-        </p:txBody>
-      </p:sp>
-    </p:spTree>
-    <p:extLst>
-      <p:ext uri="{BB962C8B-B14F-4D97-AF65-F5344CB8AC3E}">
-        <p14:creationId xmlns:p14="http://schemas.microsoft.com/office/powerpoint/2010/main" val="1384826650"/>
-      </p:ext>
-    </p:extLst>
-  </p:cSld>
-  <p:clrMapOvr>
-    <a:masterClrMapping/>
-  </p:clrMapOvr>
-</p:sld>
-</file>
-
-<file path=ppt/slides/slide22.xml><?xml version="1.0" encoding="utf-8"?>
-<p:sld xmlns:a="http://schemas.openxmlformats.org/drawingml/2006/main" xmlns:r="http://schemas.openxmlformats.org/officeDocument/2006/relationships" xmlns:p="http://schemas.openxmlformats.org/presentationml/2006/main">
-  <p:cSld>
-    <p:spTree>
-      <p:nvGrpSpPr>
-        <p:cNvPr id="1" name=""/>
-        <p:cNvGrpSpPr/>
-        <p:nvPr/>
-      </p:nvGrpSpPr>
-      <p:grpSpPr>
-        <a:xfrm>
-          <a:off x="0" y="0"/>
-          <a:ext cx="0" cy="0"/>
-          <a:chOff x="0" y="0"/>
-          <a:chExt cx="0" cy="0"/>
-        </a:xfrm>
-      </p:grpSpPr>
-      <p:pic>
-        <p:nvPicPr>
-          <p:cNvPr id="4" name="Picture 3">
-            <a:extLst>
-              <a:ext uri="{FF2B5EF4-FFF2-40B4-BE49-F238E27FC236}">
-                <a16:creationId xmlns:a16="http://schemas.microsoft.com/office/drawing/2014/main" id="{022B32D3-FAD5-4A4E-AA93-85E64BEC9447}"/>
-              </a:ext>
-            </a:extLst>
-          </p:cNvPr>
-          <p:cNvPicPr>
-            <a:picLocks noChangeAspect="1"/>
-          </p:cNvPicPr>
-          <p:nvPr/>
-        </p:nvPicPr>
-        <p:blipFill>
-          <a:blip r:embed="rId2"/>
-          <a:stretch>
-            <a:fillRect/>
-          </a:stretch>
-        </p:blipFill>
-        <p:spPr>
-          <a:xfrm>
-            <a:off x="0" y="895520"/>
-            <a:ext cx="6552696" cy="5066960"/>
-          </a:xfrm>
-          <a:prstGeom prst="rect">
-            <a:avLst/>
-          </a:prstGeom>
-        </p:spPr>
-      </p:pic>
-      <p:sp>
-        <p:nvSpPr>
-          <p:cNvPr id="5" name="TextBox 4">
-            <a:extLst>
-              <a:ext uri="{FF2B5EF4-FFF2-40B4-BE49-F238E27FC236}">
-                <a16:creationId xmlns:a16="http://schemas.microsoft.com/office/drawing/2014/main" id="{BECE5536-C37B-89D9-638A-5BFFBDC3B75B}"/>
-              </a:ext>
-            </a:extLst>
-          </p:cNvPr>
-          <p:cNvSpPr txBox="1"/>
-          <p:nvPr/>
-        </p:nvSpPr>
-        <p:spPr>
-          <a:xfrm>
-            <a:off x="7303476" y="1822377"/>
-            <a:ext cx="4489939" cy="3416320"/>
-          </a:xfrm>
-          <a:prstGeom prst="rect">
-            <a:avLst/>
-          </a:prstGeom>
-          <a:noFill/>
-        </p:spPr>
-        <p:txBody>
-          <a:bodyPr wrap="square" rtlCol="0">
-            <a:spAutoFit/>
-          </a:bodyPr>
-          <a:lstStyle/>
-          <a:p>
-            <a:pPr marL="285750" indent="-285750">
-              <a:buFont typeface="Arial" panose="020B0604020202020204" pitchFamily="34" charset="0"/>
-              <a:buChar char="•"/>
-            </a:pPr>
-            <a:r>
-              <a:rPr lang="en-US" sz="2000" dirty="0"/>
-              <a:t>Classic visualization</a:t>
-            </a:r>
-          </a:p>
-          <a:p>
-            <a:pPr marL="285750" indent="-285750">
-              <a:buFont typeface="Arial" panose="020B0604020202020204" pitchFamily="34" charset="0"/>
-              <a:buChar char="•"/>
-            </a:pPr>
-            <a:r>
-              <a:rPr lang="en-US" sz="2000" dirty="0"/>
-              <a:t>Can be hard to read</a:t>
-            </a:r>
-          </a:p>
-          <a:p>
-            <a:pPr marL="285750" indent="-285750">
-              <a:buFont typeface="Arial" panose="020B0604020202020204" pitchFamily="34" charset="0"/>
-              <a:buChar char="•"/>
-            </a:pPr>
-            <a:r>
-              <a:rPr lang="en-US" sz="2000" dirty="0"/>
-              <a:t>Do not use with many categories</a:t>
-            </a:r>
-          </a:p>
-          <a:p>
-            <a:pPr marL="285750" indent="-285750">
-              <a:buFont typeface="Arial" panose="020B0604020202020204" pitchFamily="34" charset="0"/>
-              <a:buChar char="•"/>
-            </a:pPr>
-            <a:r>
-              <a:rPr lang="en-US" sz="2000" dirty="0"/>
-              <a:t>Color contrast should be immediately clear</a:t>
-            </a:r>
-            <a:endParaRPr lang="en-US" sz="2000" i="1" dirty="0"/>
-          </a:p>
-          <a:p>
-            <a:endParaRPr lang="en-US" i="1" dirty="0"/>
-          </a:p>
-          <a:p>
-            <a:r>
-              <a:rPr lang="en-US" sz="1400" i="1" dirty="0"/>
-              <a:t>The pie chart is classic, but some people find it hard to read because it requires you to distinguish between different hues, which can be difficult. </a:t>
-            </a:r>
-          </a:p>
-          <a:p>
-            <a:endParaRPr lang="en-US" sz="1400" i="1" dirty="0"/>
-          </a:p>
-          <a:p>
-            <a:r>
-              <a:rPr lang="en-US" sz="1400" i="1" dirty="0"/>
-              <a:t>Therefore, it works better when the colors contrast more, but if there are many different categories it becomes harder to select sufficiently contrasting colors.</a:t>
-            </a:r>
-          </a:p>
-        </p:txBody>
-      </p:sp>
-    </p:spTree>
-    <p:extLst>
-      <p:ext uri="{BB962C8B-B14F-4D97-AF65-F5344CB8AC3E}">
-        <p14:creationId xmlns:p14="http://schemas.microsoft.com/office/powerpoint/2010/main" val="1831087003"/>
-      </p:ext>
-    </p:extLst>
-  </p:cSld>
-  <p:clrMapOvr>
-    <a:masterClrMapping/>
-  </p:clrMapOvr>
-</p:sld>
-</file>
-
-<file path=ppt/slides/slide23.xml><?xml version="1.0" encoding="utf-8"?>
-<p:sld xmlns:a="http://schemas.openxmlformats.org/drawingml/2006/main" xmlns:r="http://schemas.openxmlformats.org/officeDocument/2006/relationships" xmlns:p="http://schemas.openxmlformats.org/presentationml/2006/main">
-  <p:cSld>
-    <p:spTree>
-      <p:nvGrpSpPr>
-        <p:cNvPr id="1" name=""/>
-        <p:cNvGrpSpPr/>
-        <p:nvPr/>
-      </p:nvGrpSpPr>
-      <p:grpSpPr>
-        <a:xfrm>
-          <a:off x="0" y="0"/>
-          <a:ext cx="0" cy="0"/>
-          <a:chOff x="0" y="0"/>
-          <a:chExt cx="0" cy="0"/>
-        </a:xfrm>
-      </p:grpSpPr>
-      <p:sp>
-        <p:nvSpPr>
-          <p:cNvPr id="2" name="Title 1">
-            <a:extLst>
-              <a:ext uri="{FF2B5EF4-FFF2-40B4-BE49-F238E27FC236}">
-                <a16:creationId xmlns:a16="http://schemas.microsoft.com/office/drawing/2014/main" id="{C12FA1FA-C722-263F-B54D-B11CDEC64D53}"/>
-              </a:ext>
-            </a:extLst>
-          </p:cNvPr>
-          <p:cNvSpPr>
-            <a:spLocks noGrp="1"/>
-          </p:cNvSpPr>
-          <p:nvPr>
-            <p:ph type="title"/>
-          </p:nvPr>
-        </p:nvSpPr>
-        <p:spPr/>
-        <p:txBody>
-          <a:bodyPr/>
-          <a:lstStyle/>
-          <a:p>
-            <a:r>
-              <a:rPr lang="en-US" dirty="0"/>
-              <a:t>Takeaways and Questions</a:t>
-            </a:r>
-          </a:p>
-        </p:txBody>
-      </p:sp>
-    </p:spTree>
-    <p:extLst>
-      <p:ext uri="{BB962C8B-B14F-4D97-AF65-F5344CB8AC3E}">
-        <p14:creationId xmlns:p14="http://schemas.microsoft.com/office/powerpoint/2010/main" val="1824888273"/>
-      </p:ext>
-    </p:extLst>
-  </p:cSld>
-  <p:clrMapOvr>
-    <a:masterClrMapping/>
-  </p:clrMapOvr>
-</p:sld>
-</file>
-
-<file path=ppt/slides/slide3.xml><?xml version="1.0" encoding="utf-8"?>
-<p:sld xmlns:a="http://schemas.openxmlformats.org/drawingml/2006/main" xmlns:r="http://schemas.openxmlformats.org/officeDocument/2006/relationships" xmlns:p="http://schemas.openxmlformats.org/presentationml/2006/main">
-  <p:cSld>
-    <p:spTree>
-      <p:nvGrpSpPr>
-        <p:cNvPr id="1" name=""/>
-        <p:cNvGrpSpPr/>
-        <p:nvPr/>
-      </p:nvGrpSpPr>
-      <p:grpSpPr>
-        <a:xfrm>
-          <a:off x="0" y="0"/>
-          <a:ext cx="0" cy="0"/>
-          <a:chOff x="0" y="0"/>
-          <a:chExt cx="0" cy="0"/>
-        </a:xfrm>
-      </p:grpSpPr>
-      <p:sp>
-        <p:nvSpPr>
-          <p:cNvPr id="4" name="Title 3">
-            <a:extLst>
-              <a:ext uri="{FF2B5EF4-FFF2-40B4-BE49-F238E27FC236}">
-                <a16:creationId xmlns:a16="http://schemas.microsoft.com/office/drawing/2014/main" id="{8ED1C4CC-A40E-4C8C-A657-7BFC8652B0FD}"/>
-              </a:ext>
-            </a:extLst>
-          </p:cNvPr>
-          <p:cNvSpPr>
-            <a:spLocks noGrp="1"/>
-          </p:cNvSpPr>
-          <p:nvPr>
-            <p:ph type="title"/>
-          </p:nvPr>
-        </p:nvSpPr>
-        <p:spPr/>
-        <p:txBody>
-          <a:bodyPr>
-            <a:normAutofit fontScale="90000"/>
-          </a:bodyPr>
-          <a:lstStyle/>
-          <a:p>
-            <a:r>
-              <a:rPr lang="en-US" dirty="0"/>
-              <a:t>Use the PlayerBBall.csv dataset to visually represent (summarize) the number of players in each position.</a:t>
-            </a:r>
-          </a:p>
-        </p:txBody>
-      </p:sp>
-    </p:spTree>
-    <p:extLst>
-      <p:ext uri="{BB962C8B-B14F-4D97-AF65-F5344CB8AC3E}">
-        <p14:creationId xmlns:p14="http://schemas.microsoft.com/office/powerpoint/2010/main" val="1613393479"/>
-      </p:ext>
-    </p:extLst>
-  </p:cSld>
-  <p:clrMapOvr>
-    <a:masterClrMapping/>
-  </p:clrMapOvr>
-</p:sld>
-</file>
-
-<file path=ppt/slides/slide4.xml><?xml version="1.0" encoding="utf-8"?>
-<p:sld xmlns:a="http://schemas.openxmlformats.org/drawingml/2006/main" xmlns:r="http://schemas.openxmlformats.org/officeDocument/2006/relationships" xmlns:p="http://schemas.openxmlformats.org/presentationml/2006/main">
-  <p:cSld>
-    <p:spTree>
-      <p:nvGrpSpPr>
-        <p:cNvPr id="1" name=""/>
-        <p:cNvGrpSpPr/>
-        <p:nvPr/>
-      </p:nvGrpSpPr>
-      <p:grpSpPr>
-        <a:xfrm>
-          <a:off x="0" y="0"/>
-          <a:ext cx="0" cy="0"/>
-          <a:chOff x="0" y="0"/>
-          <a:chExt cx="0" cy="0"/>
-        </a:xfrm>
-      </p:grpSpPr>
-      <p:pic>
-        <p:nvPicPr>
-          <p:cNvPr id="6" name="Picture 5">
-            <a:extLst>
-              <a:ext uri="{FF2B5EF4-FFF2-40B4-BE49-F238E27FC236}">
-                <a16:creationId xmlns:a16="http://schemas.microsoft.com/office/drawing/2014/main" id="{5B2948BF-89DA-B54C-42BE-AFAD6D83647F}"/>
-              </a:ext>
-            </a:extLst>
-          </p:cNvPr>
-          <p:cNvPicPr>
-            <a:picLocks noChangeAspect="1"/>
-          </p:cNvPicPr>
-          <p:nvPr/>
-        </p:nvPicPr>
-        <p:blipFill>
-          <a:blip r:embed="rId2"/>
-          <a:srcRect b="86468"/>
-          <a:stretch>
-            <a:fillRect/>
-          </a:stretch>
-        </p:blipFill>
-        <p:spPr>
-          <a:xfrm>
-            <a:off x="2352543" y="728286"/>
-            <a:ext cx="7135221" cy="730940"/>
-          </a:xfrm>
-          <a:prstGeom prst="rect">
-            <a:avLst/>
-          </a:prstGeom>
-        </p:spPr>
-      </p:pic>
-      <p:pic>
-        <p:nvPicPr>
-          <p:cNvPr id="8" name="Picture 7">
-            <a:extLst>
-              <a:ext uri="{FF2B5EF4-FFF2-40B4-BE49-F238E27FC236}">
-                <a16:creationId xmlns:a16="http://schemas.microsoft.com/office/drawing/2014/main" id="{2E317755-CBD8-2304-95B0-661EA3D1E1D7}"/>
-              </a:ext>
-            </a:extLst>
-          </p:cNvPr>
-          <p:cNvPicPr>
-            <a:picLocks noChangeAspect="1"/>
-          </p:cNvPicPr>
-          <p:nvPr/>
-        </p:nvPicPr>
-        <p:blipFill>
-          <a:blip r:embed="rId3"/>
-          <a:stretch>
-            <a:fillRect/>
-          </a:stretch>
-        </p:blipFill>
-        <p:spPr>
-          <a:xfrm>
-            <a:off x="2514490" y="1611625"/>
-            <a:ext cx="6811326" cy="4267796"/>
-          </a:xfrm>
-          <a:prstGeom prst="rect">
-            <a:avLst/>
-          </a:prstGeom>
-        </p:spPr>
-      </p:pic>
-    </p:spTree>
-    <p:extLst>
-      <p:ext uri="{BB962C8B-B14F-4D97-AF65-F5344CB8AC3E}">
-        <p14:creationId xmlns:p14="http://schemas.microsoft.com/office/powerpoint/2010/main" val="2965440394"/>
-      </p:ext>
-    </p:extLst>
-  </p:cSld>
-  <p:clrMapOvr>
-    <a:masterClrMapping/>
-  </p:clrMapOvr>
-</p:sld>
-</file>
-
-<file path=ppt/slides/slide5.xml><?xml version="1.0" encoding="utf-8"?>
-<p:sld xmlns:a="http://schemas.openxmlformats.org/drawingml/2006/main" xmlns:r="http://schemas.openxmlformats.org/officeDocument/2006/relationships" xmlns:p="http://schemas.openxmlformats.org/presentationml/2006/main">
-  <p:cSld>
-    <p:spTree>
-      <p:nvGrpSpPr>
-        <p:cNvPr id="1" name=""/>
-        <p:cNvGrpSpPr/>
-        <p:nvPr/>
-      </p:nvGrpSpPr>
-      <p:grpSpPr>
-        <a:xfrm>
-          <a:off x="0" y="0"/>
-          <a:ext cx="0" cy="0"/>
-          <a:chOff x="0" y="0"/>
-          <a:chExt cx="0" cy="0"/>
-        </a:xfrm>
-      </p:grpSpPr>
-      <p:sp>
-        <p:nvSpPr>
-          <p:cNvPr id="2" name="Title 1">
-            <a:extLst>
-              <a:ext uri="{FF2B5EF4-FFF2-40B4-BE49-F238E27FC236}">
-                <a16:creationId xmlns:a16="http://schemas.microsoft.com/office/drawing/2014/main" id="{812AD565-DB8F-CEFE-00FA-6119B24B2654}"/>
-              </a:ext>
-            </a:extLst>
-          </p:cNvPr>
-          <p:cNvSpPr>
-            <a:spLocks noGrp="1"/>
-          </p:cNvSpPr>
-          <p:nvPr>
-            <p:ph type="title"/>
-          </p:nvPr>
-        </p:nvSpPr>
-        <p:spPr/>
-        <p:txBody>
-          <a:bodyPr>
-            <a:normAutofit fontScale="90000"/>
-          </a:bodyPr>
-          <a:lstStyle/>
-          <a:p>
-            <a:r>
-              <a:rPr lang="en-US" dirty="0"/>
-              <a:t>Use the dataset to visually investigate the distribution of the weight of centers (C) is greater than the distribution of the weight of forwards (F).</a:t>
-            </a:r>
-          </a:p>
-        </p:txBody>
-      </p:sp>
-      <p:sp>
-        <p:nvSpPr>
-          <p:cNvPr id="3" name="Text Placeholder 2">
-            <a:extLst>
-              <a:ext uri="{FF2B5EF4-FFF2-40B4-BE49-F238E27FC236}">
-                <a16:creationId xmlns:a16="http://schemas.microsoft.com/office/drawing/2014/main" id="{0C267357-3029-FF93-B96C-D707D4ABD54E}"/>
-              </a:ext>
-            </a:extLst>
-          </p:cNvPr>
-          <p:cNvSpPr>
-            <a:spLocks noGrp="1"/>
-          </p:cNvSpPr>
-          <p:nvPr>
-            <p:ph type="body" idx="1"/>
-          </p:nvPr>
-        </p:nvSpPr>
-        <p:spPr/>
-        <p:txBody>
-          <a:bodyPr/>
-          <a:lstStyle/>
-          <a:p>
-            <a:r>
-              <a:rPr lang="en-US" dirty="0"/>
-              <a:t>Question: How do I filter the data so that only these positions appear on the graph?</a:t>
-            </a:r>
-            <a:br>
-              <a:rPr lang="en-US" dirty="0"/>
-            </a:br>
-            <a:br>
-              <a:rPr lang="en-US" dirty="0"/>
-            </a:br>
-            <a:r>
-              <a:rPr lang="en-US" dirty="0"/>
-              <a:t>The data show the distribution of weight of centers is greater than of forwards.</a:t>
-            </a:r>
-          </a:p>
-        </p:txBody>
-      </p:sp>
-    </p:spTree>
-    <p:extLst>
-      <p:ext uri="{BB962C8B-B14F-4D97-AF65-F5344CB8AC3E}">
-        <p14:creationId xmlns:p14="http://schemas.microsoft.com/office/powerpoint/2010/main" val="511420868"/>
-      </p:ext>
-    </p:extLst>
-  </p:cSld>
-  <p:clrMapOvr>
-    <a:masterClrMapping/>
-  </p:clrMapOvr>
-</p:sld>
-</file>
-
-<file path=ppt/slides/slide6.xml><?xml version="1.0" encoding="utf-8"?>
-<p:sld xmlns:a="http://schemas.openxmlformats.org/drawingml/2006/main" xmlns:r="http://schemas.openxmlformats.org/officeDocument/2006/relationships" xmlns:p="http://schemas.openxmlformats.org/presentationml/2006/main">
-  <p:cSld>
-    <p:spTree>
-      <p:nvGrpSpPr>
-        <p:cNvPr id="1" name="">
-          <a:extLst>
-            <a:ext uri="{FF2B5EF4-FFF2-40B4-BE49-F238E27FC236}">
-              <a16:creationId xmlns:a16="http://schemas.microsoft.com/office/drawing/2014/main" id="{5994AC10-FC2A-88C1-28BE-2B739E11B5D2}"/>
-            </a:ext>
-          </a:extLst>
-        </p:cNvPr>
-        <p:cNvGrpSpPr/>
-        <p:nvPr/>
-      </p:nvGrpSpPr>
-      <p:grpSpPr>
-        <a:xfrm>
-          <a:off x="0" y="0"/>
-          <a:ext cx="0" cy="0"/>
-          <a:chOff x="0" y="0"/>
-          <a:chExt cx="0" cy="0"/>
-        </a:xfrm>
-      </p:grpSpPr>
-      <p:pic>
-        <p:nvPicPr>
-          <p:cNvPr id="8" name="Picture 7">
-            <a:extLst>
-              <a:ext uri="{FF2B5EF4-FFF2-40B4-BE49-F238E27FC236}">
-                <a16:creationId xmlns:a16="http://schemas.microsoft.com/office/drawing/2014/main" id="{8DC66573-A1B9-948E-98EA-F9E622B53D91}"/>
-              </a:ext>
-            </a:extLst>
-          </p:cNvPr>
-          <p:cNvPicPr>
-            <a:picLocks noChangeAspect="1"/>
-          </p:cNvPicPr>
-          <p:nvPr/>
-        </p:nvPicPr>
-        <p:blipFill>
-          <a:blip r:embed="rId2"/>
-          <a:stretch>
-            <a:fillRect/>
-          </a:stretch>
-        </p:blipFill>
-        <p:spPr>
-          <a:xfrm>
-            <a:off x="63741" y="0"/>
-            <a:ext cx="6032259" cy="6858000"/>
-          </a:xfrm>
-          <a:prstGeom prst="rect">
-            <a:avLst/>
-          </a:prstGeom>
-        </p:spPr>
-      </p:pic>
-      <p:pic>
-        <p:nvPicPr>
-          <p:cNvPr id="10" name="Picture 9">
-            <a:extLst>
-              <a:ext uri="{FF2B5EF4-FFF2-40B4-BE49-F238E27FC236}">
-                <a16:creationId xmlns:a16="http://schemas.microsoft.com/office/drawing/2014/main" id="{6F429844-EED3-719D-C522-902066D50717}"/>
-              </a:ext>
-            </a:extLst>
-          </p:cNvPr>
-          <p:cNvPicPr>
-            <a:picLocks noChangeAspect="1"/>
-          </p:cNvPicPr>
-          <p:nvPr/>
-        </p:nvPicPr>
-        <p:blipFill>
-          <a:blip r:embed="rId3"/>
-          <a:stretch>
-            <a:fillRect/>
-          </a:stretch>
-        </p:blipFill>
-        <p:spPr>
-          <a:xfrm>
-            <a:off x="5883373" y="0"/>
-            <a:ext cx="6308627" cy="6858000"/>
-          </a:xfrm>
-          <a:prstGeom prst="rect">
-            <a:avLst/>
-          </a:prstGeom>
-        </p:spPr>
-      </p:pic>
-    </p:spTree>
-    <p:extLst>
-      <p:ext uri="{BB962C8B-B14F-4D97-AF65-F5344CB8AC3E}">
-        <p14:creationId xmlns:p14="http://schemas.microsoft.com/office/powerpoint/2010/main" val="2825713841"/>
-      </p:ext>
-    </p:extLst>
-  </p:cSld>
-  <p:clrMapOvr>
-    <a:masterClrMapping/>
-  </p:clrMapOvr>
-</p:sld>
-</file>
-
-<file path=ppt/slides/slide7.xml><?xml version="1.0" encoding="utf-8"?>
-<p:sld xmlns:a="http://schemas.openxmlformats.org/drawingml/2006/main" xmlns:r="http://schemas.openxmlformats.org/officeDocument/2006/relationships" xmlns:p="http://schemas.openxmlformats.org/presentationml/2006/main">
-  <p:cSld>
-    <p:spTree>
-      <p:nvGrpSpPr>
-        <p:cNvPr id="1" name=""/>
-        <p:cNvGrpSpPr/>
-        <p:nvPr/>
-      </p:nvGrpSpPr>
-      <p:grpSpPr>
-        <a:xfrm>
-          <a:off x="0" y="0"/>
-          <a:ext cx="0" cy="0"/>
-          <a:chOff x="0" y="0"/>
-          <a:chExt cx="0" cy="0"/>
-        </a:xfrm>
-      </p:grpSpPr>
-      <p:sp>
-        <p:nvSpPr>
-          <p:cNvPr id="2" name="Title 1">
-            <a:extLst>
-              <a:ext uri="{FF2B5EF4-FFF2-40B4-BE49-F238E27FC236}">
-                <a16:creationId xmlns:a16="http://schemas.microsoft.com/office/drawing/2014/main" id="{511AAEE6-DF89-149D-EB76-0281C10CE7B6}"/>
-              </a:ext>
-            </a:extLst>
-          </p:cNvPr>
-          <p:cNvSpPr>
-            <a:spLocks noGrp="1"/>
-          </p:cNvSpPr>
-          <p:nvPr>
-            <p:ph type="title"/>
-          </p:nvPr>
-        </p:nvSpPr>
-        <p:spPr/>
-        <p:txBody>
-          <a:bodyPr>
-            <a:normAutofit fontScale="90000"/>
-          </a:bodyPr>
-          <a:lstStyle/>
-          <a:p>
-            <a:r>
-              <a:rPr lang="en-US" dirty="0"/>
-              <a:t>Use the dataset to visually investigate if the distribution of the height of centers (C) is greater than the distribution of the height of forwards (F).</a:t>
-            </a:r>
-          </a:p>
-        </p:txBody>
-      </p:sp>
-      <p:sp>
-        <p:nvSpPr>
-          <p:cNvPr id="3" name="Text Placeholder 2">
-            <a:extLst>
-              <a:ext uri="{FF2B5EF4-FFF2-40B4-BE49-F238E27FC236}">
-                <a16:creationId xmlns:a16="http://schemas.microsoft.com/office/drawing/2014/main" id="{1D003369-28F6-83F1-A8A5-1A9A83DCB0DB}"/>
-              </a:ext>
-            </a:extLst>
-          </p:cNvPr>
-          <p:cNvSpPr>
-            <a:spLocks noGrp="1"/>
-          </p:cNvSpPr>
-          <p:nvPr>
-            <p:ph type="body" idx="1"/>
-          </p:nvPr>
-        </p:nvSpPr>
-        <p:spPr/>
-        <p:txBody>
-          <a:bodyPr/>
-          <a:lstStyle/>
-          <a:p>
-            <a:r>
-              <a:rPr lang="en-US" dirty="0"/>
-              <a:t>Question: How do I convert the height from “6-10” to “6.833”?</a:t>
-            </a:r>
-          </a:p>
-          <a:p>
-            <a:r>
-              <a:rPr lang="en-US" dirty="0"/>
-              <a:t>The data show the distribution of height of centers is greater than of forwards.</a:t>
-            </a:r>
-          </a:p>
-        </p:txBody>
-      </p:sp>
-    </p:spTree>
-    <p:extLst>
-      <p:ext uri="{BB962C8B-B14F-4D97-AF65-F5344CB8AC3E}">
-        <p14:creationId xmlns:p14="http://schemas.microsoft.com/office/powerpoint/2010/main" val="2199071866"/>
-      </p:ext>
-    </p:extLst>
-  </p:cSld>
-  <p:clrMapOvr>
-    <a:masterClrMapping/>
-  </p:clrMapOvr>
-</p:sld>
-</file>
-
-<file path=ppt/slides/slide8.xml><?xml version="1.0" encoding="utf-8"?>
-<p:sld xmlns:a="http://schemas.openxmlformats.org/drawingml/2006/main" xmlns:r="http://schemas.openxmlformats.org/officeDocument/2006/relationships" xmlns:p="http://schemas.openxmlformats.org/presentationml/2006/main">
-  <p:cSld>
-    <p:spTree>
-      <p:nvGrpSpPr>
-        <p:cNvPr id="1" name="">
-          <a:extLst>
-            <a:ext uri="{FF2B5EF4-FFF2-40B4-BE49-F238E27FC236}">
-              <a16:creationId xmlns:a16="http://schemas.microsoft.com/office/drawing/2014/main" id="{F792626B-4EB3-7039-FE06-836B706ADDE3}"/>
-            </a:ext>
-          </a:extLst>
-        </p:cNvPr>
-        <p:cNvGrpSpPr/>
-        <p:nvPr/>
-      </p:nvGrpSpPr>
-      <p:grpSpPr>
-        <a:xfrm>
-          <a:off x="0" y="0"/>
-          <a:ext cx="0" cy="0"/>
-          <a:chOff x="0" y="0"/>
-          <a:chExt cx="0" cy="0"/>
-        </a:xfrm>
-      </p:grpSpPr>
-      <p:pic>
-        <p:nvPicPr>
-          <p:cNvPr id="7" name="Picture 6">
-            <a:extLst>
-              <a:ext uri="{FF2B5EF4-FFF2-40B4-BE49-F238E27FC236}">
-                <a16:creationId xmlns:a16="http://schemas.microsoft.com/office/drawing/2014/main" id="{1668001E-68F5-88A6-68DF-E806D814FCA5}"/>
-              </a:ext>
-            </a:extLst>
-          </p:cNvPr>
-          <p:cNvPicPr>
-            <a:picLocks noChangeAspect="1"/>
-          </p:cNvPicPr>
-          <p:nvPr/>
-        </p:nvPicPr>
-        <p:blipFill>
-          <a:blip r:embed="rId2"/>
-          <a:stretch>
-            <a:fillRect/>
-          </a:stretch>
-        </p:blipFill>
-        <p:spPr>
-          <a:xfrm>
-            <a:off x="1277815" y="1284087"/>
-            <a:ext cx="4818185" cy="5550774"/>
-          </a:xfrm>
-          <a:prstGeom prst="rect">
-            <a:avLst/>
-          </a:prstGeom>
-        </p:spPr>
-      </p:pic>
-      <p:pic>
-        <p:nvPicPr>
-          <p:cNvPr id="9" name="Picture 8">
-            <a:extLst>
-              <a:ext uri="{FF2B5EF4-FFF2-40B4-BE49-F238E27FC236}">
-                <a16:creationId xmlns:a16="http://schemas.microsoft.com/office/drawing/2014/main" id="{60FBAE4C-E8CF-F6D6-562C-ABCEEBB44DAF}"/>
-              </a:ext>
-            </a:extLst>
-          </p:cNvPr>
-          <p:cNvPicPr>
-            <a:picLocks noChangeAspect="1"/>
-          </p:cNvPicPr>
-          <p:nvPr/>
-        </p:nvPicPr>
-        <p:blipFill>
-          <a:blip r:embed="rId3"/>
-          <a:stretch>
-            <a:fillRect/>
-          </a:stretch>
-        </p:blipFill>
-        <p:spPr>
-          <a:xfrm>
-            <a:off x="6095999" y="1307226"/>
-            <a:ext cx="4818185" cy="5504496"/>
-          </a:xfrm>
-          <a:prstGeom prst="rect">
-            <a:avLst/>
-          </a:prstGeom>
-        </p:spPr>
-      </p:pic>
-    </p:spTree>
-    <p:extLst>
-      <p:ext uri="{BB962C8B-B14F-4D97-AF65-F5344CB8AC3E}">
-        <p14:creationId xmlns:p14="http://schemas.microsoft.com/office/powerpoint/2010/main" val="2304346035"/>
+        <p14:creationId xmlns:p14="http://schemas.microsoft.com/office/powerpoint/2010/main" val="1584995416"/>
       </p:ext>
     </p:extLst>
   </p:cSld>
@@ -5137,10 +6029,10 @@
       </p:grpSpPr>
       <p:pic>
         <p:nvPicPr>
-          <p:cNvPr id="3" name="Picture 2">
-            <a:extLst>
-              <a:ext uri="{FF2B5EF4-FFF2-40B4-BE49-F238E27FC236}">
-                <a16:creationId xmlns:a16="http://schemas.microsoft.com/office/drawing/2014/main" id="{7A45123F-4838-4134-E4F2-7885B3621950}"/>
+          <p:cNvPr id="4" name="Picture 3">
+            <a:extLst>
+              <a:ext uri="{FF2B5EF4-FFF2-40B4-BE49-F238E27FC236}">
+                <a16:creationId xmlns:a16="http://schemas.microsoft.com/office/drawing/2014/main" id="{5B7F0E65-FA81-13AC-1881-59C65DF2CACF}"/>
               </a:ext>
             </a:extLst>
           </p:cNvPr>
@@ -5150,15 +6042,15 @@
           <p:nvPr/>
         </p:nvPicPr>
         <p:blipFill>
-          <a:blip r:embed="rId2"/>
+          <a:blip r:embed="rId3"/>
           <a:stretch>
             <a:fillRect/>
           </a:stretch>
         </p:blipFill>
         <p:spPr>
           <a:xfrm>
-            <a:off x="3340369" y="2749237"/>
-            <a:ext cx="5511262" cy="1359526"/>
+            <a:off x="2230244" y="0"/>
+            <a:ext cx="7731512" cy="6858000"/>
           </a:xfrm>
           <a:prstGeom prst="rect">
             <a:avLst/>
@@ -5168,7 +6060,7 @@
     </p:spTree>
     <p:extLst>
       <p:ext uri="{BB962C8B-B14F-4D97-AF65-F5344CB8AC3E}">
-        <p14:creationId xmlns:p14="http://schemas.microsoft.com/office/powerpoint/2010/main" val="873717824"/>
+        <p14:creationId xmlns:p14="http://schemas.microsoft.com/office/powerpoint/2010/main" val="89551103"/>
       </p:ext>
     </p:extLst>
   </p:cSld>
@@ -5491,4 +6383,319 @@
     </a:ext>
   </a:extLst>
 </a:theme>
+</file>
+
+<file path=ppt/theme/theme2.xml><?xml version="1.0" encoding="utf-8"?>
+<a:theme xmlns:a="http://schemas.openxmlformats.org/drawingml/2006/main" name="Office Theme">
+  <a:themeElements>
+    <a:clrScheme name="Office">
+      <a:dk1>
+        <a:sysClr val="windowText" lastClr="000000"/>
+      </a:dk1>
+      <a:lt1>
+        <a:sysClr val="window" lastClr="FFFFFF"/>
+      </a:lt1>
+      <a:dk2>
+        <a:srgbClr val="0E2841"/>
+      </a:dk2>
+      <a:lt2>
+        <a:srgbClr val="E8E8E8"/>
+      </a:lt2>
+      <a:accent1>
+        <a:srgbClr val="156082"/>
+      </a:accent1>
+      <a:accent2>
+        <a:srgbClr val="E97132"/>
+      </a:accent2>
+      <a:accent3>
+        <a:srgbClr val="196B24"/>
+      </a:accent3>
+      <a:accent4>
+        <a:srgbClr val="0F9ED5"/>
+      </a:accent4>
+      <a:accent5>
+        <a:srgbClr val="A02B93"/>
+      </a:accent5>
+      <a:accent6>
+        <a:srgbClr val="4EA72E"/>
+      </a:accent6>
+      <a:hlink>
+        <a:srgbClr val="467886"/>
+      </a:hlink>
+      <a:folHlink>
+        <a:srgbClr val="96607D"/>
+      </a:folHlink>
+    </a:clrScheme>
+    <a:fontScheme name="Office">
+      <a:majorFont>
+        <a:latin typeface="Aptos Display" panose="02110004020202020204"/>
+        <a:ea typeface=""/>
+        <a:cs typeface=""/>
+        <a:font script="Jpan" typeface="游ゴシック Light"/>
+        <a:font script="Hang" typeface="맑은 고딕"/>
+        <a:font script="Hans" typeface="等线 Light"/>
+        <a:font script="Hant" typeface="新細明體"/>
+        <a:font script="Arab" typeface="Times New Roman"/>
+        <a:font script="Hebr" typeface="Times New Roman"/>
+        <a:font script="Thai" typeface="Angsana New"/>
+        <a:font script="Ethi" typeface="Nyala"/>
+        <a:font script="Beng" typeface="Vrinda"/>
+        <a:font script="Gujr" typeface="Shruti"/>
+        <a:font script="Khmr" typeface="MoolBoran"/>
+        <a:font script="Knda" typeface="Tunga"/>
+        <a:font script="Guru" typeface="Raavi"/>
+        <a:font script="Cans" typeface="Euphemia"/>
+        <a:font script="Cher" typeface="Plantagenet Cherokee"/>
+        <a:font script="Yiii" typeface="Microsoft Yi Baiti"/>
+        <a:font script="Tibt" typeface="Microsoft Himalaya"/>
+        <a:font script="Thaa" typeface="MV Boli"/>
+        <a:font script="Deva" typeface="Mangal"/>
+        <a:font script="Telu" typeface="Gautami"/>
+        <a:font script="Taml" typeface="Latha"/>
+        <a:font script="Syrc" typeface="Estrangelo Edessa"/>
+        <a:font script="Orya" typeface="Kalinga"/>
+        <a:font script="Mlym" typeface="Kartika"/>
+        <a:font script="Laoo" typeface="DokChampa"/>
+        <a:font script="Sinh" typeface="Iskoola Pota"/>
+        <a:font script="Mong" typeface="Mongolian Baiti"/>
+        <a:font script="Viet" typeface="Times New Roman"/>
+        <a:font script="Uigh" typeface="Microsoft Uighur"/>
+        <a:font script="Geor" typeface="Sylfaen"/>
+        <a:font script="Armn" typeface="Arial"/>
+        <a:font script="Bugi" typeface="Leelawadee UI"/>
+        <a:font script="Bopo" typeface="Microsoft JhengHei"/>
+        <a:font script="Java" typeface="Javanese Text"/>
+        <a:font script="Lisu" typeface="Segoe UI"/>
+        <a:font script="Mymr" typeface="Myanmar Text"/>
+        <a:font script="Nkoo" typeface="Ebrima"/>
+        <a:font script="Olck" typeface="Nirmala UI"/>
+        <a:font script="Osma" typeface="Ebrima"/>
+        <a:font script="Phag" typeface="Phagspa"/>
+        <a:font script="Syrn" typeface="Estrangelo Edessa"/>
+        <a:font script="Syrj" typeface="Estrangelo Edessa"/>
+        <a:font script="Syre" typeface="Estrangelo Edessa"/>
+        <a:font script="Sora" typeface="Nirmala UI"/>
+        <a:font script="Tale" typeface="Microsoft Tai Le"/>
+        <a:font script="Talu" typeface="Microsoft New Tai Lue"/>
+        <a:font script="Tfng" typeface="Ebrima"/>
+      </a:majorFont>
+      <a:minorFont>
+        <a:latin typeface="Aptos" panose="02110004020202020204"/>
+        <a:ea typeface=""/>
+        <a:cs typeface=""/>
+        <a:font script="Jpan" typeface="游ゴシック"/>
+        <a:font script="Hang" typeface="맑은 고딕"/>
+        <a:font script="Hans" typeface="等线"/>
+        <a:font script="Hant" typeface="新細明體"/>
+        <a:font script="Arab" typeface="Arial"/>
+        <a:font script="Hebr" typeface="Arial"/>
+        <a:font script="Thai" typeface="Cordia New"/>
+        <a:font script="Ethi" typeface="Nyala"/>
+        <a:font script="Beng" typeface="Vrinda"/>
+        <a:font script="Gujr" typeface="Shruti"/>
+        <a:font script="Khmr" typeface="DaunPenh"/>
+        <a:font script="Knda" typeface="Tunga"/>
+        <a:font script="Guru" typeface="Raavi"/>
+        <a:font script="Cans" typeface="Euphemia"/>
+        <a:font script="Cher" typeface="Plantagenet Cherokee"/>
+        <a:font script="Yiii" typeface="Microsoft Yi Baiti"/>
+        <a:font script="Tibt" typeface="Microsoft Himalaya"/>
+        <a:font script="Thaa" typeface="MV Boli"/>
+        <a:font script="Deva" typeface="Mangal"/>
+        <a:font script="Telu" typeface="Gautami"/>
+        <a:font script="Taml" typeface="Latha"/>
+        <a:font script="Syrc" typeface="Estrangelo Edessa"/>
+        <a:font script="Orya" typeface="Kalinga"/>
+        <a:font script="Mlym" typeface="Kartika"/>
+        <a:font script="Laoo" typeface="DokChampa"/>
+        <a:font script="Sinh" typeface="Iskoola Pota"/>
+        <a:font script="Mong" typeface="Mongolian Baiti"/>
+        <a:font script="Viet" typeface="Arial"/>
+        <a:font script="Uigh" typeface="Microsoft Uighur"/>
+        <a:font script="Geor" typeface="Sylfaen"/>
+        <a:font script="Armn" typeface="Arial"/>
+        <a:font script="Bugi" typeface="Leelawadee UI"/>
+        <a:font script="Bopo" typeface="Microsoft JhengHei"/>
+        <a:font script="Java" typeface="Javanese Text"/>
+        <a:font script="Lisu" typeface="Segoe UI"/>
+        <a:font script="Mymr" typeface="Myanmar Text"/>
+        <a:font script="Nkoo" typeface="Ebrima"/>
+        <a:font script="Olck" typeface="Nirmala UI"/>
+        <a:font script="Osma" typeface="Ebrima"/>
+        <a:font script="Phag" typeface="Phagspa"/>
+        <a:font script="Syrn" typeface="Estrangelo Edessa"/>
+        <a:font script="Syrj" typeface="Estrangelo Edessa"/>
+        <a:font script="Syre" typeface="Estrangelo Edessa"/>
+        <a:font script="Sora" typeface="Nirmala UI"/>
+        <a:font script="Tale" typeface="Microsoft Tai Le"/>
+        <a:font script="Talu" typeface="Microsoft New Tai Lue"/>
+        <a:font script="Tfng" typeface="Ebrima"/>
+      </a:minorFont>
+    </a:fontScheme>
+    <a:fmtScheme name="Office">
+      <a:fillStyleLst>
+        <a:solidFill>
+          <a:schemeClr val="phClr"/>
+        </a:solidFill>
+        <a:gradFill rotWithShape="1">
+          <a:gsLst>
+            <a:gs pos="0">
+              <a:schemeClr val="phClr">
+                <a:lumMod val="110000"/>
+                <a:satMod val="105000"/>
+                <a:tint val="67000"/>
+              </a:schemeClr>
+            </a:gs>
+            <a:gs pos="50000">
+              <a:schemeClr val="phClr">
+                <a:lumMod val="105000"/>
+                <a:satMod val="103000"/>
+                <a:tint val="73000"/>
+              </a:schemeClr>
+            </a:gs>
+            <a:gs pos="100000">
+              <a:schemeClr val="phClr">
+                <a:lumMod val="105000"/>
+                <a:satMod val="109000"/>
+                <a:tint val="81000"/>
+              </a:schemeClr>
+            </a:gs>
+          </a:gsLst>
+          <a:lin ang="5400000" scaled="0"/>
+        </a:gradFill>
+        <a:gradFill rotWithShape="1">
+          <a:gsLst>
+            <a:gs pos="0">
+              <a:schemeClr val="phClr">
+                <a:satMod val="103000"/>
+                <a:lumMod val="102000"/>
+                <a:tint val="94000"/>
+              </a:schemeClr>
+            </a:gs>
+            <a:gs pos="50000">
+              <a:schemeClr val="phClr">
+                <a:satMod val="110000"/>
+                <a:lumMod val="100000"/>
+                <a:shade val="100000"/>
+              </a:schemeClr>
+            </a:gs>
+            <a:gs pos="100000">
+              <a:schemeClr val="phClr">
+                <a:lumMod val="99000"/>
+                <a:satMod val="120000"/>
+                <a:shade val="78000"/>
+              </a:schemeClr>
+            </a:gs>
+          </a:gsLst>
+          <a:lin ang="5400000" scaled="0"/>
+        </a:gradFill>
+      </a:fillStyleLst>
+      <a:lnStyleLst>
+        <a:ln w="12700" cap="flat" cmpd="sng" algn="ctr">
+          <a:solidFill>
+            <a:schemeClr val="phClr"/>
+          </a:solidFill>
+          <a:prstDash val="solid"/>
+          <a:miter lim="800000"/>
+        </a:ln>
+        <a:ln w="19050" cap="flat" cmpd="sng" algn="ctr">
+          <a:solidFill>
+            <a:schemeClr val="phClr"/>
+          </a:solidFill>
+          <a:prstDash val="solid"/>
+          <a:miter lim="800000"/>
+        </a:ln>
+        <a:ln w="25400" cap="flat" cmpd="sng" algn="ctr">
+          <a:solidFill>
+            <a:schemeClr val="phClr"/>
+          </a:solidFill>
+          <a:prstDash val="solid"/>
+          <a:miter lim="800000"/>
+        </a:ln>
+      </a:lnStyleLst>
+      <a:effectStyleLst>
+        <a:effectStyle>
+          <a:effectLst/>
+        </a:effectStyle>
+        <a:effectStyle>
+          <a:effectLst/>
+        </a:effectStyle>
+        <a:effectStyle>
+          <a:effectLst>
+            <a:outerShdw blurRad="57150" dist="19050" dir="5400000" algn="ctr" rotWithShape="0">
+              <a:srgbClr val="000000">
+                <a:alpha val="63000"/>
+              </a:srgbClr>
+            </a:outerShdw>
+          </a:effectLst>
+        </a:effectStyle>
+      </a:effectStyleLst>
+      <a:bgFillStyleLst>
+        <a:solidFill>
+          <a:schemeClr val="phClr"/>
+        </a:solidFill>
+        <a:solidFill>
+          <a:schemeClr val="phClr">
+            <a:tint val="95000"/>
+            <a:satMod val="170000"/>
+          </a:schemeClr>
+        </a:solidFill>
+        <a:gradFill rotWithShape="1">
+          <a:gsLst>
+            <a:gs pos="0">
+              <a:schemeClr val="phClr">
+                <a:tint val="93000"/>
+                <a:satMod val="150000"/>
+                <a:shade val="98000"/>
+                <a:lumMod val="102000"/>
+              </a:schemeClr>
+            </a:gs>
+            <a:gs pos="50000">
+              <a:schemeClr val="phClr">
+                <a:tint val="98000"/>
+                <a:satMod val="130000"/>
+                <a:shade val="90000"/>
+                <a:lumMod val="103000"/>
+              </a:schemeClr>
+            </a:gs>
+            <a:gs pos="100000">
+              <a:schemeClr val="phClr">
+                <a:shade val="63000"/>
+                <a:satMod val="120000"/>
+              </a:schemeClr>
+            </a:gs>
+          </a:gsLst>
+          <a:lin ang="5400000" scaled="0"/>
+        </a:gradFill>
+      </a:bgFillStyleLst>
+    </a:fmtScheme>
+  </a:themeElements>
+  <a:objectDefaults>
+    <a:lnDef>
+      <a:spPr/>
+      <a:bodyPr/>
+      <a:lstStyle/>
+      <a:style>
+        <a:lnRef idx="2">
+          <a:schemeClr val="accent1"/>
+        </a:lnRef>
+        <a:fillRef idx="0">
+          <a:schemeClr val="accent1"/>
+        </a:fillRef>
+        <a:effectRef idx="1">
+          <a:schemeClr val="accent1"/>
+        </a:effectRef>
+        <a:fontRef idx="minor">
+          <a:schemeClr val="tx1"/>
+        </a:fontRef>
+      </a:style>
+    </a:lnDef>
+  </a:objectDefaults>
+  <a:extraClrSchemeLst/>
+  <a:extLst>
+    <a:ext uri="{05A4C25C-085E-4340-85A3-A5531E510DB2}">
+      <thm15:themeFamily xmlns:thm15="http://schemas.microsoft.com/office/thememl/2012/main" name="Office Theme" id="{2E142A2C-CD16-42D6-873A-C26D2A0506FA}" vid="{1BDDFF52-6CD6-40A5-AB3C-68EB2F1E4D0A}"/>
+    </a:ext>
+  </a:extLst>
+</a:theme>
 </file>
</xml_diff>